<commit_message>
docs(p5): publish p6 final presentation status
</commit_message>
<xml_diff>
--- a/demo/final/期末汇报_20261030最终版.pptx
+++ b/demo/final/期末汇报_20261030最终版.pptx
@@ -2,22 +2,22 @@
 <file path=ppt/presentation.xml><?xml version="1.0" encoding="utf-8"?>
 <p:presentation xmlns:p="http://schemas.openxmlformats.org/presentationml/2006/main">
   <p:sldMasterIdLst>
-    <p:sldMasterId xmlns:r="http://schemas.openxmlformats.org/officeDocument/2006/relationships" id="2147483648" r:id="Ra631a457b6db43fb"/>
+    <p:sldMasterId xmlns:r="http://schemas.openxmlformats.org/officeDocument/2006/relationships" id="2147483648" r:id="R3b67597d745e454b"/>
   </p:sldMasterIdLst>
   <p:notesMasterIdLst>
-    <p:notesMasterId xmlns:r="http://schemas.openxmlformats.org/officeDocument/2006/relationships" r:id="R727c8fa38bdb406e"/>
+    <p:notesMasterId xmlns:r="http://schemas.openxmlformats.org/officeDocument/2006/relationships" r:id="R5b047af2b6d347e8"/>
   </p:notesMasterIdLst>
   <p:sldIdLst>
-    <p:sldId xmlns:r="http://schemas.openxmlformats.org/officeDocument/2006/relationships" id="256" r:id="R3a26d902b1094b30"/>
-    <p:sldId xmlns:r="http://schemas.openxmlformats.org/officeDocument/2006/relationships" id="257" r:id="R0d07b1d2e2984dbe"/>
-    <p:sldId xmlns:r="http://schemas.openxmlformats.org/officeDocument/2006/relationships" id="258" r:id="R78f6f4358c2d4d9c"/>
-    <p:sldId xmlns:r="http://schemas.openxmlformats.org/officeDocument/2006/relationships" id="259" r:id="R5cc496e96f7b4923"/>
-    <p:sldId xmlns:r="http://schemas.openxmlformats.org/officeDocument/2006/relationships" id="260" r:id="Rca58556330f24be1"/>
-    <p:sldId xmlns:r="http://schemas.openxmlformats.org/officeDocument/2006/relationships" id="261" r:id="R416737165ccb4800"/>
-    <p:sldId xmlns:r="http://schemas.openxmlformats.org/officeDocument/2006/relationships" id="262" r:id="Rcf8cf3533b9a4e7f"/>
-    <p:sldId xmlns:r="http://schemas.openxmlformats.org/officeDocument/2006/relationships" id="263" r:id="R5ec0a3a8a08541a6"/>
-    <p:sldId xmlns:r="http://schemas.openxmlformats.org/officeDocument/2006/relationships" id="264" r:id="R9d343112e7d64880"/>
-    <p:sldId xmlns:r="http://schemas.openxmlformats.org/officeDocument/2006/relationships" id="265" r:id="Rc799ae6e5f28447e"/>
+    <p:sldId xmlns:r="http://schemas.openxmlformats.org/officeDocument/2006/relationships" id="256" r:id="R6b0e308c0fae4828"/>
+    <p:sldId xmlns:r="http://schemas.openxmlformats.org/officeDocument/2006/relationships" id="257" r:id="Rd7d12c8d33b8411a"/>
+    <p:sldId xmlns:r="http://schemas.openxmlformats.org/officeDocument/2006/relationships" id="258" r:id="R1a01b8e1f40e49af"/>
+    <p:sldId xmlns:r="http://schemas.openxmlformats.org/officeDocument/2006/relationships" id="259" r:id="R08729ad4c8df4634"/>
+    <p:sldId xmlns:r="http://schemas.openxmlformats.org/officeDocument/2006/relationships" id="260" r:id="Rc31a3a765e3d4c90"/>
+    <p:sldId xmlns:r="http://schemas.openxmlformats.org/officeDocument/2006/relationships" id="261" r:id="Rdc8cd94608c34848"/>
+    <p:sldId xmlns:r="http://schemas.openxmlformats.org/officeDocument/2006/relationships" id="262" r:id="R4f1aa1840fca48aa"/>
+    <p:sldId xmlns:r="http://schemas.openxmlformats.org/officeDocument/2006/relationships" id="263" r:id="R6ec32f262ac94b87"/>
+    <p:sldId xmlns:r="http://schemas.openxmlformats.org/officeDocument/2006/relationships" id="264" r:id="R47faa14b84de482b"/>
+    <p:sldId xmlns:r="http://schemas.openxmlformats.org/officeDocument/2006/relationships" id="265" r:id="Rd467b29013294cc9"/>
   </p:sldIdLst>
   <p:sldSz cx="12192000" cy="6858000"/>
   <p:notesSz cx="6858000" cy="9144000"/>
@@ -521,7 +521,7 @@
           <a:lstStyle xmlns:a="http://schemas.openxmlformats.org/drawingml/2006/main"/>
           <a:p xmlns:a="http://schemas.openxmlformats.org/drawingml/2006/main">
             <a:r>
-              <a:t>建议约40秒。最后一页把可提交内容和未完成边界分开。系统已经完成真实 Flask URL 到采集、抽取、建图、检索和带出处问答的闭环；冻结包可以复现，在线重跑需要使用者自己的 API 和预算。结论是系统可运行、可追溯、可复现，但图谱收益没有在本次小样本中成立，正确弃答率仍是 N/A。六角色分工见表，姓名、学号和正式互评没有提供，全部保留待本人补充，不虚构。P4 前期独立调研、方案、架构、协作框架、试跑和采集器移植保留原归属。来源：reports/technical_report.md第8–9章；deliveries/P1/2026-10-30/handoff.md；deliveries/P4/2026-10-27/handoff.md；coordination/STATUS_P5.md。</a:t>
+              <a:t>建议约40秒。最后一页把已完成结果和不能外推的边界分开。系统已经完成真实 Flask URL 到采集、抽取、建图、检索和带出处问答的闭环；P6 还完成了 pallets/itsdangerous 的第二小库迁移检查，得到可核对的依赖查询答案。冻结包可以复现，在线重跑需要使用者自己的 API 与预算。结论是系统可运行、可追溯、可复现，但图谱收益没有在本次小样本中显著成立，正确弃答率因合格分母为 0 而保持 N/A，不能解释为核验失败。仍未外推的是一般图收益、任意仓库适用性；当前真实残余包括 Neo4j 在最终审计时未能现场重连、Windows 与 PowerPoint 原生检查未完成。六角色分工见表，姓名、学号和正式互评全部保留待本人补充，不虚构。P4 前期独立调研、方案、架构、协作框架、试跑和采集器移植保留原归属。来源：reports/technical_report.md第8–9章；feat/p6-formal-results 78eaa07 的 final_acceptance.json 与 P6 handoff；deliveries/P1/2026-10-30/handoff.md；deliveries/P4/2026-10-27/handoff.md；coordination/STATUS_P5.md。</a:t>
             </a:r>
           </a:p>
         </p:txBody>
@@ -1081,7 +1081,7 @@
           <a:lstStyle xmlns:a="http://schemas.openxmlformats.org/drawingml/2006/main"/>
           <a:p xmlns:a="http://schemas.openxmlformats.org/drawingml/2006/main">
             <a:r>
-              <a:t>建议约90秒。20 道测试题上，A 组事实覆盖 0.600、证据组召回 0.636、无依据断言率 0.026；B 组分别是 0.740、0.691 和 0.043。B-A 配对事实覆盖差是 0.157，但配对胜负为 B 胜 5、A 胜 4、平 6，固定种子 95% 描述性 bootstrap 区间是 [-0.122,0.457]，跨零。因此不能宣称图扩展有显著收益。正确弃答率必须明确为 N/A：以下是 2026-10-30 的 P6 收尾前快照，全池 92 个位置只有 86 个成功，已确认证据不足为 0，而且没有题目完成两遍完整确认。48 个答案中还有 1 个生产失败，不能删掉。第 9 页下方是唯一 P6 状态区，若 P6 收尾后数字变化，只替换该文本框并保留日期与口径；86/92 不是永久终稿。局限包括单一项目、模型银标、小样本、图扩展增加无依据断言，以及全池和第二小库仍需以 P6 收尾状态为准。来源：evaluation/results/formal_summary.json 的 qa.test 与 whole_pool 字段；deliveries/P6/2026-10-30/experiment_chapter_draft.md。</a:t>
+              <a:t>建议约100秒。20 道测试题上，A 组事实覆盖 0.600、证据组召回 0.636、无依据断言率 0.026；B 组分别是 0.740、0.691 和 0.043。B-A 配对事实覆盖差是 0.157，但配对胜负为 B 胜 5、A 胜 4、平 6，固定种子 95% 描述性 bootstrap 区间是 [-0.122,0.457]，跨零，因此不能宣称图扩展有显著收益。P6 最终公开结果为全池 92/92；6 道候选题均完成两遍完整核验，确认证据不足为 0。正确弃答率仍为 N/A，但原因是分子和合格分母都为 0，表示没有确认不足题，不再表示核验未完成。48 个 A/B 答案仍完整保留为 32 ok、15 empty、1 error，不能把空回答改写成正确弃答。第二小库 pallets/itsdangerous 得到 347 来源、30 完整讨论、82 实体、78 关系和 180 证据；job 仍为 partial 并保留记录缺口，但 validate、graph、retrieval 均 ready。依赖查询返回 50 条路径、25 条证据和 5 条 claims，所有 cited evidence、原文引文和来源哈希复核通过。共享账本保守累计 9.465795 元，剩余 10.374205 元。第 9 页下方 p6-status-update 是唯一 P6 状态区，数据来自公开提交 78eaa07。真实残余仍是单一 Flask、模型银标、小样本、图扩展增加无依据断言、Neo4j 未现场重连、Windows 与 PowerPoint 实机未验证。来源：feat/p6-formal-results 78eaa07 的 evaluation/results/formal_summary.json、final_acceptance.json、second_repo_acceptance.json 和 P6 handoff。</a:t>
             </a:r>
           </a:p>
         </p:txBody>
@@ -1128,7 +1128,7 @@
           <p:cNvPr id="3" name="Title">
             <a:extLst xmlns:a="http://schemas.openxmlformats.org/drawingml/2006/main">
               <a:ext uri="{FF2B5EF4-FFF2-40B4-BE49-F238E27FC236}">
-                <a16:creationId xmlns:a16="http://schemas.microsoft.com/office/drawing/2014/main" id="{C4379305-FEEF-48FF-978B-3BB49044D6E8}"/>
+                <a16:creationId xmlns:a16="http://schemas.microsoft.com/office/drawing/2014/main" id="{C4C428A1-1C7D-4667-98D9-17AC389B4C94}"/>
               </a:ext>
             </a:extLst>
           </p:cNvPr>
@@ -1357,7 +1357,7 @@
           <p:cNvPr id="2" name="Subtitle">
             <a:extLst xmlns:a="http://schemas.openxmlformats.org/drawingml/2006/main">
               <a:ext uri="{FF2B5EF4-FFF2-40B4-BE49-F238E27FC236}">
-                <a16:creationId xmlns:a16="http://schemas.microsoft.com/office/drawing/2014/main" id="{CEFD3499-320A-4D65-90FC-36BCE1531E63}"/>
+                <a16:creationId xmlns:a16="http://schemas.microsoft.com/office/drawing/2014/main" id="{925AB974-4FDD-490F-A7AB-9FA13FCA8B13}"/>
               </a:ext>
             </a:extLst>
           </p:cNvPr>
@@ -1603,7 +1603,7 @@
           <p:cNvPr id="2" name="Section title">
             <a:extLst xmlns:a="http://schemas.openxmlformats.org/drawingml/2006/main">
               <a:ext uri="{FF2B5EF4-FFF2-40B4-BE49-F238E27FC236}">
-                <a16:creationId xmlns:a16="http://schemas.microsoft.com/office/drawing/2014/main" id="{9DE4534C-FDB6-47FA-AECE-814B74BF17C7}"/>
+                <a16:creationId xmlns:a16="http://schemas.microsoft.com/office/drawing/2014/main" id="{08A04146-8E30-4AD2-A54E-D9DE7778803F}"/>
               </a:ext>
             </a:extLst>
           </p:cNvPr>
@@ -1849,7 +1849,7 @@
           <p:cNvPr id="3" name="Title">
             <a:extLst xmlns:a="http://schemas.openxmlformats.org/drawingml/2006/main">
               <a:ext uri="{FF2B5EF4-FFF2-40B4-BE49-F238E27FC236}">
-                <a16:creationId xmlns:a16="http://schemas.microsoft.com/office/drawing/2014/main" id="{8796DA2E-51FD-4A10-AA29-9E6D362577A9}"/>
+                <a16:creationId xmlns:a16="http://schemas.microsoft.com/office/drawing/2014/main" id="{47A77AE2-A747-4256-A1C3-9D789C2AAC79}"/>
               </a:ext>
             </a:extLst>
           </p:cNvPr>
@@ -2078,7 +2078,7 @@
           <p:cNvPr id="2" name="Body">
             <a:extLst xmlns:a="http://schemas.openxmlformats.org/drawingml/2006/main">
               <a:ext uri="{FF2B5EF4-FFF2-40B4-BE49-F238E27FC236}">
-                <a16:creationId xmlns:a16="http://schemas.microsoft.com/office/drawing/2014/main" id="{C2879448-9515-497B-8C30-C408CC80912F}"/>
+                <a16:creationId xmlns:a16="http://schemas.microsoft.com/office/drawing/2014/main" id="{712EA308-0056-412A-B04D-2B5B5EEE4794}"/>
               </a:ext>
             </a:extLst>
           </p:cNvPr>
@@ -2324,7 +2324,7 @@
           <p:cNvPr id="4" name="Title">
             <a:extLst xmlns:a="http://schemas.openxmlformats.org/drawingml/2006/main">
               <a:ext uri="{FF2B5EF4-FFF2-40B4-BE49-F238E27FC236}">
-                <a16:creationId xmlns:a16="http://schemas.microsoft.com/office/drawing/2014/main" id="{86E32930-360F-458F-BE88-17CC4A06D87F}"/>
+                <a16:creationId xmlns:a16="http://schemas.microsoft.com/office/drawing/2014/main" id="{9DEDD542-A1E1-42E4-8DF6-9009566173E1}"/>
               </a:ext>
             </a:extLst>
           </p:cNvPr>
@@ -2553,7 +2553,7 @@
           <p:cNvPr id="2" name="Left column">
             <a:extLst xmlns:a="http://schemas.openxmlformats.org/drawingml/2006/main">
               <a:ext uri="{FF2B5EF4-FFF2-40B4-BE49-F238E27FC236}">
-                <a16:creationId xmlns:a16="http://schemas.microsoft.com/office/drawing/2014/main" id="{2701E0A1-6FF4-405E-ADF9-EFDF699B5B8B}"/>
+                <a16:creationId xmlns:a16="http://schemas.microsoft.com/office/drawing/2014/main" id="{200DDD9F-7854-48E1-9D39-1E571292E340}"/>
               </a:ext>
             </a:extLst>
           </p:cNvPr>
@@ -2782,7 +2782,7 @@
           <p:cNvPr id="3" name="Right column">
             <a:extLst xmlns:a="http://schemas.openxmlformats.org/drawingml/2006/main">
               <a:ext uri="{FF2B5EF4-FFF2-40B4-BE49-F238E27FC236}">
-                <a16:creationId xmlns:a16="http://schemas.microsoft.com/office/drawing/2014/main" id="{178BACC6-8EF5-4765-9C82-304288D8E724}"/>
+                <a16:creationId xmlns:a16="http://schemas.microsoft.com/office/drawing/2014/main" id="{64CDE508-FDAC-4D75-9E70-E19A2318058D}"/>
               </a:ext>
             </a:extLst>
           </p:cNvPr>
@@ -3028,7 +3028,7 @@
           <p:cNvPr id="3" name="Title">
             <a:extLst xmlns:a="http://schemas.openxmlformats.org/drawingml/2006/main">
               <a:ext uri="{FF2B5EF4-FFF2-40B4-BE49-F238E27FC236}">
-                <a16:creationId xmlns:a16="http://schemas.microsoft.com/office/drawing/2014/main" id="{09376643-B024-44BB-A9C6-F8127143E4D2}"/>
+                <a16:creationId xmlns:a16="http://schemas.microsoft.com/office/drawing/2014/main" id="{27B133AC-4C5C-4EC9-8D40-137E0D001941}"/>
               </a:ext>
             </a:extLst>
           </p:cNvPr>
@@ -3257,7 +3257,7 @@
           <p:cNvPr id="2" name="Left column">
             <a:extLst xmlns:a="http://schemas.openxmlformats.org/drawingml/2006/main">
               <a:ext uri="{FF2B5EF4-FFF2-40B4-BE49-F238E27FC236}">
-                <a16:creationId xmlns:a16="http://schemas.microsoft.com/office/drawing/2014/main" id="{BB7F850C-7474-422B-AD25-F0EAA9D3148D}"/>
+                <a16:creationId xmlns:a16="http://schemas.microsoft.com/office/drawing/2014/main" id="{4CA92564-F14F-491B-9BD2-08A0EA6E9EF9}"/>
               </a:ext>
             </a:extLst>
           </p:cNvPr>
@@ -3524,12 +3524,12 @@
   </p:cSld>
   <p:clrMap bg1="lt1" tx1="dk1" bg2="lt2" tx2="dk2" accent1="accent1" accent2="accent2" accent3="accent3" accent4="accent4" accent5="accent5" accent6="accent6" hlink="hlink" folHlink="folHlink"/>
   <p:sldLayoutIdLst>
-    <p:sldLayoutId xmlns:r="http://schemas.openxmlformats.org/officeDocument/2006/relationships" id="2147483649" r:id="R39180b3391e04ee8"/>
-    <p:sldLayoutId xmlns:r="http://schemas.openxmlformats.org/officeDocument/2006/relationships" id="2147483650" r:id="R2d3a5d76e5c846f6"/>
-    <p:sldLayoutId xmlns:r="http://schemas.openxmlformats.org/officeDocument/2006/relationships" id="2147483651" r:id="R983457bf8c81489c"/>
-    <p:sldLayoutId xmlns:r="http://schemas.openxmlformats.org/officeDocument/2006/relationships" id="2147483652" r:id="R3cc03a2e916b4601"/>
-    <p:sldLayoutId xmlns:r="http://schemas.openxmlformats.org/officeDocument/2006/relationships" id="2147483653" r:id="Re6a8ba0aee844a0f"/>
-    <p:sldLayoutId xmlns:r="http://schemas.openxmlformats.org/officeDocument/2006/relationships" id="2147483654" r:id="R1c4d6031b2694602"/>
+    <p:sldLayoutId xmlns:r="http://schemas.openxmlformats.org/officeDocument/2006/relationships" id="2147483649" r:id="R3fb4b4e8c5b9498d"/>
+    <p:sldLayoutId xmlns:r="http://schemas.openxmlformats.org/officeDocument/2006/relationships" id="2147483650" r:id="R7efa4a545a874d3d"/>
+    <p:sldLayoutId xmlns:r="http://schemas.openxmlformats.org/officeDocument/2006/relationships" id="2147483651" r:id="Rfb403c061b054bc9"/>
+    <p:sldLayoutId xmlns:r="http://schemas.openxmlformats.org/officeDocument/2006/relationships" id="2147483652" r:id="R3e07072a79a143cc"/>
+    <p:sldLayoutId xmlns:r="http://schemas.openxmlformats.org/officeDocument/2006/relationships" id="2147483653" r:id="R5ed6c64d88e5442c"/>
+    <p:sldLayoutId xmlns:r="http://schemas.openxmlformats.org/officeDocument/2006/relationships" id="2147483654" r:id="Re20a7fd823d34d42"/>
   </p:sldLayoutIdLst>
   <p:txStyles>
     <p:titleStyle>
@@ -4338,7 +4338,7 @@
           <p:cNvPr id="10" name="">
             <a:extLst xmlns:a="http://schemas.openxmlformats.org/drawingml/2006/main">
               <a:ext uri="{FF2B5EF4-FFF2-40B4-BE49-F238E27FC236}">
-                <a16:creationId xmlns:a16="http://schemas.microsoft.com/office/drawing/2014/main" id="{15B66DD7-7604-467F-9DE2-37B1DEC03B91}"/>
+                <a16:creationId xmlns:a16="http://schemas.microsoft.com/office/drawing/2014/main" id="{1044C5EB-BDF8-4631-A187-2F5AE8FE2B3E}"/>
               </a:ext>
             </a:extLst>
           </p:cNvPr>
@@ -4369,7 +4369,7 @@
           <p:cNvPr id="2" name="">
             <a:extLst xmlns:a="http://schemas.openxmlformats.org/drawingml/2006/main">
               <a:ext uri="{FF2B5EF4-FFF2-40B4-BE49-F238E27FC236}">
-                <a16:creationId xmlns:a16="http://schemas.microsoft.com/office/drawing/2014/main" id="{6A6143D4-A837-4414-B19F-BB3127E5E6EC}"/>
+                <a16:creationId xmlns:a16="http://schemas.microsoft.com/office/drawing/2014/main" id="{15AFECCB-6EDF-4A69-9D46-13A0ADD9BBD0}"/>
               </a:ext>
             </a:extLst>
           </p:cNvPr>
@@ -4526,7 +4526,7 @@
           <p:cNvPr id="3" name="">
             <a:extLst xmlns:a="http://schemas.openxmlformats.org/drawingml/2006/main">
               <a:ext uri="{FF2B5EF4-FFF2-40B4-BE49-F238E27FC236}">
-                <a16:creationId xmlns:a16="http://schemas.microsoft.com/office/drawing/2014/main" id="{01A0C8A6-F004-48F8-8FD0-E7F897C5071E}"/>
+                <a16:creationId xmlns:a16="http://schemas.microsoft.com/office/drawing/2014/main" id="{74ED7362-FF46-47ED-B876-D9B4934BA600}"/>
               </a:ext>
             </a:extLst>
           </p:cNvPr>
@@ -4683,7 +4683,7 @@
           <p:cNvPr id="4" name="">
             <a:extLst xmlns:a="http://schemas.openxmlformats.org/drawingml/2006/main">
               <a:ext uri="{FF2B5EF4-FFF2-40B4-BE49-F238E27FC236}">
-                <a16:creationId xmlns:a16="http://schemas.microsoft.com/office/drawing/2014/main" id="{7DAC814E-9749-4F76-A312-63425C01A473}"/>
+                <a16:creationId xmlns:a16="http://schemas.microsoft.com/office/drawing/2014/main" id="{B366F10C-F4CC-467A-8151-D476B492BF7C}"/>
               </a:ext>
             </a:extLst>
           </p:cNvPr>
@@ -4840,7 +4840,7 @@
           <p:cNvPr id="5" name="">
             <a:extLst xmlns:a="http://schemas.openxmlformats.org/drawingml/2006/main">
               <a:ext uri="{FF2B5EF4-FFF2-40B4-BE49-F238E27FC236}">
-                <a16:creationId xmlns:a16="http://schemas.microsoft.com/office/drawing/2014/main" id="{A209D52C-37F2-4F08-A9F3-FB5BD58B39A5}"/>
+                <a16:creationId xmlns:a16="http://schemas.microsoft.com/office/drawing/2014/main" id="{D074743F-4596-44A5-B62F-7FEE35BFE5FE}"/>
               </a:ext>
             </a:extLst>
           </p:cNvPr>
@@ -4997,7 +4997,7 @@
           <p:cNvPr id="6" name="">
             <a:extLst xmlns:a="http://schemas.openxmlformats.org/drawingml/2006/main">
               <a:ext uri="{FF2B5EF4-FFF2-40B4-BE49-F238E27FC236}">
-                <a16:creationId xmlns:a16="http://schemas.microsoft.com/office/drawing/2014/main" id="{BFF1E8BE-D18F-4130-A426-48877FE1BAF6}"/>
+                <a16:creationId xmlns:a16="http://schemas.microsoft.com/office/drawing/2014/main" id="{C7400D6B-D39B-401B-857B-E99708783E72}"/>
               </a:ext>
             </a:extLst>
           </p:cNvPr>
@@ -5028,7 +5028,7 @@
           <p:cNvPr id="7" name="">
             <a:extLst xmlns:a="http://schemas.openxmlformats.org/drawingml/2006/main">
               <a:ext uri="{FF2B5EF4-FFF2-40B4-BE49-F238E27FC236}">
-                <a16:creationId xmlns:a16="http://schemas.microsoft.com/office/drawing/2014/main" id="{BE007136-7FC6-4875-A1D2-878686EA8434}"/>
+                <a16:creationId xmlns:a16="http://schemas.microsoft.com/office/drawing/2014/main" id="{AD44CA77-2F4B-4AC7-8113-3E6A4BE6E2D9}"/>
               </a:ext>
             </a:extLst>
           </p:cNvPr>
@@ -5185,7 +5185,7 @@
           <p:cNvPr id="8" name="">
             <a:extLst xmlns:a="http://schemas.openxmlformats.org/drawingml/2006/main">
               <a:ext uri="{FF2B5EF4-FFF2-40B4-BE49-F238E27FC236}">
-                <a16:creationId xmlns:a16="http://schemas.microsoft.com/office/drawing/2014/main" id="{4614C37C-A54E-466E-B0EF-B45EFB3154D8}"/>
+                <a16:creationId xmlns:a16="http://schemas.microsoft.com/office/drawing/2014/main" id="{E784DBC0-EBD4-4015-8A16-FF402BF93C4A}"/>
               </a:ext>
             </a:extLst>
           </p:cNvPr>
@@ -5342,7 +5342,7 @@
           <p:cNvPr id="9" name="">
             <a:extLst xmlns:a="http://schemas.openxmlformats.org/drawingml/2006/main">
               <a:ext uri="{FF2B5EF4-FFF2-40B4-BE49-F238E27FC236}">
-                <a16:creationId xmlns:a16="http://schemas.microsoft.com/office/drawing/2014/main" id="{631B7C7D-9596-4CBE-BB22-235F5B8B6984}"/>
+                <a16:creationId xmlns:a16="http://schemas.microsoft.com/office/drawing/2014/main" id="{01B82A4A-D027-4A63-A3A1-303F81197AEB}"/>
               </a:ext>
             </a:extLst>
           </p:cNvPr>
@@ -5497,7 +5497,7 @@
     </p:spTree>
     <p:extLst>
       <p:ext uri="{BB962C8B-B14F-4D97-AF65-F5344CB8AC3E}">
-        <p14:creationId xmlns:p14="http://schemas.microsoft.com/office/powerpoint/2010/main" val="1589376111"/>
+        <p14:creationId xmlns:p14="http://schemas.microsoft.com/office/powerpoint/2010/main" val="1801122426"/>
       </p:ext>
     </p:extLst>
   </p:cSld>
@@ -5528,7 +5528,7 @@
           <p:cNvPr id="20" name="">
             <a:extLst xmlns:a="http://schemas.openxmlformats.org/drawingml/2006/main">
               <a:ext uri="{FF2B5EF4-FFF2-40B4-BE49-F238E27FC236}">
-                <a16:creationId xmlns:a16="http://schemas.microsoft.com/office/drawing/2014/main" id="{79F3402B-2F48-475D-9EE5-76DF5A618D4D}"/>
+                <a16:creationId xmlns:a16="http://schemas.microsoft.com/office/drawing/2014/main" id="{953AC817-4FE3-4FBE-B9B1-73E978F3943E}"/>
               </a:ext>
             </a:extLst>
           </p:cNvPr>
@@ -5685,7 +5685,7 @@
           <p:cNvPr id="2" name="">
             <a:extLst xmlns:a="http://schemas.openxmlformats.org/drawingml/2006/main">
               <a:ext uri="{FF2B5EF4-FFF2-40B4-BE49-F238E27FC236}">
-                <a16:creationId xmlns:a16="http://schemas.microsoft.com/office/drawing/2014/main" id="{33E3B265-84B5-4EEB-920C-6945604E5112}"/>
+                <a16:creationId xmlns:a16="http://schemas.microsoft.com/office/drawing/2014/main" id="{6D24B775-79E9-4057-9C10-1FEB0267EA77}"/>
               </a:ext>
             </a:extLst>
           </p:cNvPr>
@@ -5716,7 +5716,7 @@
           <p:cNvPr id="3" name="">
             <a:extLst xmlns:a="http://schemas.openxmlformats.org/drawingml/2006/main">
               <a:ext uri="{FF2B5EF4-FFF2-40B4-BE49-F238E27FC236}">
-                <a16:creationId xmlns:a16="http://schemas.microsoft.com/office/drawing/2014/main" id="{9A914B73-103A-45A3-B7A1-3507D74DBE9E}"/>
+                <a16:creationId xmlns:a16="http://schemas.microsoft.com/office/drawing/2014/main" id="{E3EF83FB-0A87-49BE-A187-2F03C38F1D69}"/>
               </a:ext>
             </a:extLst>
           </p:cNvPr>
@@ -5873,7 +5873,7 @@
           <p:cNvPr id="4" name="">
             <a:extLst xmlns:a="http://schemas.openxmlformats.org/drawingml/2006/main">
               <a:ext uri="{FF2B5EF4-FFF2-40B4-BE49-F238E27FC236}">
-                <a16:creationId xmlns:a16="http://schemas.microsoft.com/office/drawing/2014/main" id="{7EC7F135-7352-4A3F-A31D-D9A217DB7B4E}"/>
+                <a16:creationId xmlns:a16="http://schemas.microsoft.com/office/drawing/2014/main" id="{B4B41EB0-B403-4E9B-9B1E-148B296CF3BF}"/>
               </a:ext>
             </a:extLst>
           </p:cNvPr>
@@ -6030,7 +6030,7 @@
           <p:cNvPr id="5" name="">
             <a:extLst xmlns:a="http://schemas.openxmlformats.org/drawingml/2006/main">
               <a:ext uri="{FF2B5EF4-FFF2-40B4-BE49-F238E27FC236}">
-                <a16:creationId xmlns:a16="http://schemas.microsoft.com/office/drawing/2014/main" id="{ED319BDB-E2AD-449F-B78F-8662AA39C1B0}"/>
+                <a16:creationId xmlns:a16="http://schemas.microsoft.com/office/drawing/2014/main" id="{7D6A5EDF-EDFB-4B84-B939-213D53375A9B}"/>
               </a:ext>
             </a:extLst>
           </p:cNvPr>
@@ -6187,7 +6187,7 @@
           <p:cNvPr id="6" name="">
             <a:extLst xmlns:a="http://schemas.openxmlformats.org/drawingml/2006/main">
               <a:ext uri="{FF2B5EF4-FFF2-40B4-BE49-F238E27FC236}">
-                <a16:creationId xmlns:a16="http://schemas.microsoft.com/office/drawing/2014/main" id="{D04531F0-39A3-4654-A20B-3CE032078924}"/>
+                <a16:creationId xmlns:a16="http://schemas.microsoft.com/office/drawing/2014/main" id="{271647BE-0376-4507-B81F-DAB5941C517F}"/>
               </a:ext>
             </a:extLst>
           </p:cNvPr>
@@ -7046,7 +7046,7 @@
           <p:cNvPr id="7" name="">
             <a:extLst xmlns:a="http://schemas.openxmlformats.org/drawingml/2006/main">
               <a:ext uri="{FF2B5EF4-FFF2-40B4-BE49-F238E27FC236}">
-                <a16:creationId xmlns:a16="http://schemas.microsoft.com/office/drawing/2014/main" id="{AB88FC0E-F773-45C4-8437-CF280AB813D9}"/>
+                <a16:creationId xmlns:a16="http://schemas.microsoft.com/office/drawing/2014/main" id="{41570CA9-A2AE-4413-85B3-CF50F9540578}"/>
               </a:ext>
             </a:extLst>
           </p:cNvPr>
@@ -7203,7 +7203,7 @@
           <p:cNvPr id="8" name="">
             <a:extLst xmlns:a="http://schemas.openxmlformats.org/drawingml/2006/main">
               <a:ext uri="{FF2B5EF4-FFF2-40B4-BE49-F238E27FC236}">
-                <a16:creationId xmlns:a16="http://schemas.microsoft.com/office/drawing/2014/main" id="{C1FB6484-31F0-44C3-BF28-71FF53148620}"/>
+                <a16:creationId xmlns:a16="http://schemas.microsoft.com/office/drawing/2014/main" id="{1198D554-CF49-45A3-809C-C5870FF56A08}"/>
               </a:ext>
             </a:extLst>
           </p:cNvPr>
@@ -7360,7 +7360,7 @@
           <p:cNvPr id="9" name="">
             <a:extLst xmlns:a="http://schemas.openxmlformats.org/drawingml/2006/main">
               <a:ext uri="{FF2B5EF4-FFF2-40B4-BE49-F238E27FC236}">
-                <a16:creationId xmlns:a16="http://schemas.microsoft.com/office/drawing/2014/main" id="{85FE9B14-4188-45FE-8C86-6518D87EBA71}"/>
+                <a16:creationId xmlns:a16="http://schemas.microsoft.com/office/drawing/2014/main" id="{53BD46FC-8E9E-4148-AE07-874C5867C6AA}"/>
               </a:ext>
             </a:extLst>
           </p:cNvPr>
@@ -7517,7 +7517,7 @@
           <p:cNvPr id="10" name="">
             <a:extLst xmlns:a="http://schemas.openxmlformats.org/drawingml/2006/main">
               <a:ext uri="{FF2B5EF4-FFF2-40B4-BE49-F238E27FC236}">
-                <a16:creationId xmlns:a16="http://schemas.microsoft.com/office/drawing/2014/main" id="{E41AF3D5-2A63-4757-B5ED-9B8837454B7A}"/>
+                <a16:creationId xmlns:a16="http://schemas.microsoft.com/office/drawing/2014/main" id="{EFE69C04-9245-4209-AFEF-3FBAD256DC0C}"/>
               </a:ext>
             </a:extLst>
           </p:cNvPr>
@@ -7674,7 +7674,7 @@
           <p:cNvPr id="11" name="">
             <a:extLst xmlns:a="http://schemas.openxmlformats.org/drawingml/2006/main">
               <a:ext uri="{FF2B5EF4-FFF2-40B4-BE49-F238E27FC236}">
-                <a16:creationId xmlns:a16="http://schemas.microsoft.com/office/drawing/2014/main" id="{093F116B-87ED-4CC6-A155-AF49882EE738}"/>
+                <a16:creationId xmlns:a16="http://schemas.microsoft.com/office/drawing/2014/main" id="{1CBB38D4-5BFD-406A-A9C4-151EE358E473}"/>
               </a:ext>
             </a:extLst>
           </p:cNvPr>
@@ -7831,7 +7831,7 @@
           <p:cNvPr id="12" name="">
             <a:extLst xmlns:a="http://schemas.openxmlformats.org/drawingml/2006/main">
               <a:ext uri="{FF2B5EF4-FFF2-40B4-BE49-F238E27FC236}">
-                <a16:creationId xmlns:a16="http://schemas.microsoft.com/office/drawing/2014/main" id="{8DE7BF6A-8AE8-4B74-94FA-633B01F57947}"/>
+                <a16:creationId xmlns:a16="http://schemas.microsoft.com/office/drawing/2014/main" id="{0A0DACC3-4AEF-4B17-A69D-69A8DCBE8040}"/>
               </a:ext>
             </a:extLst>
           </p:cNvPr>
@@ -7988,7 +7988,7 @@
           <p:cNvPr id="13" name="">
             <a:extLst xmlns:a="http://schemas.openxmlformats.org/drawingml/2006/main">
               <a:ext uri="{FF2B5EF4-FFF2-40B4-BE49-F238E27FC236}">
-                <a16:creationId xmlns:a16="http://schemas.microsoft.com/office/drawing/2014/main" id="{12778F81-60CD-483B-8163-21DABCAE5796}"/>
+                <a16:creationId xmlns:a16="http://schemas.microsoft.com/office/drawing/2014/main" id="{C7CC7FB5-A4DE-4240-BAF5-D0441385DA5C}"/>
               </a:ext>
             </a:extLst>
           </p:cNvPr>
@@ -8145,7 +8145,7 @@
           <p:cNvPr id="14" name="">
             <a:extLst xmlns:a="http://schemas.openxmlformats.org/drawingml/2006/main">
               <a:ext uri="{FF2B5EF4-FFF2-40B4-BE49-F238E27FC236}">
-                <a16:creationId xmlns:a16="http://schemas.microsoft.com/office/drawing/2014/main" id="{6B54E058-91EA-4506-B8A0-44B15A940DD6}"/>
+                <a16:creationId xmlns:a16="http://schemas.microsoft.com/office/drawing/2014/main" id="{30C7AA50-0C30-4A4A-B5AA-F5986254130D}"/>
               </a:ext>
             </a:extLst>
           </p:cNvPr>
@@ -8176,7 +8176,7 @@
           <p:cNvPr id="15" name="">
             <a:extLst xmlns:a="http://schemas.openxmlformats.org/drawingml/2006/main">
               <a:ext uri="{FF2B5EF4-FFF2-40B4-BE49-F238E27FC236}">
-                <a16:creationId xmlns:a16="http://schemas.microsoft.com/office/drawing/2014/main" id="{8F67535E-A83B-4F71-938C-F92AD3B8C85D}"/>
+                <a16:creationId xmlns:a16="http://schemas.microsoft.com/office/drawing/2014/main" id="{63B00504-D618-486A-AA76-E4E361EAAFA0}"/>
               </a:ext>
             </a:extLst>
           </p:cNvPr>
@@ -8323,7 +8323,7 @@
                 <a:ea typeface="Songti SC"/>
                 <a:cs typeface="Songti SC"/>
               </a:rPr>
-              <a:t>仍未成立</a:t>
+              <a:t>仍未给出一般结论</a:t>
             </a:r>
           </a:p>
         </p:txBody>
@@ -8333,7 +8333,7 @@
           <p:cNvPr id="16" name="">
             <a:extLst xmlns:a="http://schemas.openxmlformats.org/drawingml/2006/main">
               <a:ext uri="{FF2B5EF4-FFF2-40B4-BE49-F238E27FC236}">
-                <a16:creationId xmlns:a16="http://schemas.microsoft.com/office/drawing/2014/main" id="{D4BEB56A-509A-42E5-BB9D-6C9816BE348A}"/>
+                <a16:creationId xmlns:a16="http://schemas.microsoft.com/office/drawing/2014/main" id="{8AE2B471-FB0E-4B8F-84DB-073316195CCC}"/>
               </a:ext>
             </a:extLst>
           </p:cNvPr>
@@ -8480,7 +8480,7 @@
                 <a:ea typeface="Songti SC"/>
                 <a:cs typeface="Songti SC"/>
               </a:rPr>
-              <a:t>图谱收益、正确弃答率、跨仓库泛化</a:t>
+              <a:t>图谱收益、正确弃答率（分母 0）、跨仓库泛化</a:t>
             </a:r>
           </a:p>
         </p:txBody>
@@ -8490,7 +8490,7 @@
           <p:cNvPr id="17" name="">
             <a:extLst xmlns:a="http://schemas.openxmlformats.org/drawingml/2006/main">
               <a:ext uri="{FF2B5EF4-FFF2-40B4-BE49-F238E27FC236}">
-                <a16:creationId xmlns:a16="http://schemas.microsoft.com/office/drawing/2014/main" id="{44A52D02-4748-4847-AB65-C269B4E6788F}"/>
+                <a16:creationId xmlns:a16="http://schemas.microsoft.com/office/drawing/2014/main" id="{A61D0099-A20B-462C-AB86-577067B9EF80}"/>
               </a:ext>
             </a:extLst>
           </p:cNvPr>
@@ -8637,7 +8637,7 @@
                 <a:ea typeface="Songti SC"/>
                 <a:cs typeface="Songti SC"/>
               </a:rPr>
-              <a:t>下一步：全池两遍核验、第二小库、Windows / PowerPoint 实机、成员信息。</a:t>
+              <a:t>下一步：Windows 实机、Neo4j 现场重连、PowerPoint 原生检查、成员信息。</a:t>
             </a:r>
           </a:p>
         </p:txBody>
@@ -8647,7 +8647,7 @@
           <p:cNvPr id="18" name="">
             <a:extLst xmlns:a="http://schemas.openxmlformats.org/drawingml/2006/main">
               <a:ext uri="{FF2B5EF4-FFF2-40B4-BE49-F238E27FC236}">
-                <a16:creationId xmlns:a16="http://schemas.microsoft.com/office/drawing/2014/main" id="{13ECD7C2-8252-476E-BE8D-51C0424F5BDD}"/>
+                <a16:creationId xmlns:a16="http://schemas.microsoft.com/office/drawing/2014/main" id="{C96FD164-1476-491E-8673-CF920B3667B1}"/>
               </a:ext>
             </a:extLst>
           </p:cNvPr>
@@ -8804,7 +8804,7 @@
           <p:cNvPr id="19" name="">
             <a:extLst xmlns:a="http://schemas.openxmlformats.org/drawingml/2006/main">
               <a:ext uri="{FF2B5EF4-FFF2-40B4-BE49-F238E27FC236}">
-                <a16:creationId xmlns:a16="http://schemas.microsoft.com/office/drawing/2014/main" id="{49986D79-CBB6-43F4-876E-7AEC0B8A204D}"/>
+                <a16:creationId xmlns:a16="http://schemas.microsoft.com/office/drawing/2014/main" id="{740B42B0-6594-46E0-8263-174EEEDB73C1}"/>
               </a:ext>
             </a:extLst>
           </p:cNvPr>
@@ -8959,7 +8959,7 @@
     </p:spTree>
     <p:extLst>
       <p:ext uri="{BB962C8B-B14F-4D97-AF65-F5344CB8AC3E}">
-        <p14:creationId xmlns:p14="http://schemas.microsoft.com/office/powerpoint/2010/main" val="1359108575"/>
+        <p14:creationId xmlns:p14="http://schemas.microsoft.com/office/powerpoint/2010/main" val="1002141494"/>
       </p:ext>
     </p:extLst>
   </p:cSld>
@@ -8990,7 +8990,7 @@
           <p:cNvPr id="25" name="">
             <a:extLst xmlns:a="http://schemas.openxmlformats.org/drawingml/2006/main">
               <a:ext uri="{FF2B5EF4-FFF2-40B4-BE49-F238E27FC236}">
-                <a16:creationId xmlns:a16="http://schemas.microsoft.com/office/drawing/2014/main" id="{7507465B-009B-41C6-9DF3-0B4CCAFCF69E}"/>
+                <a16:creationId xmlns:a16="http://schemas.microsoft.com/office/drawing/2014/main" id="{EE83CCB0-1467-4EBC-B672-353B4A147B7B}"/>
               </a:ext>
             </a:extLst>
           </p:cNvPr>
@@ -9147,7 +9147,7 @@
           <p:cNvPr id="2" name="">
             <a:extLst xmlns:a="http://schemas.openxmlformats.org/drawingml/2006/main">
               <a:ext uri="{FF2B5EF4-FFF2-40B4-BE49-F238E27FC236}">
-                <a16:creationId xmlns:a16="http://schemas.microsoft.com/office/drawing/2014/main" id="{B8CFB4EF-C91A-4E3F-B835-7600BF91BD44}"/>
+                <a16:creationId xmlns:a16="http://schemas.microsoft.com/office/drawing/2014/main" id="{EC383CCC-B98D-4294-9D6B-60301B1D94F8}"/>
               </a:ext>
             </a:extLst>
           </p:cNvPr>
@@ -9178,7 +9178,7 @@
           <p:cNvPr id="3" name="">
             <a:extLst xmlns:a="http://schemas.openxmlformats.org/drawingml/2006/main">
               <a:ext uri="{FF2B5EF4-FFF2-40B4-BE49-F238E27FC236}">
-                <a16:creationId xmlns:a16="http://schemas.microsoft.com/office/drawing/2014/main" id="{EFF2228D-B300-4833-BCF0-AA227E86A0CB}"/>
+                <a16:creationId xmlns:a16="http://schemas.microsoft.com/office/drawing/2014/main" id="{C3585B4E-F033-416B-B744-1A2C3A8302F4}"/>
               </a:ext>
             </a:extLst>
           </p:cNvPr>
@@ -9335,7 +9335,7 @@
           <p:cNvPr id="4" name="">
             <a:extLst xmlns:a="http://schemas.openxmlformats.org/drawingml/2006/main">
               <a:ext uri="{FF2B5EF4-FFF2-40B4-BE49-F238E27FC236}">
-                <a16:creationId xmlns:a16="http://schemas.microsoft.com/office/drawing/2014/main" id="{A011C258-47B2-4F42-9F24-B11C8EBBB394}"/>
+                <a16:creationId xmlns:a16="http://schemas.microsoft.com/office/drawing/2014/main" id="{94464FE2-5982-4CC3-ADA8-3B6B00260FF1}"/>
               </a:ext>
             </a:extLst>
           </p:cNvPr>
@@ -9492,7 +9492,7 @@
           <p:cNvPr id="5" name="">
             <a:extLst xmlns:a="http://schemas.openxmlformats.org/drawingml/2006/main">
               <a:ext uri="{FF2B5EF4-FFF2-40B4-BE49-F238E27FC236}">
-                <a16:creationId xmlns:a16="http://schemas.microsoft.com/office/drawing/2014/main" id="{D4589FC9-D335-4443-B150-BD7DC83D4C57}"/>
+                <a16:creationId xmlns:a16="http://schemas.microsoft.com/office/drawing/2014/main" id="{E5840865-B8F5-46FF-B698-C3D80866D37A}"/>
               </a:ext>
             </a:extLst>
           </p:cNvPr>
@@ -9649,7 +9649,7 @@
           <p:cNvPr id="6" name="">
             <a:extLst xmlns:a="http://schemas.openxmlformats.org/drawingml/2006/main">
               <a:ext uri="{FF2B5EF4-FFF2-40B4-BE49-F238E27FC236}">
-                <a16:creationId xmlns:a16="http://schemas.microsoft.com/office/drawing/2014/main" id="{4D08B11E-2745-4F88-9E73-ACEB2DF33B52}"/>
+                <a16:creationId xmlns:a16="http://schemas.microsoft.com/office/drawing/2014/main" id="{B4B8B3C4-7F41-418B-BA5B-CBBF527D7FA0}"/>
               </a:ext>
             </a:extLst>
           </p:cNvPr>
@@ -9806,7 +9806,7 @@
           <p:cNvPr id="7" name="">
             <a:extLst xmlns:a="http://schemas.openxmlformats.org/drawingml/2006/main">
               <a:ext uri="{FF2B5EF4-FFF2-40B4-BE49-F238E27FC236}">
-                <a16:creationId xmlns:a16="http://schemas.microsoft.com/office/drawing/2014/main" id="{A1E7A92B-D237-4FC0-AB56-5BC72DF38533}"/>
+                <a16:creationId xmlns:a16="http://schemas.microsoft.com/office/drawing/2014/main" id="{0A2A0E32-740F-4034-AD2F-985B9B547897}"/>
               </a:ext>
             </a:extLst>
           </p:cNvPr>
@@ -9963,7 +9963,7 @@
           <p:cNvPr id="8" name="">
             <a:extLst xmlns:a="http://schemas.openxmlformats.org/drawingml/2006/main">
               <a:ext uri="{FF2B5EF4-FFF2-40B4-BE49-F238E27FC236}">
-                <a16:creationId xmlns:a16="http://schemas.microsoft.com/office/drawing/2014/main" id="{04DC3A89-CA20-4F37-BEA8-7E027B891B47}"/>
+                <a16:creationId xmlns:a16="http://schemas.microsoft.com/office/drawing/2014/main" id="{2027C18F-ED09-4CE1-B2EB-CCE532D170CA}"/>
               </a:ext>
             </a:extLst>
           </p:cNvPr>
@@ -9994,7 +9994,7 @@
           <p:cNvPr id="9" name="">
             <a:extLst xmlns:a="http://schemas.openxmlformats.org/drawingml/2006/main">
               <a:ext uri="{FF2B5EF4-FFF2-40B4-BE49-F238E27FC236}">
-                <a16:creationId xmlns:a16="http://schemas.microsoft.com/office/drawing/2014/main" id="{C49817EF-FE85-4ED7-AB10-E30796341D7F}"/>
+                <a16:creationId xmlns:a16="http://schemas.microsoft.com/office/drawing/2014/main" id="{48E159FB-1659-46EF-A178-119FD430B674}"/>
               </a:ext>
             </a:extLst>
           </p:cNvPr>
@@ -10151,7 +10151,7 @@
           <p:cNvPr id="10" name="">
             <a:extLst xmlns:a="http://schemas.openxmlformats.org/drawingml/2006/main">
               <a:ext uri="{FF2B5EF4-FFF2-40B4-BE49-F238E27FC236}">
-                <a16:creationId xmlns:a16="http://schemas.microsoft.com/office/drawing/2014/main" id="{D18CE5F0-5B35-4F0D-A661-AC804B6156B1}"/>
+                <a16:creationId xmlns:a16="http://schemas.microsoft.com/office/drawing/2014/main" id="{48FC8CE3-D882-4E3C-909F-5EA8B1A46E02}"/>
               </a:ext>
             </a:extLst>
           </p:cNvPr>
@@ -10308,7 +10308,7 @@
           <p:cNvPr id="11" name="">
             <a:extLst xmlns:a="http://schemas.openxmlformats.org/drawingml/2006/main">
               <a:ext uri="{FF2B5EF4-FFF2-40B4-BE49-F238E27FC236}">
-                <a16:creationId xmlns:a16="http://schemas.microsoft.com/office/drawing/2014/main" id="{6BAFBA27-D5E7-4A1D-A363-56B39E39CCB0}"/>
+                <a16:creationId xmlns:a16="http://schemas.microsoft.com/office/drawing/2014/main" id="{89BC7FC2-9F50-4683-8D5E-D9F53E1ADEF7}"/>
               </a:ext>
             </a:extLst>
           </p:cNvPr>
@@ -10339,7 +10339,7 @@
           <p:cNvPr id="12" name="">
             <a:extLst xmlns:a="http://schemas.openxmlformats.org/drawingml/2006/main">
               <a:ext uri="{FF2B5EF4-FFF2-40B4-BE49-F238E27FC236}">
-                <a16:creationId xmlns:a16="http://schemas.microsoft.com/office/drawing/2014/main" id="{E0ED2BFB-FC2F-4215-9346-586F27EF6803}"/>
+                <a16:creationId xmlns:a16="http://schemas.microsoft.com/office/drawing/2014/main" id="{B2DED518-2BCC-4DE4-BD49-7CB474206A13}"/>
               </a:ext>
             </a:extLst>
           </p:cNvPr>
@@ -10496,7 +10496,7 @@
           <p:cNvPr id="13" name="">
             <a:extLst xmlns:a="http://schemas.openxmlformats.org/drawingml/2006/main">
               <a:ext uri="{FF2B5EF4-FFF2-40B4-BE49-F238E27FC236}">
-                <a16:creationId xmlns:a16="http://schemas.microsoft.com/office/drawing/2014/main" id="{C172AC00-0D19-4B40-9AA5-4120070874D1}"/>
+                <a16:creationId xmlns:a16="http://schemas.microsoft.com/office/drawing/2014/main" id="{BDEB1BC3-20D9-4359-BA70-38941BCF40C6}"/>
               </a:ext>
             </a:extLst>
           </p:cNvPr>
@@ -10653,7 +10653,7 @@
           <p:cNvPr id="14" name="">
             <a:extLst xmlns:a="http://schemas.openxmlformats.org/drawingml/2006/main">
               <a:ext uri="{FF2B5EF4-FFF2-40B4-BE49-F238E27FC236}">
-                <a16:creationId xmlns:a16="http://schemas.microsoft.com/office/drawing/2014/main" id="{1F94EB68-8E59-471D-B6EB-8A31A8C35E17}"/>
+                <a16:creationId xmlns:a16="http://schemas.microsoft.com/office/drawing/2014/main" id="{94A06E7F-7180-4F8D-9BF9-D3DA16C4F23B}"/>
               </a:ext>
             </a:extLst>
           </p:cNvPr>
@@ -10684,7 +10684,7 @@
           <p:cNvPr id="15" name="">
             <a:extLst xmlns:a="http://schemas.openxmlformats.org/drawingml/2006/main">
               <a:ext uri="{FF2B5EF4-FFF2-40B4-BE49-F238E27FC236}">
-                <a16:creationId xmlns:a16="http://schemas.microsoft.com/office/drawing/2014/main" id="{4A30586E-ADA5-4D63-A94E-FE5461AB2373}"/>
+                <a16:creationId xmlns:a16="http://schemas.microsoft.com/office/drawing/2014/main" id="{E883E3CA-5322-48FA-AA9E-2CB9068ED987}"/>
               </a:ext>
             </a:extLst>
           </p:cNvPr>
@@ -10841,7 +10841,7 @@
           <p:cNvPr id="16" name="">
             <a:extLst xmlns:a="http://schemas.openxmlformats.org/drawingml/2006/main">
               <a:ext uri="{FF2B5EF4-FFF2-40B4-BE49-F238E27FC236}">
-                <a16:creationId xmlns:a16="http://schemas.microsoft.com/office/drawing/2014/main" id="{443A65CB-4D00-486E-97D3-990668065B7F}"/>
+                <a16:creationId xmlns:a16="http://schemas.microsoft.com/office/drawing/2014/main" id="{1A11F26D-14DF-4F2A-B7FD-FA5DD0E99247}"/>
               </a:ext>
             </a:extLst>
           </p:cNvPr>
@@ -10998,7 +10998,7 @@
           <p:cNvPr id="17" name="">
             <a:extLst xmlns:a="http://schemas.openxmlformats.org/drawingml/2006/main">
               <a:ext uri="{FF2B5EF4-FFF2-40B4-BE49-F238E27FC236}">
-                <a16:creationId xmlns:a16="http://schemas.microsoft.com/office/drawing/2014/main" id="{F8B7591B-1440-4B44-8FD9-12B5FD90CF6A}"/>
+                <a16:creationId xmlns:a16="http://schemas.microsoft.com/office/drawing/2014/main" id="{35F37844-95B9-4EE1-89C6-B4CC1805E711}"/>
               </a:ext>
             </a:extLst>
           </p:cNvPr>
@@ -11029,7 +11029,7 @@
           <p:cNvPr id="18" name="">
             <a:extLst xmlns:a="http://schemas.openxmlformats.org/drawingml/2006/main">
               <a:ext uri="{FF2B5EF4-FFF2-40B4-BE49-F238E27FC236}">
-                <a16:creationId xmlns:a16="http://schemas.microsoft.com/office/drawing/2014/main" id="{4F567C9C-1A05-4134-AA86-3BC5745D9B9D}"/>
+                <a16:creationId xmlns:a16="http://schemas.microsoft.com/office/drawing/2014/main" id="{291DC32A-2ECB-405E-81A2-537713FAC8AC}"/>
               </a:ext>
             </a:extLst>
           </p:cNvPr>
@@ -11186,7 +11186,7 @@
           <p:cNvPr id="19" name="">
             <a:extLst xmlns:a="http://schemas.openxmlformats.org/drawingml/2006/main">
               <a:ext uri="{FF2B5EF4-FFF2-40B4-BE49-F238E27FC236}">
-                <a16:creationId xmlns:a16="http://schemas.microsoft.com/office/drawing/2014/main" id="{D4F4179D-3BC3-42B9-AF8B-AB7713EA0F98}"/>
+                <a16:creationId xmlns:a16="http://schemas.microsoft.com/office/drawing/2014/main" id="{687CDF99-F5E0-4D3F-B569-35F5EB874CDC}"/>
               </a:ext>
             </a:extLst>
           </p:cNvPr>
@@ -11343,7 +11343,7 @@
           <p:cNvPr id="20" name="">
             <a:extLst xmlns:a="http://schemas.openxmlformats.org/drawingml/2006/main">
               <a:ext uri="{FF2B5EF4-FFF2-40B4-BE49-F238E27FC236}">
-                <a16:creationId xmlns:a16="http://schemas.microsoft.com/office/drawing/2014/main" id="{546E6142-DDA2-4BF2-870A-76F1DDF2A47E}"/>
+                <a16:creationId xmlns:a16="http://schemas.microsoft.com/office/drawing/2014/main" id="{8F8A2447-10AD-46B7-AD4D-DB04CC031CE2}"/>
               </a:ext>
             </a:extLst>
           </p:cNvPr>
@@ -11500,7 +11500,7 @@
           <p:cNvPr id="21" name="">
             <a:extLst xmlns:a="http://schemas.openxmlformats.org/drawingml/2006/main">
               <a:ext uri="{FF2B5EF4-FFF2-40B4-BE49-F238E27FC236}">
-                <a16:creationId xmlns:a16="http://schemas.microsoft.com/office/drawing/2014/main" id="{9E776865-F8BB-4603-86A6-5B6A6057FC55}"/>
+                <a16:creationId xmlns:a16="http://schemas.microsoft.com/office/drawing/2014/main" id="{67882A56-4363-4F27-92DE-B6A9CF53916B}"/>
               </a:ext>
             </a:extLst>
           </p:cNvPr>
@@ -11657,7 +11657,7 @@
           <p:cNvPr id="22" name="">
             <a:extLst xmlns:a="http://schemas.openxmlformats.org/drawingml/2006/main">
               <a:ext uri="{FF2B5EF4-FFF2-40B4-BE49-F238E27FC236}">
-                <a16:creationId xmlns:a16="http://schemas.microsoft.com/office/drawing/2014/main" id="{2514381D-B8BF-412C-A32B-5CAA8F0817F8}"/>
+                <a16:creationId xmlns:a16="http://schemas.microsoft.com/office/drawing/2014/main" id="{31C8B890-C2BC-4420-89E0-1C3C69A70126}"/>
               </a:ext>
             </a:extLst>
           </p:cNvPr>
@@ -11688,7 +11688,7 @@
           <p:cNvPr id="23" name="">
             <a:extLst xmlns:a="http://schemas.openxmlformats.org/drawingml/2006/main">
               <a:ext uri="{FF2B5EF4-FFF2-40B4-BE49-F238E27FC236}">
-                <a16:creationId xmlns:a16="http://schemas.microsoft.com/office/drawing/2014/main" id="{A5FCA13B-A2C0-48DD-9C2C-5AABFEA409C0}"/>
+                <a16:creationId xmlns:a16="http://schemas.microsoft.com/office/drawing/2014/main" id="{FA735DB8-CE8B-4110-A488-413BB07B2C76}"/>
               </a:ext>
             </a:extLst>
           </p:cNvPr>
@@ -11845,7 +11845,7 @@
           <p:cNvPr id="24" name="">
             <a:extLst xmlns:a="http://schemas.openxmlformats.org/drawingml/2006/main">
               <a:ext uri="{FF2B5EF4-FFF2-40B4-BE49-F238E27FC236}">
-                <a16:creationId xmlns:a16="http://schemas.microsoft.com/office/drawing/2014/main" id="{55E9F474-DE9E-4317-BDA5-5CD89AE67F7F}"/>
+                <a16:creationId xmlns:a16="http://schemas.microsoft.com/office/drawing/2014/main" id="{3BB9EFB6-3162-4E16-BFA1-643E60279274}"/>
               </a:ext>
             </a:extLst>
           </p:cNvPr>
@@ -12000,7 +12000,7 @@
     </p:spTree>
     <p:extLst>
       <p:ext uri="{BB962C8B-B14F-4D97-AF65-F5344CB8AC3E}">
-        <p14:creationId xmlns:p14="http://schemas.microsoft.com/office/powerpoint/2010/main" val="2145537460"/>
+        <p14:creationId xmlns:p14="http://schemas.microsoft.com/office/powerpoint/2010/main" val="319776351"/>
       </p:ext>
     </p:extLst>
   </p:cSld>
@@ -12031,7 +12031,7 @@
           <p:cNvPr id="32" name="">
             <a:extLst xmlns:a="http://schemas.openxmlformats.org/drawingml/2006/main">
               <a:ext uri="{FF2B5EF4-FFF2-40B4-BE49-F238E27FC236}">
-                <a16:creationId xmlns:a16="http://schemas.microsoft.com/office/drawing/2014/main" id="{21716CCF-BCB4-450E-83C2-72A3C0A626AF}"/>
+                <a16:creationId xmlns:a16="http://schemas.microsoft.com/office/drawing/2014/main" id="{AB8BE954-95EC-495D-B9C7-243CEA401413}"/>
               </a:ext>
             </a:extLst>
           </p:cNvPr>
@@ -12188,7 +12188,7 @@
           <p:cNvPr id="2" name="">
             <a:extLst xmlns:a="http://schemas.openxmlformats.org/drawingml/2006/main">
               <a:ext uri="{FF2B5EF4-FFF2-40B4-BE49-F238E27FC236}">
-                <a16:creationId xmlns:a16="http://schemas.microsoft.com/office/drawing/2014/main" id="{1F809C55-0513-4839-BC47-48C4C1FCFCBE}"/>
+                <a16:creationId xmlns:a16="http://schemas.microsoft.com/office/drawing/2014/main" id="{91C09E95-13B2-47FB-8E4A-46012A66EBA3}"/>
               </a:ext>
             </a:extLst>
           </p:cNvPr>
@@ -12219,7 +12219,7 @@
           <p:cNvPr id="3" name="">
             <a:extLst xmlns:a="http://schemas.openxmlformats.org/drawingml/2006/main">
               <a:ext uri="{FF2B5EF4-FFF2-40B4-BE49-F238E27FC236}">
-                <a16:creationId xmlns:a16="http://schemas.microsoft.com/office/drawing/2014/main" id="{F352D9F4-BF6D-48AB-842A-DB32394F5F9F}"/>
+                <a16:creationId xmlns:a16="http://schemas.microsoft.com/office/drawing/2014/main" id="{7E905802-C207-4CB5-97E8-E33C4F6AE6C4}"/>
               </a:ext>
             </a:extLst>
           </p:cNvPr>
@@ -12376,7 +12376,7 @@
           <p:cNvPr id="4" name="">
             <a:extLst xmlns:a="http://schemas.openxmlformats.org/drawingml/2006/main">
               <a:ext uri="{FF2B5EF4-FFF2-40B4-BE49-F238E27FC236}">
-                <a16:creationId xmlns:a16="http://schemas.microsoft.com/office/drawing/2014/main" id="{F1FC3363-ED0E-4F97-AB44-6047E0488611}"/>
+                <a16:creationId xmlns:a16="http://schemas.microsoft.com/office/drawing/2014/main" id="{142C0750-B2ED-4748-9BFB-4BE9CD0DE5C9}"/>
               </a:ext>
             </a:extLst>
           </p:cNvPr>
@@ -12533,7 +12533,7 @@
           <p:cNvPr id="5" name="">
             <a:extLst xmlns:a="http://schemas.openxmlformats.org/drawingml/2006/main">
               <a:ext uri="{FF2B5EF4-FFF2-40B4-BE49-F238E27FC236}">
-                <a16:creationId xmlns:a16="http://schemas.microsoft.com/office/drawing/2014/main" id="{A5AE5397-14D3-44C5-B388-29C2701C83D8}"/>
+                <a16:creationId xmlns:a16="http://schemas.microsoft.com/office/drawing/2014/main" id="{9F846C03-BA24-4645-92A9-999F4FEBB457}"/>
               </a:ext>
             </a:extLst>
           </p:cNvPr>
@@ -12690,7 +12690,7 @@
           <p:cNvPr id="6" name="">
             <a:extLst xmlns:a="http://schemas.openxmlformats.org/drawingml/2006/main">
               <a:ext uri="{FF2B5EF4-FFF2-40B4-BE49-F238E27FC236}">
-                <a16:creationId xmlns:a16="http://schemas.microsoft.com/office/drawing/2014/main" id="{3B4A4CEC-E47E-4929-BFF5-3A12712E6F62}"/>
+                <a16:creationId xmlns:a16="http://schemas.microsoft.com/office/drawing/2014/main" id="{9EB303A6-C838-43D8-B64E-8847111AACA7}"/>
               </a:ext>
             </a:extLst>
           </p:cNvPr>
@@ -12847,7 +12847,7 @@
           <p:cNvPr id="7" name="">
             <a:extLst xmlns:a="http://schemas.openxmlformats.org/drawingml/2006/main">
               <a:ext uri="{FF2B5EF4-FFF2-40B4-BE49-F238E27FC236}">
-                <a16:creationId xmlns:a16="http://schemas.microsoft.com/office/drawing/2014/main" id="{D229E5E1-6D1D-403A-9DFA-5E7594B4C4C4}"/>
+                <a16:creationId xmlns:a16="http://schemas.microsoft.com/office/drawing/2014/main" id="{0A51D4DE-8B7B-4E0F-B852-27FB69B4A677}"/>
               </a:ext>
             </a:extLst>
           </p:cNvPr>
@@ -12878,7 +12878,7 @@
           <p:cNvPr id="8" name="">
             <a:extLst xmlns:a="http://schemas.openxmlformats.org/drawingml/2006/main">
               <a:ext uri="{FF2B5EF4-FFF2-40B4-BE49-F238E27FC236}">
-                <a16:creationId xmlns:a16="http://schemas.microsoft.com/office/drawing/2014/main" id="{5907C686-347C-4402-A8D6-D7C20259C9F5}"/>
+                <a16:creationId xmlns:a16="http://schemas.microsoft.com/office/drawing/2014/main" id="{7D508F39-57B7-4840-8F5C-3E7FD537AC03}"/>
               </a:ext>
             </a:extLst>
           </p:cNvPr>
@@ -13037,7 +13037,7 @@
           <p:cNvPr id="9" name="">
             <a:extLst xmlns:a="http://schemas.openxmlformats.org/drawingml/2006/main">
               <a:ext uri="{FF2B5EF4-FFF2-40B4-BE49-F238E27FC236}">
-                <a16:creationId xmlns:a16="http://schemas.microsoft.com/office/drawing/2014/main" id="{019C1FBA-8268-4713-8560-233034C8AA6C}"/>
+                <a16:creationId xmlns:a16="http://schemas.microsoft.com/office/drawing/2014/main" id="{ADF762E7-A6E6-4B4B-B5ED-DBF28E603E76}"/>
               </a:ext>
             </a:extLst>
           </p:cNvPr>
@@ -13194,7 +13194,7 @@
           <p:cNvPr id="10" name="">
             <a:extLst xmlns:a="http://schemas.openxmlformats.org/drawingml/2006/main">
               <a:ext uri="{FF2B5EF4-FFF2-40B4-BE49-F238E27FC236}">
-                <a16:creationId xmlns:a16="http://schemas.microsoft.com/office/drawing/2014/main" id="{63AB9534-8110-4579-BA8E-0A2EADB95525}"/>
+                <a16:creationId xmlns:a16="http://schemas.microsoft.com/office/drawing/2014/main" id="{935D3D70-9A3D-4053-8A3D-0DBD1498FDF2}"/>
               </a:ext>
             </a:extLst>
           </p:cNvPr>
@@ -13351,7 +13351,7 @@
           <p:cNvPr id="11" name="">
             <a:extLst xmlns:a="http://schemas.openxmlformats.org/drawingml/2006/main">
               <a:ext uri="{FF2B5EF4-FFF2-40B4-BE49-F238E27FC236}">
-                <a16:creationId xmlns:a16="http://schemas.microsoft.com/office/drawing/2014/main" id="{DF99972B-7043-4280-8A9D-E9D278ABE2E9}"/>
+                <a16:creationId xmlns:a16="http://schemas.microsoft.com/office/drawing/2014/main" id="{D29F66E5-2C0B-4F5E-99F6-98C46B7DA47A}"/>
               </a:ext>
             </a:extLst>
           </p:cNvPr>
@@ -13510,7 +13510,7 @@
           <p:cNvPr id="12" name="">
             <a:extLst xmlns:a="http://schemas.openxmlformats.org/drawingml/2006/main">
               <a:ext uri="{FF2B5EF4-FFF2-40B4-BE49-F238E27FC236}">
-                <a16:creationId xmlns:a16="http://schemas.microsoft.com/office/drawing/2014/main" id="{1D36BF8F-367C-4CD2-AB79-D6A647B75462}"/>
+                <a16:creationId xmlns:a16="http://schemas.microsoft.com/office/drawing/2014/main" id="{996F9C36-8DAE-44F8-9323-29E471A97D4A}"/>
               </a:ext>
             </a:extLst>
           </p:cNvPr>
@@ -13667,7 +13667,7 @@
           <p:cNvPr id="13" name="">
             <a:extLst xmlns:a="http://schemas.openxmlformats.org/drawingml/2006/main">
               <a:ext uri="{FF2B5EF4-FFF2-40B4-BE49-F238E27FC236}">
-                <a16:creationId xmlns:a16="http://schemas.microsoft.com/office/drawing/2014/main" id="{D42DEDAB-A1C1-41B5-9FA0-0A588B1AE9D6}"/>
+                <a16:creationId xmlns:a16="http://schemas.microsoft.com/office/drawing/2014/main" id="{A25307DC-1787-45F8-A082-41F069AAD8C9}"/>
               </a:ext>
             </a:extLst>
           </p:cNvPr>
@@ -13824,7 +13824,7 @@
           <p:cNvPr id="14" name="">
             <a:extLst xmlns:a="http://schemas.openxmlformats.org/drawingml/2006/main">
               <a:ext uri="{FF2B5EF4-FFF2-40B4-BE49-F238E27FC236}">
-                <a16:creationId xmlns:a16="http://schemas.microsoft.com/office/drawing/2014/main" id="{5607C5A6-0AB6-489E-A4F5-0C5E143B28E0}"/>
+                <a16:creationId xmlns:a16="http://schemas.microsoft.com/office/drawing/2014/main" id="{B48F5FD7-08C2-4156-8882-759AFF699E29}"/>
               </a:ext>
             </a:extLst>
           </p:cNvPr>
@@ -13983,7 +13983,7 @@
           <p:cNvPr id="15" name="">
             <a:extLst xmlns:a="http://schemas.openxmlformats.org/drawingml/2006/main">
               <a:ext uri="{FF2B5EF4-FFF2-40B4-BE49-F238E27FC236}">
-                <a16:creationId xmlns:a16="http://schemas.microsoft.com/office/drawing/2014/main" id="{9D5A8370-43D0-467C-A75B-8167D2F40DAA}"/>
+                <a16:creationId xmlns:a16="http://schemas.microsoft.com/office/drawing/2014/main" id="{BC18FD73-46B3-47E2-948E-4565BFA20EAB}"/>
               </a:ext>
             </a:extLst>
           </p:cNvPr>
@@ -14140,7 +14140,7 @@
           <p:cNvPr id="16" name="">
             <a:extLst xmlns:a="http://schemas.openxmlformats.org/drawingml/2006/main">
               <a:ext uri="{FF2B5EF4-FFF2-40B4-BE49-F238E27FC236}">
-                <a16:creationId xmlns:a16="http://schemas.microsoft.com/office/drawing/2014/main" id="{EA2568AD-41A4-40ED-BA25-6702D0F969CB}"/>
+                <a16:creationId xmlns:a16="http://schemas.microsoft.com/office/drawing/2014/main" id="{A2A2DB69-A2B0-4A50-BC1B-9E794B71F414}"/>
               </a:ext>
             </a:extLst>
           </p:cNvPr>
@@ -14297,7 +14297,7 @@
           <p:cNvPr id="17" name="">
             <a:extLst xmlns:a="http://schemas.openxmlformats.org/drawingml/2006/main">
               <a:ext uri="{FF2B5EF4-FFF2-40B4-BE49-F238E27FC236}">
-                <a16:creationId xmlns:a16="http://schemas.microsoft.com/office/drawing/2014/main" id="{03454410-603D-4458-86CA-8A57AAFB5CF5}"/>
+                <a16:creationId xmlns:a16="http://schemas.microsoft.com/office/drawing/2014/main" id="{CAA8EAC3-086B-4045-8CB5-32A210FA1EEB}"/>
               </a:ext>
             </a:extLst>
           </p:cNvPr>
@@ -14456,7 +14456,7 @@
           <p:cNvPr id="18" name="">
             <a:extLst xmlns:a="http://schemas.openxmlformats.org/drawingml/2006/main">
               <a:ext uri="{FF2B5EF4-FFF2-40B4-BE49-F238E27FC236}">
-                <a16:creationId xmlns:a16="http://schemas.microsoft.com/office/drawing/2014/main" id="{9706C29E-4A3C-4B0D-83B9-2321F6376D54}"/>
+                <a16:creationId xmlns:a16="http://schemas.microsoft.com/office/drawing/2014/main" id="{5D61F916-F972-4B5F-9A2D-63E13D900980}"/>
               </a:ext>
             </a:extLst>
           </p:cNvPr>
@@ -14613,7 +14613,7 @@
           <p:cNvPr id="19" name="">
             <a:extLst xmlns:a="http://schemas.openxmlformats.org/drawingml/2006/main">
               <a:ext uri="{FF2B5EF4-FFF2-40B4-BE49-F238E27FC236}">
-                <a16:creationId xmlns:a16="http://schemas.microsoft.com/office/drawing/2014/main" id="{7E77C23C-820D-4DA6-9D1C-412886357538}"/>
+                <a16:creationId xmlns:a16="http://schemas.microsoft.com/office/drawing/2014/main" id="{3986A056-BFBC-45A7-87A1-D5200DE8E8F7}"/>
               </a:ext>
             </a:extLst>
           </p:cNvPr>
@@ -14770,7 +14770,7 @@
           <p:cNvPr id="20" name="">
             <a:extLst xmlns:a="http://schemas.openxmlformats.org/drawingml/2006/main">
               <a:ext uri="{FF2B5EF4-FFF2-40B4-BE49-F238E27FC236}">
-                <a16:creationId xmlns:a16="http://schemas.microsoft.com/office/drawing/2014/main" id="{06ED62F7-55C9-4683-A3DF-C15D5DAF222E}"/>
+                <a16:creationId xmlns:a16="http://schemas.microsoft.com/office/drawing/2014/main" id="{41C68B8B-1FC2-4878-9F5D-3B985F64D963}"/>
               </a:ext>
             </a:extLst>
           </p:cNvPr>
@@ -14929,7 +14929,7 @@
           <p:cNvPr id="21" name="">
             <a:extLst xmlns:a="http://schemas.openxmlformats.org/drawingml/2006/main">
               <a:ext uri="{FF2B5EF4-FFF2-40B4-BE49-F238E27FC236}">
-                <a16:creationId xmlns:a16="http://schemas.microsoft.com/office/drawing/2014/main" id="{D748C391-0697-447B-8DD2-FEBFB70076C5}"/>
+                <a16:creationId xmlns:a16="http://schemas.microsoft.com/office/drawing/2014/main" id="{D9BCE3F1-6463-4309-BBAA-0E534B52AA05}"/>
               </a:ext>
             </a:extLst>
           </p:cNvPr>
@@ -15086,7 +15086,7 @@
           <p:cNvPr id="22" name="">
             <a:extLst xmlns:a="http://schemas.openxmlformats.org/drawingml/2006/main">
               <a:ext uri="{FF2B5EF4-FFF2-40B4-BE49-F238E27FC236}">
-                <a16:creationId xmlns:a16="http://schemas.microsoft.com/office/drawing/2014/main" id="{850F1AEC-7804-4958-8D5C-2B4D81892092}"/>
+                <a16:creationId xmlns:a16="http://schemas.microsoft.com/office/drawing/2014/main" id="{3BE57BE7-3DE3-4286-9A37-F4DE65808FD8}"/>
               </a:ext>
             </a:extLst>
           </p:cNvPr>
@@ -15243,7 +15243,7 @@
           <p:cNvPr id="23" name="">
             <a:extLst xmlns:a="http://schemas.openxmlformats.org/drawingml/2006/main">
               <a:ext uri="{FF2B5EF4-FFF2-40B4-BE49-F238E27FC236}">
-                <a16:creationId xmlns:a16="http://schemas.microsoft.com/office/drawing/2014/main" id="{841EE95C-CCFE-4A64-8634-2BC467681633}"/>
+                <a16:creationId xmlns:a16="http://schemas.microsoft.com/office/drawing/2014/main" id="{A9E114C5-A165-47A5-99C3-97659812D866}"/>
               </a:ext>
             </a:extLst>
           </p:cNvPr>
@@ -15402,7 +15402,7 @@
           <p:cNvPr id="24" name="">
             <a:extLst xmlns:a="http://schemas.openxmlformats.org/drawingml/2006/main">
               <a:ext uri="{FF2B5EF4-FFF2-40B4-BE49-F238E27FC236}">
-                <a16:creationId xmlns:a16="http://schemas.microsoft.com/office/drawing/2014/main" id="{16742FAF-9DCF-43D3-946B-02C94CD0DBEE}"/>
+                <a16:creationId xmlns:a16="http://schemas.microsoft.com/office/drawing/2014/main" id="{85EFB2DA-3032-4EBD-B2E1-51C0B7589BE6}"/>
               </a:ext>
             </a:extLst>
           </p:cNvPr>
@@ -15559,7 +15559,7 @@
           <p:cNvPr id="25" name="">
             <a:extLst xmlns:a="http://schemas.openxmlformats.org/drawingml/2006/main">
               <a:ext uri="{FF2B5EF4-FFF2-40B4-BE49-F238E27FC236}">
-                <a16:creationId xmlns:a16="http://schemas.microsoft.com/office/drawing/2014/main" id="{F3608DA6-6DA6-4644-80EC-A760A3C26509}"/>
+                <a16:creationId xmlns:a16="http://schemas.microsoft.com/office/drawing/2014/main" id="{380BFACC-C734-4D76-B99C-9D6DD6E73ACE}"/>
               </a:ext>
             </a:extLst>
           </p:cNvPr>
@@ -15716,7 +15716,7 @@
           <p:cNvPr id="26" name="">
             <a:extLst xmlns:a="http://schemas.openxmlformats.org/drawingml/2006/main">
               <a:ext uri="{FF2B5EF4-FFF2-40B4-BE49-F238E27FC236}">
-                <a16:creationId xmlns:a16="http://schemas.microsoft.com/office/drawing/2014/main" id="{A9046E93-4409-4D68-8AC0-6DD0B9E99205}"/>
+                <a16:creationId xmlns:a16="http://schemas.microsoft.com/office/drawing/2014/main" id="{77C0C723-5A35-4757-BA08-DD9A38D0D32A}"/>
               </a:ext>
             </a:extLst>
           </p:cNvPr>
@@ -15756,7 +15756,7 @@
           <p:cNvPr id="27" name="">
             <a:extLst xmlns:a="http://schemas.openxmlformats.org/drawingml/2006/main">
               <a:ext uri="{FF2B5EF4-FFF2-40B4-BE49-F238E27FC236}">
-                <a16:creationId xmlns:a16="http://schemas.microsoft.com/office/drawing/2014/main" id="{86F777B4-D950-4E70-8B38-C5575406A886}"/>
+                <a16:creationId xmlns:a16="http://schemas.microsoft.com/office/drawing/2014/main" id="{662F0606-1B69-480C-9786-5B82C57AAE6A}"/>
               </a:ext>
             </a:extLst>
           </p:cNvPr>
@@ -15913,7 +15913,7 @@
           <p:cNvPr id="28" name="">
             <a:extLst xmlns:a="http://schemas.openxmlformats.org/drawingml/2006/main">
               <a:ext uri="{FF2B5EF4-FFF2-40B4-BE49-F238E27FC236}">
-                <a16:creationId xmlns:a16="http://schemas.microsoft.com/office/drawing/2014/main" id="{CBFD3710-60E1-4223-A647-C8A7367A5CA0}"/>
+                <a16:creationId xmlns:a16="http://schemas.microsoft.com/office/drawing/2014/main" id="{0FF016EB-4666-44C3-B2B7-0B7995CE9A54}"/>
               </a:ext>
             </a:extLst>
           </p:cNvPr>
@@ -16070,7 +16070,7 @@
           <p:cNvPr id="29" name="">
             <a:extLst xmlns:a="http://schemas.openxmlformats.org/drawingml/2006/main">
               <a:ext uri="{FF2B5EF4-FFF2-40B4-BE49-F238E27FC236}">
-                <a16:creationId xmlns:a16="http://schemas.microsoft.com/office/drawing/2014/main" id="{7212656A-4D58-446C-9A3C-05754B7E858A}"/>
+                <a16:creationId xmlns:a16="http://schemas.microsoft.com/office/drawing/2014/main" id="{CD94194F-94BC-49F0-B843-1245FE4F3BA7}"/>
               </a:ext>
             </a:extLst>
           </p:cNvPr>
@@ -16101,7 +16101,7 @@
           <p:cNvPr id="30" name="">
             <a:extLst xmlns:a="http://schemas.openxmlformats.org/drawingml/2006/main">
               <a:ext uri="{FF2B5EF4-FFF2-40B4-BE49-F238E27FC236}">
-                <a16:creationId xmlns:a16="http://schemas.microsoft.com/office/drawing/2014/main" id="{1AA9BC36-8A2F-407C-9F28-085BF6587865}"/>
+                <a16:creationId xmlns:a16="http://schemas.microsoft.com/office/drawing/2014/main" id="{2CE8DD7D-FD65-4B1C-A100-0564A76EF818}"/>
               </a:ext>
             </a:extLst>
           </p:cNvPr>
@@ -16258,7 +16258,7 @@
           <p:cNvPr id="31" name="">
             <a:extLst xmlns:a="http://schemas.openxmlformats.org/drawingml/2006/main">
               <a:ext uri="{FF2B5EF4-FFF2-40B4-BE49-F238E27FC236}">
-                <a16:creationId xmlns:a16="http://schemas.microsoft.com/office/drawing/2014/main" id="{BA581240-3875-4E4C-8D12-3127140EC908}"/>
+                <a16:creationId xmlns:a16="http://schemas.microsoft.com/office/drawing/2014/main" id="{18A85340-173F-43B4-8DCD-8F9BA1137CC9}"/>
               </a:ext>
             </a:extLst>
           </p:cNvPr>
@@ -16413,7 +16413,7 @@
     </p:spTree>
     <p:extLst>
       <p:ext uri="{BB962C8B-B14F-4D97-AF65-F5344CB8AC3E}">
-        <p14:creationId xmlns:p14="http://schemas.microsoft.com/office/powerpoint/2010/main" val="1792348054"/>
+        <p14:creationId xmlns:p14="http://schemas.microsoft.com/office/powerpoint/2010/main" val="1660286004"/>
       </p:ext>
     </p:extLst>
   </p:cSld>
@@ -16444,7 +16444,7 @@
           <p:cNvPr id="22" name="">
             <a:extLst xmlns:a="http://schemas.openxmlformats.org/drawingml/2006/main">
               <a:ext uri="{FF2B5EF4-FFF2-40B4-BE49-F238E27FC236}">
-                <a16:creationId xmlns:a16="http://schemas.microsoft.com/office/drawing/2014/main" id="{BDA8161F-4763-41F9-9C0D-965DA36D87B0}"/>
+                <a16:creationId xmlns:a16="http://schemas.microsoft.com/office/drawing/2014/main" id="{65F800E0-4425-4C9C-A76F-78DCA92346E3}"/>
               </a:ext>
             </a:extLst>
           </p:cNvPr>
@@ -16601,7 +16601,7 @@
           <p:cNvPr id="2" name="">
             <a:extLst xmlns:a="http://schemas.openxmlformats.org/drawingml/2006/main">
               <a:ext uri="{FF2B5EF4-FFF2-40B4-BE49-F238E27FC236}">
-                <a16:creationId xmlns:a16="http://schemas.microsoft.com/office/drawing/2014/main" id="{DAA428D1-5D07-4737-BEB8-AC2EFAAB13D2}"/>
+                <a16:creationId xmlns:a16="http://schemas.microsoft.com/office/drawing/2014/main" id="{5FC872AB-1290-4D42-A03B-4C573FDB9C81}"/>
               </a:ext>
             </a:extLst>
           </p:cNvPr>
@@ -16632,7 +16632,7 @@
           <p:cNvPr id="3" name="">
             <a:extLst xmlns:a="http://schemas.openxmlformats.org/drawingml/2006/main">
               <a:ext uri="{FF2B5EF4-FFF2-40B4-BE49-F238E27FC236}">
-                <a16:creationId xmlns:a16="http://schemas.microsoft.com/office/drawing/2014/main" id="{26B591E7-874B-4CC0-A37D-E01E1BB6B88D}"/>
+                <a16:creationId xmlns:a16="http://schemas.microsoft.com/office/drawing/2014/main" id="{7272594A-9FB7-4192-A8A9-A4BD65D883E3}"/>
               </a:ext>
             </a:extLst>
           </p:cNvPr>
@@ -16789,7 +16789,7 @@
           <p:cNvPr id="4" name="">
             <a:extLst xmlns:a="http://schemas.openxmlformats.org/drawingml/2006/main">
               <a:ext uri="{FF2B5EF4-FFF2-40B4-BE49-F238E27FC236}">
-                <a16:creationId xmlns:a16="http://schemas.microsoft.com/office/drawing/2014/main" id="{4577914D-DF0E-49D7-BD2F-4CEC21C3D8F1}"/>
+                <a16:creationId xmlns:a16="http://schemas.microsoft.com/office/drawing/2014/main" id="{327FA98F-3EC2-40A2-8AE2-3AE981D85F8A}"/>
               </a:ext>
             </a:extLst>
           </p:cNvPr>
@@ -16946,7 +16946,7 @@
           <p:cNvPr id="5" name="">
             <a:extLst xmlns:a="http://schemas.openxmlformats.org/drawingml/2006/main">
               <a:ext uri="{FF2B5EF4-FFF2-40B4-BE49-F238E27FC236}">
-                <a16:creationId xmlns:a16="http://schemas.microsoft.com/office/drawing/2014/main" id="{175D068C-217E-4AAB-A4F8-23B2CD2D7C7E}"/>
+                <a16:creationId xmlns:a16="http://schemas.microsoft.com/office/drawing/2014/main" id="{3D39FC62-598E-4FB8-992C-2DF125687362}"/>
               </a:ext>
             </a:extLst>
           </p:cNvPr>
@@ -17103,7 +17103,7 @@
           <p:cNvPr id="6" name="">
             <a:extLst xmlns:a="http://schemas.openxmlformats.org/drawingml/2006/main">
               <a:ext uri="{FF2B5EF4-FFF2-40B4-BE49-F238E27FC236}">
-                <a16:creationId xmlns:a16="http://schemas.microsoft.com/office/drawing/2014/main" id="{113C92E4-F62C-4A77-8476-A40B85A36C67}"/>
+                <a16:creationId xmlns:a16="http://schemas.microsoft.com/office/drawing/2014/main" id="{C83DC847-F53D-4FC7-93D2-9CAA0CD5D9EB}"/>
               </a:ext>
             </a:extLst>
           </p:cNvPr>
@@ -18194,7 +18194,7 @@
           <p:cNvPr id="7" name="">
             <a:extLst xmlns:a="http://schemas.openxmlformats.org/drawingml/2006/main">
               <a:ext uri="{FF2B5EF4-FFF2-40B4-BE49-F238E27FC236}">
-                <a16:creationId xmlns:a16="http://schemas.microsoft.com/office/drawing/2014/main" id="{4BA66AC4-093A-4DB0-94B8-EB214F1E2C33}"/>
+                <a16:creationId xmlns:a16="http://schemas.microsoft.com/office/drawing/2014/main" id="{1C10BA0A-D698-447D-AD8B-A25181242719}"/>
               </a:ext>
             </a:extLst>
           </p:cNvPr>
@@ -18351,7 +18351,7 @@
           <p:cNvPr id="8" name="">
             <a:extLst xmlns:a="http://schemas.openxmlformats.org/drawingml/2006/main">
               <a:ext uri="{FF2B5EF4-FFF2-40B4-BE49-F238E27FC236}">
-                <a16:creationId xmlns:a16="http://schemas.microsoft.com/office/drawing/2014/main" id="{84EFABA6-EEBE-4CFF-A7EF-79E14BEDB0D0}"/>
+                <a16:creationId xmlns:a16="http://schemas.microsoft.com/office/drawing/2014/main" id="{2B3E64BC-370E-4548-A677-2E011E6AA0D5}"/>
               </a:ext>
             </a:extLst>
           </p:cNvPr>
@@ -18508,7 +18508,7 @@
           <p:cNvPr id="9" name="">
             <a:extLst xmlns:a="http://schemas.openxmlformats.org/drawingml/2006/main">
               <a:ext uri="{FF2B5EF4-FFF2-40B4-BE49-F238E27FC236}">
-                <a16:creationId xmlns:a16="http://schemas.microsoft.com/office/drawing/2014/main" id="{EB882EF7-EFC3-4B8C-AACA-713F5839B78A}"/>
+                <a16:creationId xmlns:a16="http://schemas.microsoft.com/office/drawing/2014/main" id="{4C66CD61-BD4D-4762-A5F4-47C39BC95F82}"/>
               </a:ext>
             </a:extLst>
           </p:cNvPr>
@@ -18688,7 +18688,7 @@
           <p:cNvPr id="10" name="">
             <a:extLst xmlns:a="http://schemas.openxmlformats.org/drawingml/2006/main">
               <a:ext uri="{FF2B5EF4-FFF2-40B4-BE49-F238E27FC236}">
-                <a16:creationId xmlns:a16="http://schemas.microsoft.com/office/drawing/2014/main" id="{3CB9F0C1-30CD-4901-872F-0524E546D964}"/>
+                <a16:creationId xmlns:a16="http://schemas.microsoft.com/office/drawing/2014/main" id="{E6167643-DED4-4A4F-B681-70D47EFADBBA}"/>
               </a:ext>
             </a:extLst>
           </p:cNvPr>
@@ -18719,7 +18719,7 @@
           <p:cNvPr id="11" name="">
             <a:extLst xmlns:a="http://schemas.openxmlformats.org/drawingml/2006/main">
               <a:ext uri="{FF2B5EF4-FFF2-40B4-BE49-F238E27FC236}">
-                <a16:creationId xmlns:a16="http://schemas.microsoft.com/office/drawing/2014/main" id="{A97BD063-40CA-422C-81AB-3E019B1AD483}"/>
+                <a16:creationId xmlns:a16="http://schemas.microsoft.com/office/drawing/2014/main" id="{5FA3202E-5ADA-410A-86C3-0FC2EECC1625}"/>
               </a:ext>
             </a:extLst>
           </p:cNvPr>
@@ -18876,7 +18876,7 @@
           <p:cNvPr id="12" name="">
             <a:extLst xmlns:a="http://schemas.openxmlformats.org/drawingml/2006/main">
               <a:ext uri="{FF2B5EF4-FFF2-40B4-BE49-F238E27FC236}">
-                <a16:creationId xmlns:a16="http://schemas.microsoft.com/office/drawing/2014/main" id="{20E528B4-619F-4E1E-B263-FDA7DE8A7081}"/>
+                <a16:creationId xmlns:a16="http://schemas.microsoft.com/office/drawing/2014/main" id="{7B0E2842-6301-4AF8-8C06-6DC8A328BD7E}"/>
               </a:ext>
             </a:extLst>
           </p:cNvPr>
@@ -19033,7 +19033,7 @@
           <p:cNvPr id="13" name="">
             <a:extLst xmlns:a="http://schemas.openxmlformats.org/drawingml/2006/main">
               <a:ext uri="{FF2B5EF4-FFF2-40B4-BE49-F238E27FC236}">
-                <a16:creationId xmlns:a16="http://schemas.microsoft.com/office/drawing/2014/main" id="{CDA48A77-B19C-4DC3-BFD7-EB2989DE7526}"/>
+                <a16:creationId xmlns:a16="http://schemas.microsoft.com/office/drawing/2014/main" id="{5628E260-7AE1-47E5-9FC8-07EA36712E3A}"/>
               </a:ext>
             </a:extLst>
           </p:cNvPr>
@@ -19190,7 +19190,7 @@
           <p:cNvPr id="14" name="">
             <a:extLst xmlns:a="http://schemas.openxmlformats.org/drawingml/2006/main">
               <a:ext uri="{FF2B5EF4-FFF2-40B4-BE49-F238E27FC236}">
-                <a16:creationId xmlns:a16="http://schemas.microsoft.com/office/drawing/2014/main" id="{749B21CC-DB6D-4A80-92B3-CDA1BBE75B95}"/>
+                <a16:creationId xmlns:a16="http://schemas.microsoft.com/office/drawing/2014/main" id="{1183CFD6-801C-49B3-9D0B-69C80C5E3C40}"/>
               </a:ext>
             </a:extLst>
           </p:cNvPr>
@@ -19347,7 +19347,7 @@
           <p:cNvPr id="15" name="">
             <a:extLst xmlns:a="http://schemas.openxmlformats.org/drawingml/2006/main">
               <a:ext uri="{FF2B5EF4-FFF2-40B4-BE49-F238E27FC236}">
-                <a16:creationId xmlns:a16="http://schemas.microsoft.com/office/drawing/2014/main" id="{B483EF00-EBDB-4E7F-B803-B3C62025425C}"/>
+                <a16:creationId xmlns:a16="http://schemas.microsoft.com/office/drawing/2014/main" id="{DC3D0D80-7A20-4B83-8E29-154EB287EA53}"/>
               </a:ext>
             </a:extLst>
           </p:cNvPr>
@@ -19504,7 +19504,7 @@
           <p:cNvPr id="16" name="">
             <a:extLst xmlns:a="http://schemas.openxmlformats.org/drawingml/2006/main">
               <a:ext uri="{FF2B5EF4-FFF2-40B4-BE49-F238E27FC236}">
-                <a16:creationId xmlns:a16="http://schemas.microsoft.com/office/drawing/2014/main" id="{DFC7A45B-5F52-435E-B444-FC1F56732664}"/>
+                <a16:creationId xmlns:a16="http://schemas.microsoft.com/office/drawing/2014/main" id="{0A6611FD-B531-43E8-81FC-51AD73FB5FA8}"/>
               </a:ext>
             </a:extLst>
           </p:cNvPr>
@@ -19661,7 +19661,7 @@
           <p:cNvPr id="17" name="">
             <a:extLst xmlns:a="http://schemas.openxmlformats.org/drawingml/2006/main">
               <a:ext uri="{FF2B5EF4-FFF2-40B4-BE49-F238E27FC236}">
-                <a16:creationId xmlns:a16="http://schemas.microsoft.com/office/drawing/2014/main" id="{5BFFCCC1-4099-4E66-B939-7FA57ACD878A}"/>
+                <a16:creationId xmlns:a16="http://schemas.microsoft.com/office/drawing/2014/main" id="{F7DDF2B3-811C-43EE-91DA-3586F4B831C1}"/>
               </a:ext>
             </a:extLst>
           </p:cNvPr>
@@ -19818,7 +19818,7 @@
           <p:cNvPr id="18" name="">
             <a:extLst xmlns:a="http://schemas.openxmlformats.org/drawingml/2006/main">
               <a:ext uri="{FF2B5EF4-FFF2-40B4-BE49-F238E27FC236}">
-                <a16:creationId xmlns:a16="http://schemas.microsoft.com/office/drawing/2014/main" id="{E17DDC17-ACAB-4F36-8DBB-293B71974DAA}"/>
+                <a16:creationId xmlns:a16="http://schemas.microsoft.com/office/drawing/2014/main" id="{C8B9CB66-05AE-403F-970F-33B2E51BD00F}"/>
               </a:ext>
             </a:extLst>
           </p:cNvPr>
@@ -19975,7 +19975,7 @@
           <p:cNvPr id="19" name="">
             <a:extLst xmlns:a="http://schemas.openxmlformats.org/drawingml/2006/main">
               <a:ext uri="{FF2B5EF4-FFF2-40B4-BE49-F238E27FC236}">
-                <a16:creationId xmlns:a16="http://schemas.microsoft.com/office/drawing/2014/main" id="{7BF9081F-7C31-43A2-AE03-28A73DBD33F3}"/>
+                <a16:creationId xmlns:a16="http://schemas.microsoft.com/office/drawing/2014/main" id="{B44DFE7F-D346-46FD-A3D2-DCDFB3DD1194}"/>
               </a:ext>
             </a:extLst>
           </p:cNvPr>
@@ -20132,7 +20132,7 @@
           <p:cNvPr id="20" name="">
             <a:extLst xmlns:a="http://schemas.openxmlformats.org/drawingml/2006/main">
               <a:ext uri="{FF2B5EF4-FFF2-40B4-BE49-F238E27FC236}">
-                <a16:creationId xmlns:a16="http://schemas.microsoft.com/office/drawing/2014/main" id="{26E77AD8-AD49-4B49-9014-752232DB4A93}"/>
+                <a16:creationId xmlns:a16="http://schemas.microsoft.com/office/drawing/2014/main" id="{5DB8F179-15DE-4F3A-97A7-D64E954DA8F1}"/>
               </a:ext>
             </a:extLst>
           </p:cNvPr>
@@ -20312,7 +20312,7 @@
           <p:cNvPr id="21" name="">
             <a:extLst xmlns:a="http://schemas.openxmlformats.org/drawingml/2006/main">
               <a:ext uri="{FF2B5EF4-FFF2-40B4-BE49-F238E27FC236}">
-                <a16:creationId xmlns:a16="http://schemas.microsoft.com/office/drawing/2014/main" id="{88146670-87C2-4774-AB5D-AE5ABC8270F7}"/>
+                <a16:creationId xmlns:a16="http://schemas.microsoft.com/office/drawing/2014/main" id="{BCF21C97-EE75-43EA-8FA0-1B4E81406455}"/>
               </a:ext>
             </a:extLst>
           </p:cNvPr>
@@ -20467,7 +20467,7 @@
     </p:spTree>
     <p:extLst>
       <p:ext uri="{BB962C8B-B14F-4D97-AF65-F5344CB8AC3E}">
-        <p14:creationId xmlns:p14="http://schemas.microsoft.com/office/powerpoint/2010/main" val="30432809"/>
+        <p14:creationId xmlns:p14="http://schemas.microsoft.com/office/powerpoint/2010/main" val="1320248957"/>
       </p:ext>
     </p:extLst>
   </p:cSld>
@@ -20498,7 +20498,7 @@
           <p:cNvPr id="27" name="">
             <a:extLst xmlns:a="http://schemas.openxmlformats.org/drawingml/2006/main">
               <a:ext uri="{FF2B5EF4-FFF2-40B4-BE49-F238E27FC236}">
-                <a16:creationId xmlns:a16="http://schemas.microsoft.com/office/drawing/2014/main" id="{B04A3788-E044-4312-8B1D-944309BF6435}"/>
+                <a16:creationId xmlns:a16="http://schemas.microsoft.com/office/drawing/2014/main" id="{7C74FC92-9479-4087-9816-42487C498B33}"/>
               </a:ext>
             </a:extLst>
           </p:cNvPr>
@@ -20655,7 +20655,7 @@
           <p:cNvPr id="2" name="">
             <a:extLst xmlns:a="http://schemas.openxmlformats.org/drawingml/2006/main">
               <a:ext uri="{FF2B5EF4-FFF2-40B4-BE49-F238E27FC236}">
-                <a16:creationId xmlns:a16="http://schemas.microsoft.com/office/drawing/2014/main" id="{D05400B8-1907-485A-925A-3755763A11B5}"/>
+                <a16:creationId xmlns:a16="http://schemas.microsoft.com/office/drawing/2014/main" id="{F0ACA338-3C7E-4DE4-AC8B-082E6EBFA26A}"/>
               </a:ext>
             </a:extLst>
           </p:cNvPr>
@@ -20686,7 +20686,7 @@
           <p:cNvPr id="3" name="">
             <a:extLst xmlns:a="http://schemas.openxmlformats.org/drawingml/2006/main">
               <a:ext uri="{FF2B5EF4-FFF2-40B4-BE49-F238E27FC236}">
-                <a16:creationId xmlns:a16="http://schemas.microsoft.com/office/drawing/2014/main" id="{DB14AE05-03AC-4B93-99E9-EF47CBF2E769}"/>
+                <a16:creationId xmlns:a16="http://schemas.microsoft.com/office/drawing/2014/main" id="{E695AB94-20EC-490D-AAE7-B8B20961796C}"/>
               </a:ext>
             </a:extLst>
           </p:cNvPr>
@@ -20843,7 +20843,7 @@
           <p:cNvPr id="4" name="">
             <a:extLst xmlns:a="http://schemas.openxmlformats.org/drawingml/2006/main">
               <a:ext uri="{FF2B5EF4-FFF2-40B4-BE49-F238E27FC236}">
-                <a16:creationId xmlns:a16="http://schemas.microsoft.com/office/drawing/2014/main" id="{95F7DE60-5CD6-496C-93FF-D881B2E2D69B}"/>
+                <a16:creationId xmlns:a16="http://schemas.microsoft.com/office/drawing/2014/main" id="{E68FA4B3-FF52-45CB-86AA-F94291F7E3AE}"/>
               </a:ext>
             </a:extLst>
           </p:cNvPr>
@@ -21000,7 +21000,7 @@
           <p:cNvPr id="5" name="">
             <a:extLst xmlns:a="http://schemas.openxmlformats.org/drawingml/2006/main">
               <a:ext uri="{FF2B5EF4-FFF2-40B4-BE49-F238E27FC236}">
-                <a16:creationId xmlns:a16="http://schemas.microsoft.com/office/drawing/2014/main" id="{3527585F-4CC3-462E-A02B-BB85D06B4027}"/>
+                <a16:creationId xmlns:a16="http://schemas.microsoft.com/office/drawing/2014/main" id="{D1FD62D9-F765-4B9E-A8B0-80F749FD7D29}"/>
               </a:ext>
             </a:extLst>
           </p:cNvPr>
@@ -21157,7 +21157,7 @@
           <p:cNvPr id="6" name="">
             <a:extLst xmlns:a="http://schemas.openxmlformats.org/drawingml/2006/main">
               <a:ext uri="{FF2B5EF4-FFF2-40B4-BE49-F238E27FC236}">
-                <a16:creationId xmlns:a16="http://schemas.microsoft.com/office/drawing/2014/main" id="{C7A07FF2-97B6-468B-B236-B005001D5951}"/>
+                <a16:creationId xmlns:a16="http://schemas.microsoft.com/office/drawing/2014/main" id="{6269CB20-74C6-4118-A226-E58E22F27635}"/>
               </a:ext>
             </a:extLst>
           </p:cNvPr>
@@ -21314,7 +21314,7 @@
           <p:cNvPr id="7" name="">
             <a:extLst xmlns:a="http://schemas.openxmlformats.org/drawingml/2006/main">
               <a:ext uri="{FF2B5EF4-FFF2-40B4-BE49-F238E27FC236}">
-                <a16:creationId xmlns:a16="http://schemas.microsoft.com/office/drawing/2014/main" id="{96482242-DB53-4EDC-88AD-2E5679DECE78}"/>
+                <a16:creationId xmlns:a16="http://schemas.microsoft.com/office/drawing/2014/main" id="{32F39B53-66D3-407C-8A8D-8AE3CA50828D}"/>
               </a:ext>
             </a:extLst>
           </p:cNvPr>
@@ -21471,7 +21471,7 @@
           <p:cNvPr id="8" name="">
             <a:extLst xmlns:a="http://schemas.openxmlformats.org/drawingml/2006/main">
               <a:ext uri="{FF2B5EF4-FFF2-40B4-BE49-F238E27FC236}">
-                <a16:creationId xmlns:a16="http://schemas.microsoft.com/office/drawing/2014/main" id="{F4D4B4D8-4E51-4D49-8AED-1FCF1E0B1484}"/>
+                <a16:creationId xmlns:a16="http://schemas.microsoft.com/office/drawing/2014/main" id="{75BC4F95-0834-4AC7-B0A9-DF436551B38D}"/>
               </a:ext>
             </a:extLst>
           </p:cNvPr>
@@ -21628,7 +21628,7 @@
           <p:cNvPr id="9" name="">
             <a:extLst xmlns:a="http://schemas.openxmlformats.org/drawingml/2006/main">
               <a:ext uri="{FF2B5EF4-FFF2-40B4-BE49-F238E27FC236}">
-                <a16:creationId xmlns:a16="http://schemas.microsoft.com/office/drawing/2014/main" id="{DD2AE2D5-63F9-44C6-A53A-C5AAC19D9BEC}"/>
+                <a16:creationId xmlns:a16="http://schemas.microsoft.com/office/drawing/2014/main" id="{075DB53B-3A4E-4852-95D2-D787622A7314}"/>
               </a:ext>
             </a:extLst>
           </p:cNvPr>
@@ -21785,7 +21785,7 @@
           <p:cNvPr id="10" name="">
             <a:extLst xmlns:a="http://schemas.openxmlformats.org/drawingml/2006/main">
               <a:ext uri="{FF2B5EF4-FFF2-40B4-BE49-F238E27FC236}">
-                <a16:creationId xmlns:a16="http://schemas.microsoft.com/office/drawing/2014/main" id="{E76B72F0-0F2E-4C21-9C1C-75742B5E4FBB}"/>
+                <a16:creationId xmlns:a16="http://schemas.microsoft.com/office/drawing/2014/main" id="{70782625-2653-436C-B305-C36DF0E0BFA6}"/>
               </a:ext>
             </a:extLst>
           </p:cNvPr>
@@ -21942,7 +21942,7 @@
           <p:cNvPr id="11" name="">
             <a:extLst xmlns:a="http://schemas.openxmlformats.org/drawingml/2006/main">
               <a:ext uri="{FF2B5EF4-FFF2-40B4-BE49-F238E27FC236}">
-                <a16:creationId xmlns:a16="http://schemas.microsoft.com/office/drawing/2014/main" id="{64ACDD7E-D900-484A-BEA0-A2FB16F1ECE6}"/>
+                <a16:creationId xmlns:a16="http://schemas.microsoft.com/office/drawing/2014/main" id="{5DCF61F3-F356-48FA-95A2-EFDEBFBDAE23}"/>
               </a:ext>
             </a:extLst>
           </p:cNvPr>
@@ -22099,7 +22099,7 @@
           <p:cNvPr id="12" name="">
             <a:extLst xmlns:a="http://schemas.openxmlformats.org/drawingml/2006/main">
               <a:ext uri="{FF2B5EF4-FFF2-40B4-BE49-F238E27FC236}">
-                <a16:creationId xmlns:a16="http://schemas.microsoft.com/office/drawing/2014/main" id="{45727F32-B554-44DE-BB05-8AA1512E7BA8}"/>
+                <a16:creationId xmlns:a16="http://schemas.microsoft.com/office/drawing/2014/main" id="{211F07CA-8B9C-40CD-A73B-206223732B0C}"/>
               </a:ext>
             </a:extLst>
           </p:cNvPr>
@@ -22256,7 +22256,7 @@
           <p:cNvPr id="13" name="">
             <a:extLst xmlns:a="http://schemas.openxmlformats.org/drawingml/2006/main">
               <a:ext uri="{FF2B5EF4-FFF2-40B4-BE49-F238E27FC236}">
-                <a16:creationId xmlns:a16="http://schemas.microsoft.com/office/drawing/2014/main" id="{2C273660-0E73-4AD4-B118-B614F726FDA7}"/>
+                <a16:creationId xmlns:a16="http://schemas.microsoft.com/office/drawing/2014/main" id="{B1DFAF4F-EF75-4501-A47C-A9D865CC6189}"/>
               </a:ext>
             </a:extLst>
           </p:cNvPr>
@@ -22413,7 +22413,7 @@
           <p:cNvPr id="14" name="">
             <a:extLst xmlns:a="http://schemas.openxmlformats.org/drawingml/2006/main">
               <a:ext uri="{FF2B5EF4-FFF2-40B4-BE49-F238E27FC236}">
-                <a16:creationId xmlns:a16="http://schemas.microsoft.com/office/drawing/2014/main" id="{11519F1A-E8EE-4AB2-9F36-1D7612871E74}"/>
+                <a16:creationId xmlns:a16="http://schemas.microsoft.com/office/drawing/2014/main" id="{6CB680B9-EB80-443A-8CE9-7D1B9ED16D6A}"/>
               </a:ext>
             </a:extLst>
           </p:cNvPr>
@@ -22570,7 +22570,7 @@
           <p:cNvPr id="15" name="">
             <a:extLst xmlns:a="http://schemas.openxmlformats.org/drawingml/2006/main">
               <a:ext uri="{FF2B5EF4-FFF2-40B4-BE49-F238E27FC236}">
-                <a16:creationId xmlns:a16="http://schemas.microsoft.com/office/drawing/2014/main" id="{CEAFB939-C18B-4939-8616-3989540FBDA8}"/>
+                <a16:creationId xmlns:a16="http://schemas.microsoft.com/office/drawing/2014/main" id="{37C320AF-CF3F-4342-A9B7-D96378F2B127}"/>
               </a:ext>
             </a:extLst>
           </p:cNvPr>
@@ -22727,7 +22727,7 @@
           <p:cNvPr id="16" name="">
             <a:extLst xmlns:a="http://schemas.openxmlformats.org/drawingml/2006/main">
               <a:ext uri="{FF2B5EF4-FFF2-40B4-BE49-F238E27FC236}">
-                <a16:creationId xmlns:a16="http://schemas.microsoft.com/office/drawing/2014/main" id="{36F7E784-81C3-4BCB-AE09-DA8C635DB686}"/>
+                <a16:creationId xmlns:a16="http://schemas.microsoft.com/office/drawing/2014/main" id="{A994DA4A-4100-40E5-881C-485D3DBE2059}"/>
               </a:ext>
             </a:extLst>
           </p:cNvPr>
@@ -22884,7 +22884,7 @@
           <p:cNvPr id="17" name="">
             <a:extLst xmlns:a="http://schemas.openxmlformats.org/drawingml/2006/main">
               <a:ext uri="{FF2B5EF4-FFF2-40B4-BE49-F238E27FC236}">
-                <a16:creationId xmlns:a16="http://schemas.microsoft.com/office/drawing/2014/main" id="{571C4469-7D3D-454F-9423-B87D75142F71}"/>
+                <a16:creationId xmlns:a16="http://schemas.microsoft.com/office/drawing/2014/main" id="{378D38FC-8397-441B-884D-1F2254D87D76}"/>
               </a:ext>
             </a:extLst>
           </p:cNvPr>
@@ -23041,7 +23041,7 @@
           <p:cNvPr id="18" name="">
             <a:extLst xmlns:a="http://schemas.openxmlformats.org/drawingml/2006/main">
               <a:ext uri="{FF2B5EF4-FFF2-40B4-BE49-F238E27FC236}">
-                <a16:creationId xmlns:a16="http://schemas.microsoft.com/office/drawing/2014/main" id="{62316740-E216-4A1C-BE5E-555D3C55F689}"/>
+                <a16:creationId xmlns:a16="http://schemas.microsoft.com/office/drawing/2014/main" id="{A32E94EE-2EDA-4D93-B355-6D1D7699E9C7}"/>
               </a:ext>
             </a:extLst>
           </p:cNvPr>
@@ -23072,7 +23072,7 @@
           <p:cNvPr id="19" name="">
             <a:extLst xmlns:a="http://schemas.openxmlformats.org/drawingml/2006/main">
               <a:ext uri="{FF2B5EF4-FFF2-40B4-BE49-F238E27FC236}">
-                <a16:creationId xmlns:a16="http://schemas.microsoft.com/office/drawing/2014/main" id="{0ABFFA99-4294-44F5-8D53-21666AFABD10}"/>
+                <a16:creationId xmlns:a16="http://schemas.microsoft.com/office/drawing/2014/main" id="{796A1239-0068-4B96-8DF8-D58480DE2309}"/>
               </a:ext>
             </a:extLst>
           </p:cNvPr>
@@ -23229,7 +23229,7 @@
           <p:cNvPr id="20" name="">
             <a:extLst xmlns:a="http://schemas.openxmlformats.org/drawingml/2006/main">
               <a:ext uri="{FF2B5EF4-FFF2-40B4-BE49-F238E27FC236}">
-                <a16:creationId xmlns:a16="http://schemas.microsoft.com/office/drawing/2014/main" id="{36A6E45F-FFA2-475F-B5A2-7A73F9F54BCB}"/>
+                <a16:creationId xmlns:a16="http://schemas.microsoft.com/office/drawing/2014/main" id="{F9619865-A29B-4267-89D6-E26593A382DD}"/>
               </a:ext>
             </a:extLst>
           </p:cNvPr>
@@ -23386,7 +23386,7 @@
           <p:cNvPr id="21" name="">
             <a:extLst xmlns:a="http://schemas.openxmlformats.org/drawingml/2006/main">
               <a:ext uri="{FF2B5EF4-FFF2-40B4-BE49-F238E27FC236}">
-                <a16:creationId xmlns:a16="http://schemas.microsoft.com/office/drawing/2014/main" id="{25CEF97C-FA2E-421A-B9E6-DF4564F16F30}"/>
+                <a16:creationId xmlns:a16="http://schemas.microsoft.com/office/drawing/2014/main" id="{A074E0CA-8760-46C2-8DBD-86045DAE6965}"/>
               </a:ext>
             </a:extLst>
           </p:cNvPr>
@@ -23543,7 +23543,7 @@
           <p:cNvPr id="22" name="">
             <a:extLst xmlns:a="http://schemas.openxmlformats.org/drawingml/2006/main">
               <a:ext uri="{FF2B5EF4-FFF2-40B4-BE49-F238E27FC236}">
-                <a16:creationId xmlns:a16="http://schemas.microsoft.com/office/drawing/2014/main" id="{320E752D-2FF5-4E6D-9DDE-42F04B637387}"/>
+                <a16:creationId xmlns:a16="http://schemas.microsoft.com/office/drawing/2014/main" id="{9EBCAC46-9A80-439A-8061-4D816193AFF0}"/>
               </a:ext>
             </a:extLst>
           </p:cNvPr>
@@ -23585,7 +23585,7 @@
           <p:cNvPr id="23" name="">
             <a:extLst xmlns:a="http://schemas.openxmlformats.org/drawingml/2006/main">
               <a:ext uri="{FF2B5EF4-FFF2-40B4-BE49-F238E27FC236}">
-                <a16:creationId xmlns:a16="http://schemas.microsoft.com/office/drawing/2014/main" id="{CFA3FC78-F7A3-406C-9C6B-3D83567DD2DC}"/>
+                <a16:creationId xmlns:a16="http://schemas.microsoft.com/office/drawing/2014/main" id="{B3D59B37-5A9C-46F8-821F-EFBDB15BC32E}"/>
               </a:ext>
             </a:extLst>
           </p:cNvPr>
@@ -23595,7 +23595,7 @@
           <p:nvPr/>
         </p:nvPicPr>
         <p:blipFill>
-          <a:blip xmlns:r="http://schemas.openxmlformats.org/officeDocument/2006/relationships" xmlns:a="http://schemas.openxmlformats.org/drawingml/2006/main" r:embed="Refcf72943c104202"/>
+          <a:blip xmlns:r="http://schemas.openxmlformats.org/officeDocument/2006/relationships" xmlns:a="http://schemas.openxmlformats.org/drawingml/2006/main" r:embed="R21372bcb0c44482b"/>
           <a:stretch xmlns:a="http://schemas.openxmlformats.org/drawingml/2006/main"/>
         </p:blipFill>
         <p:spPr>
@@ -23613,7 +23613,7 @@
           <p:cNvPr id="24" name="">
             <a:extLst xmlns:a="http://schemas.openxmlformats.org/drawingml/2006/main">
               <a:ext uri="{FF2B5EF4-FFF2-40B4-BE49-F238E27FC236}">
-                <a16:creationId xmlns:a16="http://schemas.microsoft.com/office/drawing/2014/main" id="{72EA68E9-8AD9-4412-9E2D-5DF9BDDCB812}"/>
+                <a16:creationId xmlns:a16="http://schemas.microsoft.com/office/drawing/2014/main" id="{F4F71224-E46F-43CB-BA80-AFEA8E1B8657}"/>
               </a:ext>
             </a:extLst>
           </p:cNvPr>
@@ -23770,7 +23770,7 @@
           <p:cNvPr id="25" name="">
             <a:extLst xmlns:a="http://schemas.openxmlformats.org/drawingml/2006/main">
               <a:ext uri="{FF2B5EF4-FFF2-40B4-BE49-F238E27FC236}">
-                <a16:creationId xmlns:a16="http://schemas.microsoft.com/office/drawing/2014/main" id="{6815723F-12DD-4682-AE5D-E2FD11ED54AC}"/>
+                <a16:creationId xmlns:a16="http://schemas.microsoft.com/office/drawing/2014/main" id="{9446917A-E385-4CDF-B337-FC04D3A08214}"/>
               </a:ext>
             </a:extLst>
           </p:cNvPr>
@@ -23927,7 +23927,7 @@
           <p:cNvPr id="26" name="">
             <a:extLst xmlns:a="http://schemas.openxmlformats.org/drawingml/2006/main">
               <a:ext uri="{FF2B5EF4-FFF2-40B4-BE49-F238E27FC236}">
-                <a16:creationId xmlns:a16="http://schemas.microsoft.com/office/drawing/2014/main" id="{56EBF3A8-4177-48CD-AA1B-3F4A4C4D75A0}"/>
+                <a16:creationId xmlns:a16="http://schemas.microsoft.com/office/drawing/2014/main" id="{804D6670-2B19-4001-BCE4-01035F8F6C49}"/>
               </a:ext>
             </a:extLst>
           </p:cNvPr>
@@ -24082,7 +24082,7 @@
     </p:spTree>
     <p:extLst>
       <p:ext uri="{BB962C8B-B14F-4D97-AF65-F5344CB8AC3E}">
-        <p14:creationId xmlns:p14="http://schemas.microsoft.com/office/powerpoint/2010/main" val="542757014"/>
+        <p14:creationId xmlns:p14="http://schemas.microsoft.com/office/powerpoint/2010/main" val="1458956020"/>
       </p:ext>
     </p:extLst>
   </p:cSld>
@@ -24113,7 +24113,7 @@
           <p:cNvPr id="22" name="">
             <a:extLst xmlns:a="http://schemas.openxmlformats.org/drawingml/2006/main">
               <a:ext uri="{FF2B5EF4-FFF2-40B4-BE49-F238E27FC236}">
-                <a16:creationId xmlns:a16="http://schemas.microsoft.com/office/drawing/2014/main" id="{B7817A07-1D7E-4B1D-B98E-B15174CC5DA0}"/>
+                <a16:creationId xmlns:a16="http://schemas.microsoft.com/office/drawing/2014/main" id="{079676C1-9386-45CF-B511-F9E2779B9627}"/>
               </a:ext>
             </a:extLst>
           </p:cNvPr>
@@ -24270,7 +24270,7 @@
           <p:cNvPr id="2" name="">
             <a:extLst xmlns:a="http://schemas.openxmlformats.org/drawingml/2006/main">
               <a:ext uri="{FF2B5EF4-FFF2-40B4-BE49-F238E27FC236}">
-                <a16:creationId xmlns:a16="http://schemas.microsoft.com/office/drawing/2014/main" id="{F38336D5-ACE0-474C-BD2E-5F2A04809AEE}"/>
+                <a16:creationId xmlns:a16="http://schemas.microsoft.com/office/drawing/2014/main" id="{0588725A-80CF-4E64-B723-606B6C9562E2}"/>
               </a:ext>
             </a:extLst>
           </p:cNvPr>
@@ -24301,7 +24301,7 @@
           <p:cNvPr id="3" name="">
             <a:extLst xmlns:a="http://schemas.openxmlformats.org/drawingml/2006/main">
               <a:ext uri="{FF2B5EF4-FFF2-40B4-BE49-F238E27FC236}">
-                <a16:creationId xmlns:a16="http://schemas.microsoft.com/office/drawing/2014/main" id="{7886F944-AECA-4630-AC76-88EE62C407A6}"/>
+                <a16:creationId xmlns:a16="http://schemas.microsoft.com/office/drawing/2014/main" id="{52608D4F-0A8F-44A9-A8C2-625AD8846DBD}"/>
               </a:ext>
             </a:extLst>
           </p:cNvPr>
@@ -24458,7 +24458,7 @@
           <p:cNvPr id="4" name="">
             <a:extLst xmlns:a="http://schemas.openxmlformats.org/drawingml/2006/main">
               <a:ext uri="{FF2B5EF4-FFF2-40B4-BE49-F238E27FC236}">
-                <a16:creationId xmlns:a16="http://schemas.microsoft.com/office/drawing/2014/main" id="{52F0C17D-CBCC-47E9-A454-3BA15280E4C3}"/>
+                <a16:creationId xmlns:a16="http://schemas.microsoft.com/office/drawing/2014/main" id="{1CB464FE-3867-4881-8729-ABFC353B7652}"/>
               </a:ext>
             </a:extLst>
           </p:cNvPr>
@@ -24615,7 +24615,7 @@
           <p:cNvPr id="5" name="">
             <a:extLst xmlns:a="http://schemas.openxmlformats.org/drawingml/2006/main">
               <a:ext uri="{FF2B5EF4-FFF2-40B4-BE49-F238E27FC236}">
-                <a16:creationId xmlns:a16="http://schemas.microsoft.com/office/drawing/2014/main" id="{A72B9325-849B-44DD-9A7A-4255B60F21CF}"/>
+                <a16:creationId xmlns:a16="http://schemas.microsoft.com/office/drawing/2014/main" id="{ADEB287F-7D6B-4C76-92F7-7EF855EA570B}"/>
               </a:ext>
             </a:extLst>
           </p:cNvPr>
@@ -24772,7 +24772,7 @@
           <p:cNvPr id="6" name="">
             <a:extLst xmlns:a="http://schemas.openxmlformats.org/drawingml/2006/main">
               <a:ext uri="{FF2B5EF4-FFF2-40B4-BE49-F238E27FC236}">
-                <a16:creationId xmlns:a16="http://schemas.microsoft.com/office/drawing/2014/main" id="{AD267299-0C87-437A-9B21-3FB09C1B902D}"/>
+                <a16:creationId xmlns:a16="http://schemas.microsoft.com/office/drawing/2014/main" id="{B0229CF9-72F8-48F6-9798-0D6B19D99A75}"/>
               </a:ext>
             </a:extLst>
           </p:cNvPr>
@@ -24929,7 +24929,7 @@
           <p:cNvPr id="7" name="">
             <a:extLst xmlns:a="http://schemas.openxmlformats.org/drawingml/2006/main">
               <a:ext uri="{FF2B5EF4-FFF2-40B4-BE49-F238E27FC236}">
-                <a16:creationId xmlns:a16="http://schemas.microsoft.com/office/drawing/2014/main" id="{09C02DD6-2F76-4F58-8A3B-26640E4C22C3}"/>
+                <a16:creationId xmlns:a16="http://schemas.microsoft.com/office/drawing/2014/main" id="{E14DD365-04F2-461A-B681-BBAD9A6D0C7F}"/>
               </a:ext>
             </a:extLst>
           </p:cNvPr>
@@ -25136,7 +25136,7 @@
           <p:cNvPr id="8" name="">
             <a:extLst xmlns:a="http://schemas.openxmlformats.org/drawingml/2006/main">
               <a:ext uri="{FF2B5EF4-FFF2-40B4-BE49-F238E27FC236}">
-                <a16:creationId xmlns:a16="http://schemas.microsoft.com/office/drawing/2014/main" id="{7CF421FA-0D24-4602-A7DE-AED195D73905}"/>
+                <a16:creationId xmlns:a16="http://schemas.microsoft.com/office/drawing/2014/main" id="{F63BD34D-B68B-4ADA-9482-747689E4EC2B}"/>
               </a:ext>
             </a:extLst>
           </p:cNvPr>
@@ -25176,7 +25176,7 @@
           <p:cNvPr id="9" name="">
             <a:extLst xmlns:a="http://schemas.openxmlformats.org/drawingml/2006/main">
               <a:ext uri="{FF2B5EF4-FFF2-40B4-BE49-F238E27FC236}">
-                <a16:creationId xmlns:a16="http://schemas.microsoft.com/office/drawing/2014/main" id="{57D6C03D-5B20-4537-ABAF-3317BF5D9CA0}"/>
+                <a16:creationId xmlns:a16="http://schemas.microsoft.com/office/drawing/2014/main" id="{16C897E9-FAD0-4B0F-8D27-DA2AFA96BF5C}"/>
               </a:ext>
             </a:extLst>
           </p:cNvPr>
@@ -25333,7 +25333,7 @@
           <p:cNvPr id="10" name="">
             <a:extLst xmlns:a="http://schemas.openxmlformats.org/drawingml/2006/main">
               <a:ext uri="{FF2B5EF4-FFF2-40B4-BE49-F238E27FC236}">
-                <a16:creationId xmlns:a16="http://schemas.microsoft.com/office/drawing/2014/main" id="{644930E9-4052-4780-BD67-E7FDBA264FC1}"/>
+                <a16:creationId xmlns:a16="http://schemas.microsoft.com/office/drawing/2014/main" id="{DF7C6251-9072-4B4A-BDD4-9FEE5410A73A}"/>
               </a:ext>
             </a:extLst>
           </p:cNvPr>
@@ -25517,7 +25517,7 @@
           <p:cNvPr id="11" name="">
             <a:extLst xmlns:a="http://schemas.openxmlformats.org/drawingml/2006/main">
               <a:ext uri="{FF2B5EF4-FFF2-40B4-BE49-F238E27FC236}">
-                <a16:creationId xmlns:a16="http://schemas.microsoft.com/office/drawing/2014/main" id="{C0211FC3-6356-4029-BFBE-969D950CC254}"/>
+                <a16:creationId xmlns:a16="http://schemas.microsoft.com/office/drawing/2014/main" id="{8A6F7B22-306D-4FEF-88B3-8409FE3AB64E}"/>
               </a:ext>
             </a:extLst>
           </p:cNvPr>
@@ -25557,7 +25557,7 @@
           <p:cNvPr id="12" name="">
             <a:extLst xmlns:a="http://schemas.openxmlformats.org/drawingml/2006/main">
               <a:ext uri="{FF2B5EF4-FFF2-40B4-BE49-F238E27FC236}">
-                <a16:creationId xmlns:a16="http://schemas.microsoft.com/office/drawing/2014/main" id="{39365496-51B9-40A5-9A53-64B3FD647299}"/>
+                <a16:creationId xmlns:a16="http://schemas.microsoft.com/office/drawing/2014/main" id="{B83C21B7-26DD-453F-8B4D-6EAB89E92D85}"/>
               </a:ext>
             </a:extLst>
           </p:cNvPr>
@@ -25714,7 +25714,7 @@
           <p:cNvPr id="13" name="">
             <a:extLst xmlns:a="http://schemas.openxmlformats.org/drawingml/2006/main">
               <a:ext uri="{FF2B5EF4-FFF2-40B4-BE49-F238E27FC236}">
-                <a16:creationId xmlns:a16="http://schemas.microsoft.com/office/drawing/2014/main" id="{79796A30-0776-40A8-B878-BDF3DD6DF5FF}"/>
+                <a16:creationId xmlns:a16="http://schemas.microsoft.com/office/drawing/2014/main" id="{F127923C-88FB-4B49-8ADA-8C4B7EC566C1}"/>
               </a:ext>
             </a:extLst>
           </p:cNvPr>
@@ -25898,7 +25898,7 @@
           <p:cNvPr id="14" name="">
             <a:extLst xmlns:a="http://schemas.openxmlformats.org/drawingml/2006/main">
               <a:ext uri="{FF2B5EF4-FFF2-40B4-BE49-F238E27FC236}">
-                <a16:creationId xmlns:a16="http://schemas.microsoft.com/office/drawing/2014/main" id="{CB01124C-65B3-498B-AEA5-12E134C07575}"/>
+                <a16:creationId xmlns:a16="http://schemas.microsoft.com/office/drawing/2014/main" id="{252C00C4-590A-4820-B3D6-4503555EF991}"/>
               </a:ext>
             </a:extLst>
           </p:cNvPr>
@@ -26055,7 +26055,7 @@
           <p:cNvPr id="15" name="">
             <a:extLst xmlns:a="http://schemas.openxmlformats.org/drawingml/2006/main">
               <a:ext uri="{FF2B5EF4-FFF2-40B4-BE49-F238E27FC236}">
-                <a16:creationId xmlns:a16="http://schemas.microsoft.com/office/drawing/2014/main" id="{C72DFBA4-FD3C-48A9-8BDF-BDA388094E46}"/>
+                <a16:creationId xmlns:a16="http://schemas.microsoft.com/office/drawing/2014/main" id="{1E0B2CE4-A496-494C-8527-A446983F178C}"/>
               </a:ext>
             </a:extLst>
           </p:cNvPr>
@@ -26095,7 +26095,7 @@
           <p:cNvPr id="16" name="">
             <a:extLst xmlns:a="http://schemas.openxmlformats.org/drawingml/2006/main">
               <a:ext uri="{FF2B5EF4-FFF2-40B4-BE49-F238E27FC236}">
-                <a16:creationId xmlns:a16="http://schemas.microsoft.com/office/drawing/2014/main" id="{A3E2B557-465C-4FC3-A327-99952A4D2FD5}"/>
+                <a16:creationId xmlns:a16="http://schemas.microsoft.com/office/drawing/2014/main" id="{D8AC111B-43A2-42E3-B269-12311B008B6A}"/>
               </a:ext>
             </a:extLst>
           </p:cNvPr>
@@ -26279,7 +26279,7 @@
           <p:cNvPr id="17" name="">
             <a:extLst xmlns:a="http://schemas.openxmlformats.org/drawingml/2006/main">
               <a:ext uri="{FF2B5EF4-FFF2-40B4-BE49-F238E27FC236}">
-                <a16:creationId xmlns:a16="http://schemas.microsoft.com/office/drawing/2014/main" id="{119B0FBC-4FF4-4B62-BA0A-3CAFCC4FD060}"/>
+                <a16:creationId xmlns:a16="http://schemas.microsoft.com/office/drawing/2014/main" id="{E50780E3-BE6B-44FF-B6A3-4261DAFEDA4A}"/>
               </a:ext>
             </a:extLst>
           </p:cNvPr>
@@ -26436,7 +26436,7 @@
           <p:cNvPr id="18" name="">
             <a:extLst xmlns:a="http://schemas.openxmlformats.org/drawingml/2006/main">
               <a:ext uri="{FF2B5EF4-FFF2-40B4-BE49-F238E27FC236}">
-                <a16:creationId xmlns:a16="http://schemas.microsoft.com/office/drawing/2014/main" id="{14A67254-FE40-4D5D-9115-57A11D6573A6}"/>
+                <a16:creationId xmlns:a16="http://schemas.microsoft.com/office/drawing/2014/main" id="{0D6BAA0E-880F-4047-8971-2779D606A351}"/>
               </a:ext>
             </a:extLst>
           </p:cNvPr>
@@ -26639,7 +26639,7 @@
           <p:cNvPr id="19" name="">
             <a:extLst xmlns:a="http://schemas.openxmlformats.org/drawingml/2006/main">
               <a:ext uri="{FF2B5EF4-FFF2-40B4-BE49-F238E27FC236}">
-                <a16:creationId xmlns:a16="http://schemas.microsoft.com/office/drawing/2014/main" id="{EA24AAF4-04E6-4006-B7BD-1CEC41CBC795}"/>
+                <a16:creationId xmlns:a16="http://schemas.microsoft.com/office/drawing/2014/main" id="{914BE6BF-3AB1-4F5F-8D58-D2E1A1CA8A08}"/>
               </a:ext>
             </a:extLst>
           </p:cNvPr>
@@ -26681,7 +26681,7 @@
           <p:cNvPr id="20" name="">
             <a:extLst xmlns:a="http://schemas.openxmlformats.org/drawingml/2006/main">
               <a:ext uri="{FF2B5EF4-FFF2-40B4-BE49-F238E27FC236}">
-                <a16:creationId xmlns:a16="http://schemas.microsoft.com/office/drawing/2014/main" id="{5CB123D7-57D9-440B-A203-55D57DE420F3}"/>
+                <a16:creationId xmlns:a16="http://schemas.microsoft.com/office/drawing/2014/main" id="{67662594-F6D4-4783-9B98-3F7390029D60}"/>
               </a:ext>
             </a:extLst>
           </p:cNvPr>
@@ -26838,7 +26838,7 @@
           <p:cNvPr id="21" name="">
             <a:extLst xmlns:a="http://schemas.openxmlformats.org/drawingml/2006/main">
               <a:ext uri="{FF2B5EF4-FFF2-40B4-BE49-F238E27FC236}">
-                <a16:creationId xmlns:a16="http://schemas.microsoft.com/office/drawing/2014/main" id="{4217AFC7-D36D-4AD2-9A1E-66DB4D292046}"/>
+                <a16:creationId xmlns:a16="http://schemas.microsoft.com/office/drawing/2014/main" id="{BBD9A15C-C0F7-4F8F-A68A-801C40F4951F}"/>
               </a:ext>
             </a:extLst>
           </p:cNvPr>
@@ -27039,7 +27039,7 @@
     </p:spTree>
     <p:extLst>
       <p:ext uri="{BB962C8B-B14F-4D97-AF65-F5344CB8AC3E}">
-        <p14:creationId xmlns:p14="http://schemas.microsoft.com/office/powerpoint/2010/main" val="1962154666"/>
+        <p14:creationId xmlns:p14="http://schemas.microsoft.com/office/powerpoint/2010/main" val="140693792"/>
       </p:ext>
     </p:extLst>
   </p:cSld>
@@ -27070,7 +27070,7 @@
           <p:cNvPr id="27" name="">
             <a:extLst xmlns:a="http://schemas.openxmlformats.org/drawingml/2006/main">
               <a:ext uri="{FF2B5EF4-FFF2-40B4-BE49-F238E27FC236}">
-                <a16:creationId xmlns:a16="http://schemas.microsoft.com/office/drawing/2014/main" id="{82F636A7-0531-40E3-B40B-8D029CF2D489}"/>
+                <a16:creationId xmlns:a16="http://schemas.microsoft.com/office/drawing/2014/main" id="{A885AE92-920A-4490-AE74-F9F656111E1F}"/>
               </a:ext>
             </a:extLst>
           </p:cNvPr>
@@ -27227,7 +27227,7 @@
           <p:cNvPr id="2" name="">
             <a:extLst xmlns:a="http://schemas.openxmlformats.org/drawingml/2006/main">
               <a:ext uri="{FF2B5EF4-FFF2-40B4-BE49-F238E27FC236}">
-                <a16:creationId xmlns:a16="http://schemas.microsoft.com/office/drawing/2014/main" id="{B5083F45-CAC4-4BB1-947C-9FD918B9A264}"/>
+                <a16:creationId xmlns:a16="http://schemas.microsoft.com/office/drawing/2014/main" id="{DF1C1AF0-C300-42CB-8022-C44B9833F1BD}"/>
               </a:ext>
             </a:extLst>
           </p:cNvPr>
@@ -27258,7 +27258,7 @@
           <p:cNvPr id="3" name="">
             <a:extLst xmlns:a="http://schemas.openxmlformats.org/drawingml/2006/main">
               <a:ext uri="{FF2B5EF4-FFF2-40B4-BE49-F238E27FC236}">
-                <a16:creationId xmlns:a16="http://schemas.microsoft.com/office/drawing/2014/main" id="{AB8E1ED6-12E3-4120-B9C7-34882781D578}"/>
+                <a16:creationId xmlns:a16="http://schemas.microsoft.com/office/drawing/2014/main" id="{8F20A8AF-B8D7-4EAD-9B8B-289EF31BBE31}"/>
               </a:ext>
             </a:extLst>
           </p:cNvPr>
@@ -27415,7 +27415,7 @@
           <p:cNvPr id="4" name="">
             <a:extLst xmlns:a="http://schemas.openxmlformats.org/drawingml/2006/main">
               <a:ext uri="{FF2B5EF4-FFF2-40B4-BE49-F238E27FC236}">
-                <a16:creationId xmlns:a16="http://schemas.microsoft.com/office/drawing/2014/main" id="{DB2F4B03-172E-403E-9AD3-16961E8CDFBB}"/>
+                <a16:creationId xmlns:a16="http://schemas.microsoft.com/office/drawing/2014/main" id="{5EF87760-830D-4FBB-A857-D715370A7564}"/>
               </a:ext>
             </a:extLst>
           </p:cNvPr>
@@ -27572,7 +27572,7 @@
           <p:cNvPr id="5" name="">
             <a:extLst xmlns:a="http://schemas.openxmlformats.org/drawingml/2006/main">
               <a:ext uri="{FF2B5EF4-FFF2-40B4-BE49-F238E27FC236}">
-                <a16:creationId xmlns:a16="http://schemas.microsoft.com/office/drawing/2014/main" id="{7A12D0F1-C483-4E10-AAFB-59A3F20E0D78}"/>
+                <a16:creationId xmlns:a16="http://schemas.microsoft.com/office/drawing/2014/main" id="{CB33AC68-E188-4520-B540-4A58286CA9B3}"/>
               </a:ext>
             </a:extLst>
           </p:cNvPr>
@@ -27729,7 +27729,7 @@
           <p:cNvPr id="6" name="">
             <a:extLst xmlns:a="http://schemas.openxmlformats.org/drawingml/2006/main">
               <a:ext uri="{FF2B5EF4-FFF2-40B4-BE49-F238E27FC236}">
-                <a16:creationId xmlns:a16="http://schemas.microsoft.com/office/drawing/2014/main" id="{F3204B6C-95C1-488A-BA00-D913947F7F26}"/>
+                <a16:creationId xmlns:a16="http://schemas.microsoft.com/office/drawing/2014/main" id="{11D78918-5CB2-49B3-B664-D99A05057DF7}"/>
               </a:ext>
             </a:extLst>
           </p:cNvPr>
@@ -27886,7 +27886,7 @@
           <p:cNvPr id="7" name="">
             <a:extLst xmlns:a="http://schemas.openxmlformats.org/drawingml/2006/main">
               <a:ext uri="{FF2B5EF4-FFF2-40B4-BE49-F238E27FC236}">
-                <a16:creationId xmlns:a16="http://schemas.microsoft.com/office/drawing/2014/main" id="{9436BC3A-447F-401A-8AED-96B2F67B8A99}"/>
+                <a16:creationId xmlns:a16="http://schemas.microsoft.com/office/drawing/2014/main" id="{B3E36699-2F4B-46E3-BAF1-791B6DFE7D4F}"/>
               </a:ext>
             </a:extLst>
           </p:cNvPr>
@@ -28043,7 +28043,7 @@
           <p:cNvPr id="8" name="">
             <a:extLst xmlns:a="http://schemas.openxmlformats.org/drawingml/2006/main">
               <a:ext uri="{FF2B5EF4-FFF2-40B4-BE49-F238E27FC236}">
-                <a16:creationId xmlns:a16="http://schemas.microsoft.com/office/drawing/2014/main" id="{50AFDCD9-9147-4BA6-B51E-91BD564E0041}"/>
+                <a16:creationId xmlns:a16="http://schemas.microsoft.com/office/drawing/2014/main" id="{8294BEA8-5C57-49DB-B412-85E563457E9A}"/>
               </a:ext>
             </a:extLst>
           </p:cNvPr>
@@ -28200,7 +28200,7 @@
           <p:cNvPr id="9" name="">
             <a:extLst xmlns:a="http://schemas.openxmlformats.org/drawingml/2006/main">
               <a:ext uri="{FF2B5EF4-FFF2-40B4-BE49-F238E27FC236}">
-                <a16:creationId xmlns:a16="http://schemas.microsoft.com/office/drawing/2014/main" id="{FFB53405-8897-4930-9B16-27470281CB28}"/>
+                <a16:creationId xmlns:a16="http://schemas.microsoft.com/office/drawing/2014/main" id="{0AAB0839-0A2B-4919-A2BE-DEC16A302608}"/>
               </a:ext>
             </a:extLst>
           </p:cNvPr>
@@ -28231,7 +28231,7 @@
           <p:cNvPr id="10" name="">
             <a:extLst xmlns:a="http://schemas.openxmlformats.org/drawingml/2006/main">
               <a:ext uri="{FF2B5EF4-FFF2-40B4-BE49-F238E27FC236}">
-                <a16:creationId xmlns:a16="http://schemas.microsoft.com/office/drawing/2014/main" id="{8425FC1F-9113-4795-9A8B-4965BCCC79A9}"/>
+                <a16:creationId xmlns:a16="http://schemas.microsoft.com/office/drawing/2014/main" id="{C51112F6-E0D0-49C0-B7D2-C88E2A4ABB73}"/>
               </a:ext>
             </a:extLst>
           </p:cNvPr>
@@ -28388,7 +28388,7 @@
           <p:cNvPr id="11" name="">
             <a:extLst xmlns:a="http://schemas.openxmlformats.org/drawingml/2006/main">
               <a:ext uri="{FF2B5EF4-FFF2-40B4-BE49-F238E27FC236}">
-                <a16:creationId xmlns:a16="http://schemas.microsoft.com/office/drawing/2014/main" id="{355F4E05-2F8F-4F30-A518-E132634C3598}"/>
+                <a16:creationId xmlns:a16="http://schemas.microsoft.com/office/drawing/2014/main" id="{F45A4A75-FD26-4784-9321-A6062D7BB4CF}"/>
               </a:ext>
             </a:extLst>
           </p:cNvPr>
@@ -28545,7 +28545,7 @@
           <p:cNvPr id="12" name="">
             <a:extLst xmlns:a="http://schemas.openxmlformats.org/drawingml/2006/main">
               <a:ext uri="{FF2B5EF4-FFF2-40B4-BE49-F238E27FC236}">
-                <a16:creationId xmlns:a16="http://schemas.microsoft.com/office/drawing/2014/main" id="{F62D0C43-791B-49DA-85C5-07483AC9DC8B}"/>
+                <a16:creationId xmlns:a16="http://schemas.microsoft.com/office/drawing/2014/main" id="{A73EB47E-842D-44C7-BF97-B31B3399FB19}"/>
               </a:ext>
             </a:extLst>
           </p:cNvPr>
@@ -28576,7 +28576,7 @@
           <p:cNvPr id="13" name="">
             <a:extLst xmlns:a="http://schemas.openxmlformats.org/drawingml/2006/main">
               <a:ext uri="{FF2B5EF4-FFF2-40B4-BE49-F238E27FC236}">
-                <a16:creationId xmlns:a16="http://schemas.microsoft.com/office/drawing/2014/main" id="{45BC3AC6-2810-41FE-A526-E05A0029D865}"/>
+                <a16:creationId xmlns:a16="http://schemas.microsoft.com/office/drawing/2014/main" id="{25739423-7705-46A6-ACFE-2052BE792E17}"/>
               </a:ext>
             </a:extLst>
           </p:cNvPr>
@@ -28733,7 +28733,7 @@
           <p:cNvPr id="14" name="">
             <a:extLst xmlns:a="http://schemas.openxmlformats.org/drawingml/2006/main">
               <a:ext uri="{FF2B5EF4-FFF2-40B4-BE49-F238E27FC236}">
-                <a16:creationId xmlns:a16="http://schemas.microsoft.com/office/drawing/2014/main" id="{46225A01-1748-4C6F-B84D-C7A5707EAD0E}"/>
+                <a16:creationId xmlns:a16="http://schemas.microsoft.com/office/drawing/2014/main" id="{5064363E-62D5-4D3D-B507-FC1CD46178DD}"/>
               </a:ext>
             </a:extLst>
           </p:cNvPr>
@@ -28890,7 +28890,7 @@
           <p:cNvPr id="15" name="">
             <a:extLst xmlns:a="http://schemas.openxmlformats.org/drawingml/2006/main">
               <a:ext uri="{FF2B5EF4-FFF2-40B4-BE49-F238E27FC236}">
-                <a16:creationId xmlns:a16="http://schemas.microsoft.com/office/drawing/2014/main" id="{3FCAA4E6-072B-4B7C-A1F3-13CAD8E9168E}"/>
+                <a16:creationId xmlns:a16="http://schemas.microsoft.com/office/drawing/2014/main" id="{D93FB678-2788-42B6-BFF4-D989E4F908B3}"/>
               </a:ext>
             </a:extLst>
           </p:cNvPr>
@@ -28921,7 +28921,7 @@
           <p:cNvPr id="16" name="">
             <a:extLst xmlns:a="http://schemas.openxmlformats.org/drawingml/2006/main">
               <a:ext uri="{FF2B5EF4-FFF2-40B4-BE49-F238E27FC236}">
-                <a16:creationId xmlns:a16="http://schemas.microsoft.com/office/drawing/2014/main" id="{FCB1039D-3F0B-42F8-B172-B33E397C790B}"/>
+                <a16:creationId xmlns:a16="http://schemas.microsoft.com/office/drawing/2014/main" id="{D2718D1B-7791-47CC-B017-23E3789062EA}"/>
               </a:ext>
             </a:extLst>
           </p:cNvPr>
@@ -29078,7 +29078,7 @@
           <p:cNvPr id="17" name="">
             <a:extLst xmlns:a="http://schemas.openxmlformats.org/drawingml/2006/main">
               <a:ext uri="{FF2B5EF4-FFF2-40B4-BE49-F238E27FC236}">
-                <a16:creationId xmlns:a16="http://schemas.microsoft.com/office/drawing/2014/main" id="{03D43904-177C-41C3-83B3-313DD1251614}"/>
+                <a16:creationId xmlns:a16="http://schemas.microsoft.com/office/drawing/2014/main" id="{7BB8C317-42AD-4A0E-8E5C-198BE6EE350E}"/>
               </a:ext>
             </a:extLst>
           </p:cNvPr>
@@ -29235,7 +29235,7 @@
           <p:cNvPr id="18" name="">
             <a:extLst xmlns:a="http://schemas.openxmlformats.org/drawingml/2006/main">
               <a:ext uri="{FF2B5EF4-FFF2-40B4-BE49-F238E27FC236}">
-                <a16:creationId xmlns:a16="http://schemas.microsoft.com/office/drawing/2014/main" id="{6A0CEFF9-095C-454E-9874-14224E8EA700}"/>
+                <a16:creationId xmlns:a16="http://schemas.microsoft.com/office/drawing/2014/main" id="{C622A226-8C21-4EF8-BC9B-9692A8036690}"/>
               </a:ext>
             </a:extLst>
           </p:cNvPr>
@@ -29392,7 +29392,7 @@
           <p:cNvPr id="19" name="">
             <a:extLst xmlns:a="http://schemas.openxmlformats.org/drawingml/2006/main">
               <a:ext uri="{FF2B5EF4-FFF2-40B4-BE49-F238E27FC236}">
-                <a16:creationId xmlns:a16="http://schemas.microsoft.com/office/drawing/2014/main" id="{FBE7412E-7119-45A0-8BD7-E1CCAD2C06E9}"/>
+                <a16:creationId xmlns:a16="http://schemas.microsoft.com/office/drawing/2014/main" id="{96E7CE2D-1142-4AC7-A9E0-521E92CFB781}"/>
               </a:ext>
             </a:extLst>
           </p:cNvPr>
@@ -29434,7 +29434,7 @@
           <p:cNvPr id="20" name="">
             <a:extLst xmlns:a="http://schemas.openxmlformats.org/drawingml/2006/main">
               <a:ext uri="{FF2B5EF4-FFF2-40B4-BE49-F238E27FC236}">
-                <a16:creationId xmlns:a16="http://schemas.microsoft.com/office/drawing/2014/main" id="{29E4AEA4-75DB-42A9-A1CC-0EBDF22C3E69}"/>
+                <a16:creationId xmlns:a16="http://schemas.microsoft.com/office/drawing/2014/main" id="{DA0105D5-B566-43B4-83A9-E33B92173C6B}"/>
               </a:ext>
             </a:extLst>
           </p:cNvPr>
@@ -29444,7 +29444,7 @@
           <p:nvPr/>
         </p:nvPicPr>
         <p:blipFill>
-          <a:blip xmlns:r="http://schemas.openxmlformats.org/officeDocument/2006/relationships" xmlns:a="http://schemas.openxmlformats.org/drawingml/2006/main" r:embed="R719a23101fe34e7e"/>
+          <a:blip xmlns:r="http://schemas.openxmlformats.org/officeDocument/2006/relationships" xmlns:a="http://schemas.openxmlformats.org/drawingml/2006/main" r:embed="Rb3e78c2b78784806"/>
           <a:stretch xmlns:a="http://schemas.openxmlformats.org/drawingml/2006/main"/>
         </p:blipFill>
         <p:spPr>
@@ -29462,7 +29462,7 @@
           <p:cNvPr id="21" name="">
             <a:extLst xmlns:a="http://schemas.openxmlformats.org/drawingml/2006/main">
               <a:ext uri="{FF2B5EF4-FFF2-40B4-BE49-F238E27FC236}">
-                <a16:creationId xmlns:a16="http://schemas.microsoft.com/office/drawing/2014/main" id="{1A170065-A96E-45C1-A170-87B463C1CEE2}"/>
+                <a16:creationId xmlns:a16="http://schemas.microsoft.com/office/drawing/2014/main" id="{A213646F-BAF2-4AF4-B781-168E1588D9D5}"/>
               </a:ext>
             </a:extLst>
           </p:cNvPr>
@@ -29619,7 +29619,7 @@
           <p:cNvPr id="22" name="">
             <a:extLst xmlns:a="http://schemas.openxmlformats.org/drawingml/2006/main">
               <a:ext uri="{FF2B5EF4-FFF2-40B4-BE49-F238E27FC236}">
-                <a16:creationId xmlns:a16="http://schemas.microsoft.com/office/drawing/2014/main" id="{6FCE79C5-0369-441F-8CCA-EF2AE93B0C94}"/>
+                <a16:creationId xmlns:a16="http://schemas.microsoft.com/office/drawing/2014/main" id="{2D50687F-807A-4A7C-92C7-4C0269C1BFD8}"/>
               </a:ext>
             </a:extLst>
           </p:cNvPr>
@@ -29776,7 +29776,7 @@
           <p:cNvPr id="23" name="">
             <a:extLst xmlns:a="http://schemas.openxmlformats.org/drawingml/2006/main">
               <a:ext uri="{FF2B5EF4-FFF2-40B4-BE49-F238E27FC236}">
-                <a16:creationId xmlns:a16="http://schemas.microsoft.com/office/drawing/2014/main" id="{508F699C-BD07-44B6-BE04-0D7BB5F98672}"/>
+                <a16:creationId xmlns:a16="http://schemas.microsoft.com/office/drawing/2014/main" id="{973C24A1-27D4-4F5E-9735-3B1D305E0D07}"/>
               </a:ext>
             </a:extLst>
           </p:cNvPr>
@@ -29933,7 +29933,7 @@
           <p:cNvPr id="24" name="">
             <a:extLst xmlns:a="http://schemas.openxmlformats.org/drawingml/2006/main">
               <a:ext uri="{FF2B5EF4-FFF2-40B4-BE49-F238E27FC236}">
-                <a16:creationId xmlns:a16="http://schemas.microsoft.com/office/drawing/2014/main" id="{35647B11-FEC6-49B4-95B6-19FD1C9EE6FF}"/>
+                <a16:creationId xmlns:a16="http://schemas.microsoft.com/office/drawing/2014/main" id="{0169BC37-A6FC-4327-8486-D2CF91B7748A}"/>
               </a:ext>
             </a:extLst>
           </p:cNvPr>
@@ -30090,7 +30090,7 @@
           <p:cNvPr id="25" name="">
             <a:extLst xmlns:a="http://schemas.openxmlformats.org/drawingml/2006/main">
               <a:ext uri="{FF2B5EF4-FFF2-40B4-BE49-F238E27FC236}">
-                <a16:creationId xmlns:a16="http://schemas.microsoft.com/office/drawing/2014/main" id="{AA40DA63-22D7-4313-B9D0-2885EAD7A2A8}"/>
+                <a16:creationId xmlns:a16="http://schemas.microsoft.com/office/drawing/2014/main" id="{8C321D3D-2BB8-42D1-B1C9-8484F1C6F4F9}"/>
               </a:ext>
             </a:extLst>
           </p:cNvPr>
@@ -30247,7 +30247,7 @@
           <p:cNvPr id="26" name="">
             <a:extLst xmlns:a="http://schemas.openxmlformats.org/drawingml/2006/main">
               <a:ext uri="{FF2B5EF4-FFF2-40B4-BE49-F238E27FC236}">
-                <a16:creationId xmlns:a16="http://schemas.microsoft.com/office/drawing/2014/main" id="{5279D0DE-6A49-4C50-9C90-A8B58B2A4C18}"/>
+                <a16:creationId xmlns:a16="http://schemas.microsoft.com/office/drawing/2014/main" id="{C7398435-9E1E-468B-BDBD-1B963AB7780A}"/>
               </a:ext>
             </a:extLst>
           </p:cNvPr>
@@ -30402,7 +30402,7 @@
     </p:spTree>
     <p:extLst>
       <p:ext uri="{BB962C8B-B14F-4D97-AF65-F5344CB8AC3E}">
-        <p14:creationId xmlns:p14="http://schemas.microsoft.com/office/powerpoint/2010/main" val="231788210"/>
+        <p14:creationId xmlns:p14="http://schemas.microsoft.com/office/powerpoint/2010/main" val="470989444"/>
       </p:ext>
     </p:extLst>
   </p:cSld>
@@ -30433,7 +30433,7 @@
           <p:cNvPr id="18" name="">
             <a:extLst xmlns:a="http://schemas.openxmlformats.org/drawingml/2006/main">
               <a:ext uri="{FF2B5EF4-FFF2-40B4-BE49-F238E27FC236}">
-                <a16:creationId xmlns:a16="http://schemas.microsoft.com/office/drawing/2014/main" id="{9EDA1DDC-283F-42B6-AF12-EC1F0839BE33}"/>
+                <a16:creationId xmlns:a16="http://schemas.microsoft.com/office/drawing/2014/main" id="{9D5B9A45-B7C7-4E76-AB2D-7C368B24624F}"/>
               </a:ext>
             </a:extLst>
           </p:cNvPr>
@@ -30590,7 +30590,7 @@
           <p:cNvPr id="2" name="">
             <a:extLst xmlns:a="http://schemas.openxmlformats.org/drawingml/2006/main">
               <a:ext uri="{FF2B5EF4-FFF2-40B4-BE49-F238E27FC236}">
-                <a16:creationId xmlns:a16="http://schemas.microsoft.com/office/drawing/2014/main" id="{14461B37-F152-483D-AAEC-45EE8912103A}"/>
+                <a16:creationId xmlns:a16="http://schemas.microsoft.com/office/drawing/2014/main" id="{75350DE8-ED53-41B7-811E-454DA6ED76C4}"/>
               </a:ext>
             </a:extLst>
           </p:cNvPr>
@@ -30621,7 +30621,7 @@
           <p:cNvPr id="3" name="">
             <a:extLst xmlns:a="http://schemas.openxmlformats.org/drawingml/2006/main">
               <a:ext uri="{FF2B5EF4-FFF2-40B4-BE49-F238E27FC236}">
-                <a16:creationId xmlns:a16="http://schemas.microsoft.com/office/drawing/2014/main" id="{C2C5287F-D053-4826-82C3-34FE5ED6F391}"/>
+                <a16:creationId xmlns:a16="http://schemas.microsoft.com/office/drawing/2014/main" id="{E69E354E-3F53-45C2-9506-B08F61850DBB}"/>
               </a:ext>
             </a:extLst>
           </p:cNvPr>
@@ -30778,7 +30778,7 @@
           <p:cNvPr id="4" name="">
             <a:extLst xmlns:a="http://schemas.openxmlformats.org/drawingml/2006/main">
               <a:ext uri="{FF2B5EF4-FFF2-40B4-BE49-F238E27FC236}">
-                <a16:creationId xmlns:a16="http://schemas.microsoft.com/office/drawing/2014/main" id="{70E72260-67CD-40EA-A6DC-426E18A61F59}"/>
+                <a16:creationId xmlns:a16="http://schemas.microsoft.com/office/drawing/2014/main" id="{8983D1F3-1A1B-47E0-A8AD-7BD4F6F5EB33}"/>
               </a:ext>
             </a:extLst>
           </p:cNvPr>
@@ -30935,7 +30935,7 @@
           <p:cNvPr id="5" name="">
             <a:extLst xmlns:a="http://schemas.openxmlformats.org/drawingml/2006/main">
               <a:ext uri="{FF2B5EF4-FFF2-40B4-BE49-F238E27FC236}">
-                <a16:creationId xmlns:a16="http://schemas.microsoft.com/office/drawing/2014/main" id="{A0915CBE-0707-43C1-8FAF-18286C6C5BA4}"/>
+                <a16:creationId xmlns:a16="http://schemas.microsoft.com/office/drawing/2014/main" id="{1E13DADC-026C-4260-8155-86C446BD02AA}"/>
               </a:ext>
             </a:extLst>
           </p:cNvPr>
@@ -31092,7 +31092,7 @@
           <p:cNvPr id="6" name="Chart">
             <a:extLst xmlns:a="http://schemas.openxmlformats.org/drawingml/2006/main">
               <a:ext uri="{FF2B5EF4-FFF2-40B4-BE49-F238E27FC236}">
-                <a16:creationId xmlns:a16="http://schemas.microsoft.com/office/drawing/2014/main" id="{71977CED-1F2B-4919-8AED-A736E68969D3}"/>
+                <a16:creationId xmlns:a16="http://schemas.microsoft.com/office/drawing/2014/main" id="{543B7B81-5286-4A91-ABBC-8FBFA41976C9}"/>
               </a:ext>
             </a:extLst>
           </p:cNvPr>
@@ -31105,7 +31105,7 @@
         </p:xfrm>
         <a:graphic xmlns:a="http://schemas.openxmlformats.org/drawingml/2006/main">
           <a:graphicData uri="http://schemas.openxmlformats.org/drawingml/2006/chart">
-            <c:chart xmlns:r="http://schemas.openxmlformats.org/officeDocument/2006/relationships" xmlns:c="http://schemas.openxmlformats.org/drawingml/2006/chart" r:id="R437d544841c445e6"/>
+            <c:chart xmlns:r="http://schemas.openxmlformats.org/officeDocument/2006/relationships" xmlns:c="http://schemas.openxmlformats.org/drawingml/2006/chart" r:id="R8bee8c047be74bfd"/>
           </a:graphicData>
         </a:graphic>
       </p:graphicFrame>
@@ -31114,7 +31114,7 @@
           <p:cNvPr id="7" name="">
             <a:extLst xmlns:a="http://schemas.openxmlformats.org/drawingml/2006/main">
               <a:ext uri="{FF2B5EF4-FFF2-40B4-BE49-F238E27FC236}">
-                <a16:creationId xmlns:a16="http://schemas.microsoft.com/office/drawing/2014/main" id="{7C33EE72-ACA5-416D-94B9-E24493ED9000}"/>
+                <a16:creationId xmlns:a16="http://schemas.microsoft.com/office/drawing/2014/main" id="{CE2CAE7C-ABFA-40F6-9B13-3CED4207D50A}"/>
               </a:ext>
             </a:extLst>
           </p:cNvPr>
@@ -31271,7 +31271,7 @@
           <p:cNvPr id="8" name="">
             <a:extLst xmlns:a="http://schemas.openxmlformats.org/drawingml/2006/main">
               <a:ext uri="{FF2B5EF4-FFF2-40B4-BE49-F238E27FC236}">
-                <a16:creationId xmlns:a16="http://schemas.microsoft.com/office/drawing/2014/main" id="{488BDC20-8212-45F2-A552-20E0B4B3A0ED}"/>
+                <a16:creationId xmlns:a16="http://schemas.microsoft.com/office/drawing/2014/main" id="{CC245B33-A0A8-449A-A831-A82125716C6B}"/>
               </a:ext>
             </a:extLst>
           </p:cNvPr>
@@ -31428,7 +31428,7 @@
           <p:cNvPr id="9" name="">
             <a:extLst xmlns:a="http://schemas.openxmlformats.org/drawingml/2006/main">
               <a:ext uri="{FF2B5EF4-FFF2-40B4-BE49-F238E27FC236}">
-                <a16:creationId xmlns:a16="http://schemas.microsoft.com/office/drawing/2014/main" id="{20943935-5DCF-400A-8D29-99769CCFBF79}"/>
+                <a16:creationId xmlns:a16="http://schemas.microsoft.com/office/drawing/2014/main" id="{4414AF5A-D9D9-4BA3-8B97-8252A5CC4BF1}"/>
               </a:ext>
             </a:extLst>
           </p:cNvPr>
@@ -31459,7 +31459,7 @@
           <p:cNvPr id="10" name="">
             <a:extLst xmlns:a="http://schemas.openxmlformats.org/drawingml/2006/main">
               <a:ext uri="{FF2B5EF4-FFF2-40B4-BE49-F238E27FC236}">
-                <a16:creationId xmlns:a16="http://schemas.microsoft.com/office/drawing/2014/main" id="{5D94AF37-7047-4704-8DF2-D0044A05DE12}"/>
+                <a16:creationId xmlns:a16="http://schemas.microsoft.com/office/drawing/2014/main" id="{0DF35974-A12B-4B08-B2AF-BBC8C768C895}"/>
               </a:ext>
             </a:extLst>
           </p:cNvPr>
@@ -31616,7 +31616,7 @@
           <p:cNvPr id="11" name="">
             <a:extLst xmlns:a="http://schemas.openxmlformats.org/drawingml/2006/main">
               <a:ext uri="{FF2B5EF4-FFF2-40B4-BE49-F238E27FC236}">
-                <a16:creationId xmlns:a16="http://schemas.microsoft.com/office/drawing/2014/main" id="{E848BAD5-F40E-4ECD-A982-5F2A9E926A74}"/>
+                <a16:creationId xmlns:a16="http://schemas.microsoft.com/office/drawing/2014/main" id="{4A48C3D4-D2D4-48A9-97F9-42C5265FD491}"/>
               </a:ext>
             </a:extLst>
           </p:cNvPr>
@@ -31773,7 +31773,7 @@
           <p:cNvPr id="12" name="">
             <a:extLst xmlns:a="http://schemas.openxmlformats.org/drawingml/2006/main">
               <a:ext uri="{FF2B5EF4-FFF2-40B4-BE49-F238E27FC236}">
-                <a16:creationId xmlns:a16="http://schemas.microsoft.com/office/drawing/2014/main" id="{965C1BDC-8F0C-468A-B651-BE39991713BC}"/>
+                <a16:creationId xmlns:a16="http://schemas.microsoft.com/office/drawing/2014/main" id="{5D8FDA7C-910A-468B-8186-AC4ABFD42D09}"/>
               </a:ext>
             </a:extLst>
           </p:cNvPr>
@@ -31930,7 +31930,7 @@
           <p:cNvPr id="13" name="">
             <a:extLst xmlns:a="http://schemas.openxmlformats.org/drawingml/2006/main">
               <a:ext uri="{FF2B5EF4-FFF2-40B4-BE49-F238E27FC236}">
-                <a16:creationId xmlns:a16="http://schemas.microsoft.com/office/drawing/2014/main" id="{D89FCEFA-53FB-4166-9D4B-30F92C7FE288}"/>
+                <a16:creationId xmlns:a16="http://schemas.microsoft.com/office/drawing/2014/main" id="{46E88D50-76F0-4ADE-8984-B073C13F93C2}"/>
               </a:ext>
             </a:extLst>
           </p:cNvPr>
@@ -32087,7 +32087,7 @@
           <p:cNvPr id="14" name="">
             <a:extLst xmlns:a="http://schemas.openxmlformats.org/drawingml/2006/main">
               <a:ext uri="{FF2B5EF4-FFF2-40B4-BE49-F238E27FC236}">
-                <a16:creationId xmlns:a16="http://schemas.microsoft.com/office/drawing/2014/main" id="{4B70DE0D-07E0-435A-AFD9-DBF627951481}"/>
+                <a16:creationId xmlns:a16="http://schemas.microsoft.com/office/drawing/2014/main" id="{F2D8EF85-47FC-4DE9-A6AC-14A6254058DE}"/>
               </a:ext>
             </a:extLst>
           </p:cNvPr>
@@ -32244,7 +32244,7 @@
           <p:cNvPr id="15" name="">
             <a:extLst xmlns:a="http://schemas.openxmlformats.org/drawingml/2006/main">
               <a:ext uri="{FF2B5EF4-FFF2-40B4-BE49-F238E27FC236}">
-                <a16:creationId xmlns:a16="http://schemas.microsoft.com/office/drawing/2014/main" id="{4431863D-C760-469E-9AF3-FBC1880647A2}"/>
+                <a16:creationId xmlns:a16="http://schemas.microsoft.com/office/drawing/2014/main" id="{D05F272F-7E5D-45E3-A102-C2702FB834EC}"/>
               </a:ext>
             </a:extLst>
           </p:cNvPr>
@@ -32401,7 +32401,7 @@
           <p:cNvPr id="16" name="">
             <a:extLst xmlns:a="http://schemas.openxmlformats.org/drawingml/2006/main">
               <a:ext uri="{FF2B5EF4-FFF2-40B4-BE49-F238E27FC236}">
-                <a16:creationId xmlns:a16="http://schemas.microsoft.com/office/drawing/2014/main" id="{17AE7388-ACF0-4723-826B-09D78344B1A4}"/>
+                <a16:creationId xmlns:a16="http://schemas.microsoft.com/office/drawing/2014/main" id="{32F44D2C-4147-49EA-B2EB-C4A0482CFEDF}"/>
               </a:ext>
             </a:extLst>
           </p:cNvPr>
@@ -32558,7 +32558,7 @@
           <p:cNvPr id="17" name="">
             <a:extLst xmlns:a="http://schemas.openxmlformats.org/drawingml/2006/main">
               <a:ext uri="{FF2B5EF4-FFF2-40B4-BE49-F238E27FC236}">
-                <a16:creationId xmlns:a16="http://schemas.microsoft.com/office/drawing/2014/main" id="{8AB941BE-EEA2-4DC7-B74D-EEEE08DDB4A8}"/>
+                <a16:creationId xmlns:a16="http://schemas.microsoft.com/office/drawing/2014/main" id="{91B596DB-7CE5-4DAE-AB18-EDFDCD6CE8AC}"/>
               </a:ext>
             </a:extLst>
           </p:cNvPr>
@@ -32713,7 +32713,7 @@
     </p:spTree>
     <p:extLst>
       <p:ext uri="{BB962C8B-B14F-4D97-AF65-F5344CB8AC3E}">
-        <p14:creationId xmlns:p14="http://schemas.microsoft.com/office/powerpoint/2010/main" val="2025830658"/>
+        <p14:creationId xmlns:p14="http://schemas.microsoft.com/office/powerpoint/2010/main" val="2106789842"/>
       </p:ext>
     </p:extLst>
   </p:cSld>
@@ -32744,7 +32744,7 @@
           <p:cNvPr id="18" name="">
             <a:extLst xmlns:a="http://schemas.openxmlformats.org/drawingml/2006/main">
               <a:ext uri="{FF2B5EF4-FFF2-40B4-BE49-F238E27FC236}">
-                <a16:creationId xmlns:a16="http://schemas.microsoft.com/office/drawing/2014/main" id="{28E70C53-595D-412C-831D-F79F68E75B75}"/>
+                <a16:creationId xmlns:a16="http://schemas.microsoft.com/office/drawing/2014/main" id="{8D2C3EF5-FA7F-4FAA-9AE6-87370338E95F}"/>
               </a:ext>
             </a:extLst>
           </p:cNvPr>
@@ -32901,7 +32901,7 @@
           <p:cNvPr id="2" name="">
             <a:extLst xmlns:a="http://schemas.openxmlformats.org/drawingml/2006/main">
               <a:ext uri="{FF2B5EF4-FFF2-40B4-BE49-F238E27FC236}">
-                <a16:creationId xmlns:a16="http://schemas.microsoft.com/office/drawing/2014/main" id="{89AF1446-ECA9-4F5A-BF04-63CB5D3E24F4}"/>
+                <a16:creationId xmlns:a16="http://schemas.microsoft.com/office/drawing/2014/main" id="{5580280B-EA26-4E0B-8F61-BCFED7BCE752}"/>
               </a:ext>
             </a:extLst>
           </p:cNvPr>
@@ -32932,7 +32932,7 @@
           <p:cNvPr id="3" name="">
             <a:extLst xmlns:a="http://schemas.openxmlformats.org/drawingml/2006/main">
               <a:ext uri="{FF2B5EF4-FFF2-40B4-BE49-F238E27FC236}">
-                <a16:creationId xmlns:a16="http://schemas.microsoft.com/office/drawing/2014/main" id="{579FCBCE-1238-4516-88E5-CB9A673432C7}"/>
+                <a16:creationId xmlns:a16="http://schemas.microsoft.com/office/drawing/2014/main" id="{2AAB40CB-56C0-4580-90E0-0B8300686213}"/>
               </a:ext>
             </a:extLst>
           </p:cNvPr>
@@ -33089,7 +33089,7 @@
           <p:cNvPr id="4" name="">
             <a:extLst xmlns:a="http://schemas.openxmlformats.org/drawingml/2006/main">
               <a:ext uri="{FF2B5EF4-FFF2-40B4-BE49-F238E27FC236}">
-                <a16:creationId xmlns:a16="http://schemas.microsoft.com/office/drawing/2014/main" id="{6E80B1F7-EF59-4CDC-B216-039B41CE08E9}"/>
+                <a16:creationId xmlns:a16="http://schemas.microsoft.com/office/drawing/2014/main" id="{33520BE2-8C18-43CF-95AF-9DF6E9C866C8}"/>
               </a:ext>
             </a:extLst>
           </p:cNvPr>
@@ -33246,7 +33246,7 @@
           <p:cNvPr id="5" name="">
             <a:extLst xmlns:a="http://schemas.openxmlformats.org/drawingml/2006/main">
               <a:ext uri="{FF2B5EF4-FFF2-40B4-BE49-F238E27FC236}">
-                <a16:creationId xmlns:a16="http://schemas.microsoft.com/office/drawing/2014/main" id="{BF9D6D22-2FD0-4905-9C3C-A2D5FF8B152C}"/>
+                <a16:creationId xmlns:a16="http://schemas.microsoft.com/office/drawing/2014/main" id="{8B8C64E6-DB9A-4233-BC81-78C60507F8E8}"/>
               </a:ext>
             </a:extLst>
           </p:cNvPr>
@@ -33403,7 +33403,7 @@
           <p:cNvPr id="6" name="">
             <a:extLst xmlns:a="http://schemas.openxmlformats.org/drawingml/2006/main">
               <a:ext uri="{FF2B5EF4-FFF2-40B4-BE49-F238E27FC236}">
-                <a16:creationId xmlns:a16="http://schemas.microsoft.com/office/drawing/2014/main" id="{9E7DB6E4-DF5E-4E35-92FC-C0A1A6C41004}"/>
+                <a16:creationId xmlns:a16="http://schemas.microsoft.com/office/drawing/2014/main" id="{55E70437-A0BC-46F7-ADBF-891D2F8F6C2E}"/>
               </a:ext>
             </a:extLst>
           </p:cNvPr>
@@ -34217,7 +34217,7 @@
           <p:cNvPr id="7" name="">
             <a:extLst xmlns:a="http://schemas.openxmlformats.org/drawingml/2006/main">
               <a:ext uri="{FF2B5EF4-FFF2-40B4-BE49-F238E27FC236}">
-                <a16:creationId xmlns:a16="http://schemas.microsoft.com/office/drawing/2014/main" id="{3C2D7A77-2BED-4608-B7E6-EDCB05FC9A13}"/>
+                <a16:creationId xmlns:a16="http://schemas.microsoft.com/office/drawing/2014/main" id="{27599A4A-849C-40D6-8198-708BD43A1085}"/>
               </a:ext>
             </a:extLst>
           </p:cNvPr>
@@ -34374,7 +34374,7 @@
           <p:cNvPr id="8" name="">
             <a:extLst xmlns:a="http://schemas.openxmlformats.org/drawingml/2006/main">
               <a:ext uri="{FF2B5EF4-FFF2-40B4-BE49-F238E27FC236}">
-                <a16:creationId xmlns:a16="http://schemas.microsoft.com/office/drawing/2014/main" id="{9AE7F1EE-E86F-4B45-A038-F4F60EBD5C26}"/>
+                <a16:creationId xmlns:a16="http://schemas.microsoft.com/office/drawing/2014/main" id="{5C404FA9-4BA2-4405-83B7-46A088548D17}"/>
               </a:ext>
             </a:extLst>
           </p:cNvPr>
@@ -34531,7 +34531,7 @@
           <p:cNvPr id="9" name="">
             <a:extLst xmlns:a="http://schemas.openxmlformats.org/drawingml/2006/main">
               <a:ext uri="{FF2B5EF4-FFF2-40B4-BE49-F238E27FC236}">
-                <a16:creationId xmlns:a16="http://schemas.microsoft.com/office/drawing/2014/main" id="{FD8458EC-7FFD-492C-B552-29CBA78DFDA4}"/>
+                <a16:creationId xmlns:a16="http://schemas.microsoft.com/office/drawing/2014/main" id="{E1F4D1E3-D8FF-48B7-9B4B-C3D9A29826BB}"/>
               </a:ext>
             </a:extLst>
           </p:cNvPr>
@@ -34688,7 +34688,7 @@
           <p:cNvPr id="10" name="">
             <a:extLst xmlns:a="http://schemas.openxmlformats.org/drawingml/2006/main">
               <a:ext uri="{FF2B5EF4-FFF2-40B4-BE49-F238E27FC236}">
-                <a16:creationId xmlns:a16="http://schemas.microsoft.com/office/drawing/2014/main" id="{220C2435-98E0-4BE8-A155-A03917E2CE0D}"/>
+                <a16:creationId xmlns:a16="http://schemas.microsoft.com/office/drawing/2014/main" id="{B1123C33-175F-40B0-ACC6-296F3CA7979B}"/>
               </a:ext>
             </a:extLst>
           </p:cNvPr>
@@ -34845,7 +34845,7 @@
           <p:cNvPr id="11" name="">
             <a:extLst xmlns:a="http://schemas.openxmlformats.org/drawingml/2006/main">
               <a:ext uri="{FF2B5EF4-FFF2-40B4-BE49-F238E27FC236}">
-                <a16:creationId xmlns:a16="http://schemas.microsoft.com/office/drawing/2014/main" id="{501807FA-134D-4A7C-BE64-00178B96D153}"/>
+                <a16:creationId xmlns:a16="http://schemas.microsoft.com/office/drawing/2014/main" id="{EC573360-C90D-436A-9E01-839DD4A000E5}"/>
               </a:ext>
             </a:extLst>
           </p:cNvPr>
@@ -35002,7 +35002,7 @@
           <p:cNvPr id="12" name="">
             <a:extLst xmlns:a="http://schemas.openxmlformats.org/drawingml/2006/main">
               <a:ext uri="{FF2B5EF4-FFF2-40B4-BE49-F238E27FC236}">
-                <a16:creationId xmlns:a16="http://schemas.microsoft.com/office/drawing/2014/main" id="{19FE29A8-C71D-4CDE-BB98-73ED2E2086C9}"/>
+                <a16:creationId xmlns:a16="http://schemas.microsoft.com/office/drawing/2014/main" id="{EFF27D98-616E-4B25-B106-F8F9B2ABB0A0}"/>
               </a:ext>
             </a:extLst>
           </p:cNvPr>
@@ -35033,7 +35033,7 @@
           <p:cNvPr id="13" name="">
             <a:extLst xmlns:a="http://schemas.openxmlformats.org/drawingml/2006/main">
               <a:ext uri="{FF2B5EF4-FFF2-40B4-BE49-F238E27FC236}">
-                <a16:creationId xmlns:a16="http://schemas.microsoft.com/office/drawing/2014/main" id="{E5856776-0605-4A07-9E2C-B4D20815F47F}"/>
+                <a16:creationId xmlns:a16="http://schemas.microsoft.com/office/drawing/2014/main" id="{F9B06221-F348-4955-8C73-19A1DF68C6A3}"/>
               </a:ext>
             </a:extLst>
           </p:cNvPr>
@@ -35190,7 +35190,7 @@
           <p:cNvPr id="14" name="">
             <a:extLst xmlns:a="http://schemas.openxmlformats.org/drawingml/2006/main">
               <a:ext uri="{FF2B5EF4-FFF2-40B4-BE49-F238E27FC236}">
-                <a16:creationId xmlns:a16="http://schemas.microsoft.com/office/drawing/2014/main" id="{4BFB5A15-0383-4E44-98DA-C77C4AD1967B}"/>
+                <a16:creationId xmlns:a16="http://schemas.microsoft.com/office/drawing/2014/main" id="{E20DCF29-D698-4EA9-BE34-B0D74AF1E609}"/>
               </a:ext>
             </a:extLst>
           </p:cNvPr>
@@ -35201,8 +35201,8 @@
         </p:nvSpPr>
         <p:spPr>
           <a:xfrm xmlns:a="http://schemas.openxmlformats.org/drawingml/2006/main">
-            <a:off x="8477250" y="4400550"/>
-            <a:ext cx="3028950" cy="209550"/>
+            <a:off x="8096250" y="4400550"/>
+            <a:ext cx="3409950" cy="209550"/>
           </a:xfrm>
           <a:prstGeom xmlns:a="http://schemas.openxmlformats.org/drawingml/2006/main" prst="rect">
             <a:avLst/>
@@ -35337,7 +35337,7 @@
                 <a:ea typeface="Songti SC"/>
                 <a:cs typeface="Songti SC"/>
               </a:rPr>
-              <a:t>P6 状态区 · 收尾后仅替换此处</a:t>
+              <a:t>P6 状态区 · 78eaa07 最终公开汇总</a:t>
             </a:r>
           </a:p>
         </p:txBody>
@@ -35347,7 +35347,7 @@
           <p:cNvPr id="15" name="p6-status-update">
             <a:extLst xmlns:a="http://schemas.openxmlformats.org/drawingml/2006/main">
               <a:ext uri="{FF2B5EF4-FFF2-40B4-BE49-F238E27FC236}">
-                <a16:creationId xmlns:a16="http://schemas.microsoft.com/office/drawing/2014/main" id="{2478D472-B845-4121-AA51-EA008BCBB857}"/>
+                <a16:creationId xmlns:a16="http://schemas.microsoft.com/office/drawing/2014/main" id="{C7A0F273-D196-4E57-9BAD-09269D298967}"/>
               </a:ext>
             </a:extLst>
           </p:cNvPr>
@@ -35358,8 +35358,8 @@
         </p:nvSpPr>
         <p:spPr>
           <a:xfrm xmlns:a="http://schemas.openxmlformats.org/drawingml/2006/main">
-            <a:off x="685800" y="4743450"/>
-            <a:ext cx="10287000" cy="723900"/>
+            <a:off x="685800" y="4724400"/>
+            <a:ext cx="10287000" cy="838200"/>
           </a:xfrm>
           <a:prstGeom xmlns:a="http://schemas.openxmlformats.org/drawingml/2006/main" prst="rect">
             <a:avLst/>
@@ -35374,7 +35374,7 @@
           <a:bodyPr xmlns:a="http://schemas.openxmlformats.org/drawingml/2006/main" lIns="0" tIns="0" rIns="0" bIns="0" anchor="t"/>
           <a:lstStyle xmlns:a="http://schemas.openxmlformats.org/drawingml/2006/main">
             <a:defPPr algn="l">
-              <a:defRPr sz="1425" b="0" i="0">
+              <a:defRPr sz="1110" b="0" i="0">
                 <a:solidFill>
                   <a:srgbClr val="F7F1E6"/>
                 </a:solidFill>
@@ -35384,7 +35384,7 @@
               </a:defRPr>
             </a:defPPr>
             <a:lvl1pPr algn="l">
-              <a:defRPr sz="1425" b="0" i="0">
+              <a:defRPr sz="1110" b="0" i="0">
                 <a:solidFill>
                   <a:srgbClr val="F7F1E6"/>
                 </a:solidFill>
@@ -35394,7 +35394,7 @@
               </a:defRPr>
             </a:lvl1pPr>
             <a:lvl2pPr algn="l">
-              <a:defRPr sz="1425" b="0" i="0">
+              <a:defRPr sz="1110" b="0" i="0">
                 <a:solidFill>
                   <a:srgbClr val="F7F1E6"/>
                 </a:solidFill>
@@ -35404,7 +35404,7 @@
               </a:defRPr>
             </a:lvl2pPr>
             <a:lvl3pPr algn="l">
-              <a:defRPr sz="1425" b="0" i="0">
+              <a:defRPr sz="1110" b="0" i="0">
                 <a:solidFill>
                   <a:srgbClr val="F7F1E6"/>
                 </a:solidFill>
@@ -35414,7 +35414,7 @@
               </a:defRPr>
             </a:lvl3pPr>
             <a:lvl4pPr algn="l">
-              <a:defRPr sz="1425" b="0" i="0">
+              <a:defRPr sz="1110" b="0" i="0">
                 <a:solidFill>
                   <a:srgbClr val="F7F1E6"/>
                 </a:solidFill>
@@ -35424,7 +35424,7 @@
               </a:defRPr>
             </a:lvl4pPr>
             <a:lvl5pPr algn="l">
-              <a:defRPr sz="1425" b="0" i="0">
+              <a:defRPr sz="1110" b="0" i="0">
                 <a:solidFill>
                   <a:srgbClr val="F7F1E6"/>
                 </a:solidFill>
@@ -35434,7 +35434,7 @@
               </a:defRPr>
             </a:lvl5pPr>
             <a:lvl6pPr algn="l">
-              <a:defRPr sz="1425" b="0" i="0">
+              <a:defRPr sz="1110" b="0" i="0">
                 <a:solidFill>
                   <a:srgbClr val="F7F1E6"/>
                 </a:solidFill>
@@ -35444,7 +35444,7 @@
               </a:defRPr>
             </a:lvl6pPr>
             <a:lvl7pPr algn="l">
-              <a:defRPr sz="1425" b="0" i="0">
+              <a:defRPr sz="1110" b="0" i="0">
                 <a:solidFill>
                   <a:srgbClr val="F7F1E6"/>
                 </a:solidFill>
@@ -35454,7 +35454,7 @@
               </a:defRPr>
             </a:lvl7pPr>
             <a:lvl8pPr algn="l">
-              <a:defRPr sz="1425" b="0" i="0">
+              <a:defRPr sz="1110" b="0" i="0">
                 <a:solidFill>
                   <a:srgbClr val="F7F1E6"/>
                 </a:solidFill>
@@ -35464,7 +35464,7 @@
               </a:defRPr>
             </a:lvl8pPr>
             <a:lvl9pPr algn="l">
-              <a:defRPr sz="1425" b="0" i="0">
+              <a:defRPr sz="1110" b="0" i="0">
                 <a:solidFill>
                   <a:srgbClr val="F7F1E6"/>
                 </a:solidFill>
@@ -35476,7 +35476,7 @@
           </a:lstStyle>
           <a:p xmlns:a="http://schemas.openxmlformats.org/drawingml/2006/main">
             <a:pPr algn="l">
-              <a:defRPr sz="1425" b="0" i="0">
+              <a:defRPr sz="1110" b="0" i="0">
                 <a:solidFill>
                   <a:srgbClr val="F7F1E6"/>
                 </a:solidFill>
@@ -35486,7 +35486,7 @@
               </a:defRPr>
             </a:pPr>
             <a:r>
-              <a:rPr sz="1425" b="0" i="0">
+              <a:rPr sz="1110" b="0" i="0">
                 <a:solidFill>
                   <a:srgbClr val="F7F1E6"/>
                 </a:solidFill>
@@ -35494,12 +35494,12 @@
                 <a:ea typeface="Songti SC"/>
                 <a:cs typeface="Songti SC"/>
               </a:rPr>
-              <a:t>截至 2026-10-30 的 P6 收尾前快照：全池 86/92；已确认证据不足 0；无题目完成两遍完整确认。</a:t>
+              <a:t>全池 92/92；6 题均两遍完整核验；确认证据不足 0；正确弃答率 N/A（分母 0）。</a:t>
             </a:r>
           </a:p>
           <a:p xmlns:a="http://schemas.openxmlformats.org/drawingml/2006/main">
             <a:pPr algn="l">
-              <a:defRPr sz="1425" b="0" i="0">
+              <a:defRPr sz="1110" b="0" i="0">
                 <a:solidFill>
                   <a:srgbClr val="F7F1E6"/>
                 </a:solidFill>
@@ -35509,7 +35509,7 @@
               </a:defRPr>
             </a:pPr>
             <a:r>
-              <a:rPr sz="1425" b="0" i="0">
+              <a:rPr sz="1110" b="0" i="0">
                 <a:solidFill>
                   <a:srgbClr val="F7F1E6"/>
                 </a:solidFill>
@@ -35517,7 +35517,53 @@
                 <a:ea typeface="Songti SC"/>
                 <a:cs typeface="Songti SC"/>
               </a:rPr>
-              <a:t>48 个答案：32 ok / 15 empty / 1 error；1 个生产失败保留在队列；不是永久终稿。</a:t>
+              <a:t>48 答案：32 ok / 15 empty / 1 error · itsdangerous：347来源/30讨论/82实体/78关系/180证据。</a:t>
+            </a:r>
+          </a:p>
+          <a:p xmlns:a="http://schemas.openxmlformats.org/drawingml/2006/main">
+            <a:pPr algn="l">
+              <a:defRPr sz="1110" b="0" i="0">
+                <a:solidFill>
+                  <a:srgbClr val="F7F1E6"/>
+                </a:solidFill>
+                <a:latin typeface="Songti SC"/>
+                <a:ea typeface="Songti SC"/>
+                <a:cs typeface="Songti SC"/>
+              </a:defRPr>
+            </a:pPr>
+            <a:r>
+              <a:rPr sz="1110" b="0" i="0">
+                <a:solidFill>
+                  <a:srgbClr val="F7F1E6"/>
+                </a:solidFill>
+                <a:latin typeface="Songti SC"/>
+                <a:ea typeface="Songti SC"/>
+                <a:cs typeface="Songti SC"/>
+              </a:rPr>
+              <a:t>itsdangerous 为 partial（保留记录缺口），但 validate/graph/retrieval ready；依赖查询 50路径/25证据/5 claims，出处全通过。</a:t>
+            </a:r>
+          </a:p>
+          <a:p xmlns:a="http://schemas.openxmlformats.org/drawingml/2006/main">
+            <a:pPr algn="l">
+              <a:defRPr sz="1110" b="0" i="0">
+                <a:solidFill>
+                  <a:srgbClr val="F7F1E6"/>
+                </a:solidFill>
+                <a:latin typeface="Songti SC"/>
+                <a:ea typeface="Songti SC"/>
+                <a:cs typeface="Songti SC"/>
+              </a:defRPr>
+            </a:pPr>
+            <a:r>
+              <a:rPr sz="1110" b="0" i="0">
+                <a:solidFill>
+                  <a:srgbClr val="F7F1E6"/>
+                </a:solidFill>
+                <a:latin typeface="Songti SC"/>
+                <a:ea typeface="Songti SC"/>
+                <a:cs typeface="Songti SC"/>
+              </a:rPr>
+              <a:t>预算累计 9.465795 / 剩余 10.374205。</a:t>
             </a:r>
           </a:p>
         </p:txBody>
@@ -35527,7 +35573,7 @@
           <p:cNvPr id="16" name="">
             <a:extLst xmlns:a="http://schemas.openxmlformats.org/drawingml/2006/main">
               <a:ext uri="{FF2B5EF4-FFF2-40B4-BE49-F238E27FC236}">
-                <a16:creationId xmlns:a16="http://schemas.microsoft.com/office/drawing/2014/main" id="{69C45AB4-214E-4652-A100-25F39BD16488}"/>
+                <a16:creationId xmlns:a16="http://schemas.microsoft.com/office/drawing/2014/main" id="{7167F246-947C-4689-97A8-9D76D27EC38D}"/>
               </a:ext>
             </a:extLst>
           </p:cNvPr>
@@ -35684,7 +35730,7 @@
           <p:cNvPr id="17" name="">
             <a:extLst xmlns:a="http://schemas.openxmlformats.org/drawingml/2006/main">
               <a:ext uri="{FF2B5EF4-FFF2-40B4-BE49-F238E27FC236}">
-                <a16:creationId xmlns:a16="http://schemas.microsoft.com/office/drawing/2014/main" id="{88EA30BA-BA27-4672-A97E-97C0DD976969}"/>
+                <a16:creationId xmlns:a16="http://schemas.microsoft.com/office/drawing/2014/main" id="{B98F68E3-B2A8-49D6-9055-64CFB8727574}"/>
               </a:ext>
             </a:extLst>
           </p:cNvPr>
@@ -35831,7 +35877,7 @@
                 <a:ea typeface="Songti SC"/>
                 <a:cs typeface="Songti SC"/>
               </a:rPr>
-              <a:t>局限：单一 Flask · 模型银标 · 小样本 · 图扩展增加无依据断言 · 全池与第二小库以 P6 收尾状态为准</a:t>
+              <a:t>真实残余：单一 Flask · 模型银标 · 小样本 · 图扩展增加无依据断言 · Neo4j 未现场重连 · Windows/PowerPoint 实机未验证</a:t>
             </a:r>
           </a:p>
         </p:txBody>
@@ -35839,7 +35885,7 @@
     </p:spTree>
     <p:extLst>
       <p:ext uri="{BB962C8B-B14F-4D97-AF65-F5344CB8AC3E}">
-        <p14:creationId xmlns:p14="http://schemas.microsoft.com/office/powerpoint/2010/main" val="1181492069"/>
+        <p14:creationId xmlns:p14="http://schemas.microsoft.com/office/powerpoint/2010/main" val="1568246393"/>
       </p:ext>
     </p:extLst>
   </p:cSld>

</xml_diff>

<commit_message>
docs(p5): record live neo4j extension validation
</commit_message>
<xml_diff>
--- a/demo/final/期末汇报_20261030最终版.pptx
+++ b/demo/final/期末汇报_20261030最终版.pptx
@@ -2,22 +2,22 @@
 <file path=ppt/presentation.xml><?xml version="1.0" encoding="utf-8"?>
 <p:presentation xmlns:p="http://schemas.openxmlformats.org/presentationml/2006/main">
   <p:sldMasterIdLst>
-    <p:sldMasterId xmlns:r="http://schemas.openxmlformats.org/officeDocument/2006/relationships" id="2147483648" r:id="R3b67597d745e454b"/>
+    <p:sldMasterId xmlns:r="http://schemas.openxmlformats.org/officeDocument/2006/relationships" id="2147483648" r:id="Re844a03f252743af"/>
   </p:sldMasterIdLst>
   <p:notesMasterIdLst>
-    <p:notesMasterId xmlns:r="http://schemas.openxmlformats.org/officeDocument/2006/relationships" r:id="R5b047af2b6d347e8"/>
+    <p:notesMasterId xmlns:r="http://schemas.openxmlformats.org/officeDocument/2006/relationships" r:id="R1e34b3f07dea4375"/>
   </p:notesMasterIdLst>
   <p:sldIdLst>
-    <p:sldId xmlns:r="http://schemas.openxmlformats.org/officeDocument/2006/relationships" id="256" r:id="R6b0e308c0fae4828"/>
-    <p:sldId xmlns:r="http://schemas.openxmlformats.org/officeDocument/2006/relationships" id="257" r:id="Rd7d12c8d33b8411a"/>
-    <p:sldId xmlns:r="http://schemas.openxmlformats.org/officeDocument/2006/relationships" id="258" r:id="R1a01b8e1f40e49af"/>
-    <p:sldId xmlns:r="http://schemas.openxmlformats.org/officeDocument/2006/relationships" id="259" r:id="R08729ad4c8df4634"/>
-    <p:sldId xmlns:r="http://schemas.openxmlformats.org/officeDocument/2006/relationships" id="260" r:id="Rc31a3a765e3d4c90"/>
-    <p:sldId xmlns:r="http://schemas.openxmlformats.org/officeDocument/2006/relationships" id="261" r:id="Rdc8cd94608c34848"/>
-    <p:sldId xmlns:r="http://schemas.openxmlformats.org/officeDocument/2006/relationships" id="262" r:id="R4f1aa1840fca48aa"/>
-    <p:sldId xmlns:r="http://schemas.openxmlformats.org/officeDocument/2006/relationships" id="263" r:id="R6ec32f262ac94b87"/>
-    <p:sldId xmlns:r="http://schemas.openxmlformats.org/officeDocument/2006/relationships" id="264" r:id="R47faa14b84de482b"/>
-    <p:sldId xmlns:r="http://schemas.openxmlformats.org/officeDocument/2006/relationships" id="265" r:id="Rd467b29013294cc9"/>
+    <p:sldId xmlns:r="http://schemas.openxmlformats.org/officeDocument/2006/relationships" id="256" r:id="Rc4175bb1149c4d51"/>
+    <p:sldId xmlns:r="http://schemas.openxmlformats.org/officeDocument/2006/relationships" id="257" r:id="R7f172dc2bf0740ad"/>
+    <p:sldId xmlns:r="http://schemas.openxmlformats.org/officeDocument/2006/relationships" id="258" r:id="R3e002a70f2f54581"/>
+    <p:sldId xmlns:r="http://schemas.openxmlformats.org/officeDocument/2006/relationships" id="259" r:id="R9b87d692e6e94d07"/>
+    <p:sldId xmlns:r="http://schemas.openxmlformats.org/officeDocument/2006/relationships" id="260" r:id="R79c58437c0b24e49"/>
+    <p:sldId xmlns:r="http://schemas.openxmlformats.org/officeDocument/2006/relationships" id="261" r:id="R8d74ce19a6e64fee"/>
+    <p:sldId xmlns:r="http://schemas.openxmlformats.org/officeDocument/2006/relationships" id="262" r:id="Rec19fa50b1754ec1"/>
+    <p:sldId xmlns:r="http://schemas.openxmlformats.org/officeDocument/2006/relationships" id="263" r:id="R2ce3f65f940a4644"/>
+    <p:sldId xmlns:r="http://schemas.openxmlformats.org/officeDocument/2006/relationships" id="264" r:id="Rdde07682c8824239"/>
+    <p:sldId xmlns:r="http://schemas.openxmlformats.org/officeDocument/2006/relationships" id="265" r:id="Rd18927fedb654a40"/>
   </p:sldIdLst>
   <p:sldSz cx="12192000" cy="6858000"/>
   <p:notesSz cx="6858000" cy="9144000"/>
@@ -521,7 +521,7 @@
           <a:lstStyle xmlns:a="http://schemas.openxmlformats.org/drawingml/2006/main"/>
           <a:p xmlns:a="http://schemas.openxmlformats.org/drawingml/2006/main">
             <a:r>
-              <a:t>建议约40秒。最后一页把已完成结果和不能外推的边界分开。系统已经完成真实 Flask URL 到采集、抽取、建图、检索和带出处问答的闭环；P6 还完成了 pallets/itsdangerous 的第二小库迁移检查，得到可核对的依赖查询答案。冻结包可以复现，在线重跑需要使用者自己的 API 与预算。结论是系统可运行、可追溯、可复现，但图谱收益没有在本次小样本中显著成立，正确弃答率因合格分母为 0 而保持 N/A，不能解释为核验失败。仍未外推的是一般图收益、任意仓库适用性；当前真实残余包括 Neo4j 在最终审计时未能现场重连、Windows 与 PowerPoint 原生检查未完成。六角色分工见表，姓名、学号和正式互评全部保留待本人补充，不虚构。P4 前期独立调研、方案、架构、协作框架、试跑和采集器移植保留原归属。来源：reports/technical_report.md第8–9章；feat/p6-formal-results 78eaa07 的 final_acceptance.json 与 P6 handoff；deliveries/P1/2026-10-30/handoff.md；deliveries/P4/2026-10-27/handoff.md；coordination/STATUS_P5.md。</a:t>
+              <a:t>建议约40秒。最后一页把已完成结果和不能外推的边界分开。系统已经完成真实 Flask URL 到采集、抽取、建图、检索和带出处问答的闭环；P6 还完成了 pallets/itsdangerous 的第二小库迁移检查，得到可核对的依赖查询答案。冻结包可以复现，在线重跑需要使用者自己的 API 与预算。结论是系统可运行、可追溯、可复现，但图谱收益没有在本次小样本中显著成立，正确弃答率因合格分母为 0 而保持 N/A，不能解释为核验失败。仍未外推的是一般图收益、任意仓库适用性。Neo4j 执行边界已核实：主代理恢复持久服务后，P2 在公开提交 19602e6 使用真实 Neo4j/PostgreSQL 完成扩展数据集加载和 PR #6096 四跳验收，26 项真实服务回归通过，两条方向路径分别为 author-to-function 与 function-to-merger；当前生产图仍是旧 1.4.1，新增实体来自真实新数据版本重放。其他真实残余是 Windows 字体、PowerPoint 原生检查、课堂彩排和成员信息。六角色分工见表，姓名、学号和正式互评全部保留待本人补充，不虚构。P4 前期独立调研、方案、架构、协作框架、试跑和采集器移植保留原归属。来源：P2 公开提交 19602e6 的 cross_source_chain.json、handoff 与 STATUS_P2；reports/technical_report.md第8–9章；feat/p6-formal-results 78eaa07 的 final_acceptance.json 与 P6 handoff；deliveries/P1/2026-10-30/handoff.md；deliveries/P4/2026-10-27/handoff.md；coordination/STATUS_P5.md。</a:t>
             </a:r>
           </a:p>
         </p:txBody>
@@ -1081,7 +1081,7 @@
           <a:lstStyle xmlns:a="http://schemas.openxmlformats.org/drawingml/2006/main"/>
           <a:p xmlns:a="http://schemas.openxmlformats.org/drawingml/2006/main">
             <a:r>
-              <a:t>建议约100秒。20 道测试题上，A 组事实覆盖 0.600、证据组召回 0.636、无依据断言率 0.026；B 组分别是 0.740、0.691 和 0.043。B-A 配对事实覆盖差是 0.157，但配对胜负为 B 胜 5、A 胜 4、平 6，固定种子 95% 描述性 bootstrap 区间是 [-0.122,0.457]，跨零，因此不能宣称图扩展有显著收益。P6 最终公开结果为全池 92/92；6 道候选题均完成两遍完整核验，确认证据不足为 0。正确弃答率仍为 N/A，但原因是分子和合格分母都为 0，表示没有确认不足题，不再表示核验未完成。48 个 A/B 答案仍完整保留为 32 ok、15 empty、1 error，不能把空回答改写成正确弃答。第二小库 pallets/itsdangerous 得到 347 来源、30 完整讨论、82 实体、78 关系和 180 证据；job 仍为 partial 并保留记录缺口，但 validate、graph、retrieval 均 ready。依赖查询返回 50 条路径、25 条证据和 5 条 claims，所有 cited evidence、原文引文和来源哈希复核通过。共享账本保守累计 9.465795 元，剩余 10.374205 元。第 9 页下方 p6-status-update 是唯一 P6 状态区，数据来自公开提交 78eaa07。真实残余仍是单一 Flask、模型银标、小样本、图扩展增加无依据断言、Neo4j 未现场重连、Windows 与 PowerPoint 实机未验证。来源：feat/p6-formal-results 78eaa07 的 evaluation/results/formal_summary.json、final_acceptance.json、second_repo_acceptance.json 和 P6 handoff。</a:t>
+              <a:t>建议约100秒。20 道测试题上，A 组事实覆盖 0.600、证据组召回 0.636、无依据断言率 0.026；B 组分别是 0.740、0.691 和 0.043。B-A 配对事实覆盖差是 0.157，但配对胜负为 B 胜 5、A 胜 4、平 6，固定种子 95% 描述性 bootstrap 区间是 [-0.122,0.457]，跨零，因此不能宣称图扩展有显著收益。P6 最终公开结果为全池 92/92；6 道候选题均完成两遍完整核验，确认证据不足为 0。正确弃答率仍为 N/A，但原因是分子和合格分母都为 0，表示没有确认不足题，不再表示核验未完成。48 个 A/B 答案仍完整保留为 32 ok、15 empty、1 error，不能把空回答改写成正确弃答。第二小库 pallets/itsdangerous 得到 347 来源、30 完整讨论、82 实体、78 关系和 180 证据；job 仍为 partial 并保留记录缺口，但 validate、graph、retrieval 均 ready。依赖查询返回 50 条路径、25 条证据和 5 条 claims，所有 cited evidence、原文引文和来源哈希复核通过。共享账本保守累计 9.465795 元，剩余 10.374205 元。第 9 页下方 p6-status-update 是唯一 P6 状态区，数据来自公开提交 78eaa07。Neo4j 执行边界已核实：主代理已恢复持久服务，P2 使用真实 Neo4j/PostgreSQL 完成扩展数据集加载和 PR #6096 四跳验收，26 项真实服务回归通过，包含 author-to-function 与 function-to-merger 两条方向路径。当前生产图仍为旧 1.4.1，新增实体来自真实新数据版本重放，不是生产图原地补写。其他真实残余是单一 Flask、模型银标、小样本、无依据断言增加、Windows 字体与 PowerPoint 原生未验证、课堂彩排待完成。来源：P2 公开提交 19602e6 的 cross_source_chain.json、handoff 与 STATUS_P2；feat/p6-formal-results 78eaa07 的 evaluation/results/formal_summary.json、final_acceptance.json、second_repo_acceptance.json 和 P6 handoff。</a:t>
             </a:r>
           </a:p>
         </p:txBody>
@@ -1128,7 +1128,7 @@
           <p:cNvPr id="3" name="Title">
             <a:extLst xmlns:a="http://schemas.openxmlformats.org/drawingml/2006/main">
               <a:ext uri="{FF2B5EF4-FFF2-40B4-BE49-F238E27FC236}">
-                <a16:creationId xmlns:a16="http://schemas.microsoft.com/office/drawing/2014/main" id="{C4C428A1-1C7D-4667-98D9-17AC389B4C94}"/>
+                <a16:creationId xmlns:a16="http://schemas.microsoft.com/office/drawing/2014/main" id="{AD422AF9-8361-42A1-A7FC-F2287EB48936}"/>
               </a:ext>
             </a:extLst>
           </p:cNvPr>
@@ -1357,7 +1357,7 @@
           <p:cNvPr id="2" name="Subtitle">
             <a:extLst xmlns:a="http://schemas.openxmlformats.org/drawingml/2006/main">
               <a:ext uri="{FF2B5EF4-FFF2-40B4-BE49-F238E27FC236}">
-                <a16:creationId xmlns:a16="http://schemas.microsoft.com/office/drawing/2014/main" id="{925AB974-4FDD-490F-A7AB-9FA13FCA8B13}"/>
+                <a16:creationId xmlns:a16="http://schemas.microsoft.com/office/drawing/2014/main" id="{7943E618-C584-4E8E-9008-7FC3F47B44C2}"/>
               </a:ext>
             </a:extLst>
           </p:cNvPr>
@@ -1603,7 +1603,7 @@
           <p:cNvPr id="2" name="Section title">
             <a:extLst xmlns:a="http://schemas.openxmlformats.org/drawingml/2006/main">
               <a:ext uri="{FF2B5EF4-FFF2-40B4-BE49-F238E27FC236}">
-                <a16:creationId xmlns:a16="http://schemas.microsoft.com/office/drawing/2014/main" id="{08A04146-8E30-4AD2-A54E-D9DE7778803F}"/>
+                <a16:creationId xmlns:a16="http://schemas.microsoft.com/office/drawing/2014/main" id="{E594E83F-5152-46DC-B723-DC579D0B5FD5}"/>
               </a:ext>
             </a:extLst>
           </p:cNvPr>
@@ -1849,7 +1849,7 @@
           <p:cNvPr id="3" name="Title">
             <a:extLst xmlns:a="http://schemas.openxmlformats.org/drawingml/2006/main">
               <a:ext uri="{FF2B5EF4-FFF2-40B4-BE49-F238E27FC236}">
-                <a16:creationId xmlns:a16="http://schemas.microsoft.com/office/drawing/2014/main" id="{47A77AE2-A747-4256-A1C3-9D789C2AAC79}"/>
+                <a16:creationId xmlns:a16="http://schemas.microsoft.com/office/drawing/2014/main" id="{57BFA17F-E492-4FA3-8ADD-4EE6BE02F6C1}"/>
               </a:ext>
             </a:extLst>
           </p:cNvPr>
@@ -2078,7 +2078,7 @@
           <p:cNvPr id="2" name="Body">
             <a:extLst xmlns:a="http://schemas.openxmlformats.org/drawingml/2006/main">
               <a:ext uri="{FF2B5EF4-FFF2-40B4-BE49-F238E27FC236}">
-                <a16:creationId xmlns:a16="http://schemas.microsoft.com/office/drawing/2014/main" id="{712EA308-0056-412A-B04D-2B5B5EEE4794}"/>
+                <a16:creationId xmlns:a16="http://schemas.microsoft.com/office/drawing/2014/main" id="{2BEB488B-A910-49D3-B2A4-626C38A317CD}"/>
               </a:ext>
             </a:extLst>
           </p:cNvPr>
@@ -2324,7 +2324,7 @@
           <p:cNvPr id="4" name="Title">
             <a:extLst xmlns:a="http://schemas.openxmlformats.org/drawingml/2006/main">
               <a:ext uri="{FF2B5EF4-FFF2-40B4-BE49-F238E27FC236}">
-                <a16:creationId xmlns:a16="http://schemas.microsoft.com/office/drawing/2014/main" id="{9DEDD542-A1E1-42E4-8DF6-9009566173E1}"/>
+                <a16:creationId xmlns:a16="http://schemas.microsoft.com/office/drawing/2014/main" id="{8ECEDAE2-2DE4-485A-B5A8-C066FD78EA4C}"/>
               </a:ext>
             </a:extLst>
           </p:cNvPr>
@@ -2553,7 +2553,7 @@
           <p:cNvPr id="2" name="Left column">
             <a:extLst xmlns:a="http://schemas.openxmlformats.org/drawingml/2006/main">
               <a:ext uri="{FF2B5EF4-FFF2-40B4-BE49-F238E27FC236}">
-                <a16:creationId xmlns:a16="http://schemas.microsoft.com/office/drawing/2014/main" id="{200DDD9F-7854-48E1-9D39-1E571292E340}"/>
+                <a16:creationId xmlns:a16="http://schemas.microsoft.com/office/drawing/2014/main" id="{94EB74A9-E9E5-4F58-BD5A-C7AB75FCAF93}"/>
               </a:ext>
             </a:extLst>
           </p:cNvPr>
@@ -2782,7 +2782,7 @@
           <p:cNvPr id="3" name="Right column">
             <a:extLst xmlns:a="http://schemas.openxmlformats.org/drawingml/2006/main">
               <a:ext uri="{FF2B5EF4-FFF2-40B4-BE49-F238E27FC236}">
-                <a16:creationId xmlns:a16="http://schemas.microsoft.com/office/drawing/2014/main" id="{64CDE508-FDAC-4D75-9E70-E19A2318058D}"/>
+                <a16:creationId xmlns:a16="http://schemas.microsoft.com/office/drawing/2014/main" id="{1C4ECE2D-9435-4427-94D5-4AC51F232BD2}"/>
               </a:ext>
             </a:extLst>
           </p:cNvPr>
@@ -3028,7 +3028,7 @@
           <p:cNvPr id="3" name="Title">
             <a:extLst xmlns:a="http://schemas.openxmlformats.org/drawingml/2006/main">
               <a:ext uri="{FF2B5EF4-FFF2-40B4-BE49-F238E27FC236}">
-                <a16:creationId xmlns:a16="http://schemas.microsoft.com/office/drawing/2014/main" id="{27B133AC-4C5C-4EC9-8D40-137E0D001941}"/>
+                <a16:creationId xmlns:a16="http://schemas.microsoft.com/office/drawing/2014/main" id="{BED95923-BCD0-41CD-A468-8D8F40DE4699}"/>
               </a:ext>
             </a:extLst>
           </p:cNvPr>
@@ -3257,7 +3257,7 @@
           <p:cNvPr id="2" name="Left column">
             <a:extLst xmlns:a="http://schemas.openxmlformats.org/drawingml/2006/main">
               <a:ext uri="{FF2B5EF4-FFF2-40B4-BE49-F238E27FC236}">
-                <a16:creationId xmlns:a16="http://schemas.microsoft.com/office/drawing/2014/main" id="{4CA92564-F14F-491B-9BD2-08A0EA6E9EF9}"/>
+                <a16:creationId xmlns:a16="http://schemas.microsoft.com/office/drawing/2014/main" id="{AB63ED8F-79E2-4496-966F-66B39EAD7600}"/>
               </a:ext>
             </a:extLst>
           </p:cNvPr>
@@ -3524,12 +3524,12 @@
   </p:cSld>
   <p:clrMap bg1="lt1" tx1="dk1" bg2="lt2" tx2="dk2" accent1="accent1" accent2="accent2" accent3="accent3" accent4="accent4" accent5="accent5" accent6="accent6" hlink="hlink" folHlink="folHlink"/>
   <p:sldLayoutIdLst>
-    <p:sldLayoutId xmlns:r="http://schemas.openxmlformats.org/officeDocument/2006/relationships" id="2147483649" r:id="R3fb4b4e8c5b9498d"/>
-    <p:sldLayoutId xmlns:r="http://schemas.openxmlformats.org/officeDocument/2006/relationships" id="2147483650" r:id="R7efa4a545a874d3d"/>
-    <p:sldLayoutId xmlns:r="http://schemas.openxmlformats.org/officeDocument/2006/relationships" id="2147483651" r:id="Rfb403c061b054bc9"/>
-    <p:sldLayoutId xmlns:r="http://schemas.openxmlformats.org/officeDocument/2006/relationships" id="2147483652" r:id="R3e07072a79a143cc"/>
-    <p:sldLayoutId xmlns:r="http://schemas.openxmlformats.org/officeDocument/2006/relationships" id="2147483653" r:id="R5ed6c64d88e5442c"/>
-    <p:sldLayoutId xmlns:r="http://schemas.openxmlformats.org/officeDocument/2006/relationships" id="2147483654" r:id="Re20a7fd823d34d42"/>
+    <p:sldLayoutId xmlns:r="http://schemas.openxmlformats.org/officeDocument/2006/relationships" id="2147483649" r:id="R85f3d78d27a84f9d"/>
+    <p:sldLayoutId xmlns:r="http://schemas.openxmlformats.org/officeDocument/2006/relationships" id="2147483650" r:id="R6e8f16f613d540c1"/>
+    <p:sldLayoutId xmlns:r="http://schemas.openxmlformats.org/officeDocument/2006/relationships" id="2147483651" r:id="R8195bfe0d4c94251"/>
+    <p:sldLayoutId xmlns:r="http://schemas.openxmlformats.org/officeDocument/2006/relationships" id="2147483652" r:id="Rcbb8aae3bbf54a4e"/>
+    <p:sldLayoutId xmlns:r="http://schemas.openxmlformats.org/officeDocument/2006/relationships" id="2147483653" r:id="R32e4a170f16b4f83"/>
+    <p:sldLayoutId xmlns:r="http://schemas.openxmlformats.org/officeDocument/2006/relationships" id="2147483654" r:id="R0743cab905604e23"/>
   </p:sldLayoutIdLst>
   <p:txStyles>
     <p:titleStyle>
@@ -4338,7 +4338,7 @@
           <p:cNvPr id="10" name="">
             <a:extLst xmlns:a="http://schemas.openxmlformats.org/drawingml/2006/main">
               <a:ext uri="{FF2B5EF4-FFF2-40B4-BE49-F238E27FC236}">
-                <a16:creationId xmlns:a16="http://schemas.microsoft.com/office/drawing/2014/main" id="{1044C5EB-BDF8-4631-A187-2F5AE8FE2B3E}"/>
+                <a16:creationId xmlns:a16="http://schemas.microsoft.com/office/drawing/2014/main" id="{DB8912EE-E7EC-484F-A84E-EE413AB9F634}"/>
               </a:ext>
             </a:extLst>
           </p:cNvPr>
@@ -4369,7 +4369,7 @@
           <p:cNvPr id="2" name="">
             <a:extLst xmlns:a="http://schemas.openxmlformats.org/drawingml/2006/main">
               <a:ext uri="{FF2B5EF4-FFF2-40B4-BE49-F238E27FC236}">
-                <a16:creationId xmlns:a16="http://schemas.microsoft.com/office/drawing/2014/main" id="{15AFECCB-6EDF-4A69-9D46-13A0ADD9BBD0}"/>
+                <a16:creationId xmlns:a16="http://schemas.microsoft.com/office/drawing/2014/main" id="{8FCD1449-373E-493B-9A5B-B977535E9355}"/>
               </a:ext>
             </a:extLst>
           </p:cNvPr>
@@ -4526,7 +4526,7 @@
           <p:cNvPr id="3" name="">
             <a:extLst xmlns:a="http://schemas.openxmlformats.org/drawingml/2006/main">
               <a:ext uri="{FF2B5EF4-FFF2-40B4-BE49-F238E27FC236}">
-                <a16:creationId xmlns:a16="http://schemas.microsoft.com/office/drawing/2014/main" id="{74ED7362-FF46-47ED-B876-D9B4934BA600}"/>
+                <a16:creationId xmlns:a16="http://schemas.microsoft.com/office/drawing/2014/main" id="{2A64FA3D-644D-4131-B9E6-007EB455C1B1}"/>
               </a:ext>
             </a:extLst>
           </p:cNvPr>
@@ -4683,7 +4683,7 @@
           <p:cNvPr id="4" name="">
             <a:extLst xmlns:a="http://schemas.openxmlformats.org/drawingml/2006/main">
               <a:ext uri="{FF2B5EF4-FFF2-40B4-BE49-F238E27FC236}">
-                <a16:creationId xmlns:a16="http://schemas.microsoft.com/office/drawing/2014/main" id="{B366F10C-F4CC-467A-8151-D476B492BF7C}"/>
+                <a16:creationId xmlns:a16="http://schemas.microsoft.com/office/drawing/2014/main" id="{AD57CD8A-B110-4246-8E7A-489755A9FD93}"/>
               </a:ext>
             </a:extLst>
           </p:cNvPr>
@@ -4840,7 +4840,7 @@
           <p:cNvPr id="5" name="">
             <a:extLst xmlns:a="http://schemas.openxmlformats.org/drawingml/2006/main">
               <a:ext uri="{FF2B5EF4-FFF2-40B4-BE49-F238E27FC236}">
-                <a16:creationId xmlns:a16="http://schemas.microsoft.com/office/drawing/2014/main" id="{D074743F-4596-44A5-B62F-7FEE35BFE5FE}"/>
+                <a16:creationId xmlns:a16="http://schemas.microsoft.com/office/drawing/2014/main" id="{D7161321-8492-4E08-A053-BCFD63CE9B09}"/>
               </a:ext>
             </a:extLst>
           </p:cNvPr>
@@ -4997,7 +4997,7 @@
           <p:cNvPr id="6" name="">
             <a:extLst xmlns:a="http://schemas.openxmlformats.org/drawingml/2006/main">
               <a:ext uri="{FF2B5EF4-FFF2-40B4-BE49-F238E27FC236}">
-                <a16:creationId xmlns:a16="http://schemas.microsoft.com/office/drawing/2014/main" id="{C7400D6B-D39B-401B-857B-E99708783E72}"/>
+                <a16:creationId xmlns:a16="http://schemas.microsoft.com/office/drawing/2014/main" id="{DD25A280-F1C7-4B97-B352-3732742BFA6F}"/>
               </a:ext>
             </a:extLst>
           </p:cNvPr>
@@ -5028,7 +5028,7 @@
           <p:cNvPr id="7" name="">
             <a:extLst xmlns:a="http://schemas.openxmlformats.org/drawingml/2006/main">
               <a:ext uri="{FF2B5EF4-FFF2-40B4-BE49-F238E27FC236}">
-                <a16:creationId xmlns:a16="http://schemas.microsoft.com/office/drawing/2014/main" id="{AD44CA77-2F4B-4AC7-8113-3E6A4BE6E2D9}"/>
+                <a16:creationId xmlns:a16="http://schemas.microsoft.com/office/drawing/2014/main" id="{82A79DFC-6DC4-44ED-A618-B91199D706C8}"/>
               </a:ext>
             </a:extLst>
           </p:cNvPr>
@@ -5185,7 +5185,7 @@
           <p:cNvPr id="8" name="">
             <a:extLst xmlns:a="http://schemas.openxmlformats.org/drawingml/2006/main">
               <a:ext uri="{FF2B5EF4-FFF2-40B4-BE49-F238E27FC236}">
-                <a16:creationId xmlns:a16="http://schemas.microsoft.com/office/drawing/2014/main" id="{E784DBC0-EBD4-4015-8A16-FF402BF93C4A}"/>
+                <a16:creationId xmlns:a16="http://schemas.microsoft.com/office/drawing/2014/main" id="{90150884-E63E-42CF-BE92-43C7E8B4852A}"/>
               </a:ext>
             </a:extLst>
           </p:cNvPr>
@@ -5342,7 +5342,7 @@
           <p:cNvPr id="9" name="">
             <a:extLst xmlns:a="http://schemas.openxmlformats.org/drawingml/2006/main">
               <a:ext uri="{FF2B5EF4-FFF2-40B4-BE49-F238E27FC236}">
-                <a16:creationId xmlns:a16="http://schemas.microsoft.com/office/drawing/2014/main" id="{01B82A4A-D027-4A63-A3A1-303F81197AEB}"/>
+                <a16:creationId xmlns:a16="http://schemas.microsoft.com/office/drawing/2014/main" id="{B8F43F26-5B02-4097-98CC-C9970954D0DF}"/>
               </a:ext>
             </a:extLst>
           </p:cNvPr>
@@ -5497,7 +5497,7 @@
     </p:spTree>
     <p:extLst>
       <p:ext uri="{BB962C8B-B14F-4D97-AF65-F5344CB8AC3E}">
-        <p14:creationId xmlns:p14="http://schemas.microsoft.com/office/powerpoint/2010/main" val="1801122426"/>
+        <p14:creationId xmlns:p14="http://schemas.microsoft.com/office/powerpoint/2010/main" val="1124118553"/>
       </p:ext>
     </p:extLst>
   </p:cSld>
@@ -5528,7 +5528,7 @@
           <p:cNvPr id="20" name="">
             <a:extLst xmlns:a="http://schemas.openxmlformats.org/drawingml/2006/main">
               <a:ext uri="{FF2B5EF4-FFF2-40B4-BE49-F238E27FC236}">
-                <a16:creationId xmlns:a16="http://schemas.microsoft.com/office/drawing/2014/main" id="{953AC817-4FE3-4FBE-B9B1-73E978F3943E}"/>
+                <a16:creationId xmlns:a16="http://schemas.microsoft.com/office/drawing/2014/main" id="{5801BE39-D848-4B74-B9D9-D8BEA1E1ACE8}"/>
               </a:ext>
             </a:extLst>
           </p:cNvPr>
@@ -5685,7 +5685,7 @@
           <p:cNvPr id="2" name="">
             <a:extLst xmlns:a="http://schemas.openxmlformats.org/drawingml/2006/main">
               <a:ext uri="{FF2B5EF4-FFF2-40B4-BE49-F238E27FC236}">
-                <a16:creationId xmlns:a16="http://schemas.microsoft.com/office/drawing/2014/main" id="{6D24B775-79E9-4057-9C10-1FEB0267EA77}"/>
+                <a16:creationId xmlns:a16="http://schemas.microsoft.com/office/drawing/2014/main" id="{DC8325BC-00B0-4363-B795-9CB74B09C126}"/>
               </a:ext>
             </a:extLst>
           </p:cNvPr>
@@ -5716,7 +5716,7 @@
           <p:cNvPr id="3" name="">
             <a:extLst xmlns:a="http://schemas.openxmlformats.org/drawingml/2006/main">
               <a:ext uri="{FF2B5EF4-FFF2-40B4-BE49-F238E27FC236}">
-                <a16:creationId xmlns:a16="http://schemas.microsoft.com/office/drawing/2014/main" id="{E3EF83FB-0A87-49BE-A187-2F03C38F1D69}"/>
+                <a16:creationId xmlns:a16="http://schemas.microsoft.com/office/drawing/2014/main" id="{D796AD05-D6BD-4A13-86E4-C8C4CF48E3DE}"/>
               </a:ext>
             </a:extLst>
           </p:cNvPr>
@@ -5873,7 +5873,7 @@
           <p:cNvPr id="4" name="">
             <a:extLst xmlns:a="http://schemas.openxmlformats.org/drawingml/2006/main">
               <a:ext uri="{FF2B5EF4-FFF2-40B4-BE49-F238E27FC236}">
-                <a16:creationId xmlns:a16="http://schemas.microsoft.com/office/drawing/2014/main" id="{B4B41EB0-B403-4E9B-9B1E-148B296CF3BF}"/>
+                <a16:creationId xmlns:a16="http://schemas.microsoft.com/office/drawing/2014/main" id="{222DE09E-4108-4712-BFD3-2D4B269598C7}"/>
               </a:ext>
             </a:extLst>
           </p:cNvPr>
@@ -6030,7 +6030,7 @@
           <p:cNvPr id="5" name="">
             <a:extLst xmlns:a="http://schemas.openxmlformats.org/drawingml/2006/main">
               <a:ext uri="{FF2B5EF4-FFF2-40B4-BE49-F238E27FC236}">
-                <a16:creationId xmlns:a16="http://schemas.microsoft.com/office/drawing/2014/main" id="{7D6A5EDF-EDFB-4B84-B939-213D53375A9B}"/>
+                <a16:creationId xmlns:a16="http://schemas.microsoft.com/office/drawing/2014/main" id="{C0ADCEBC-A14D-478A-8FEC-3D3ACF058DBE}"/>
               </a:ext>
             </a:extLst>
           </p:cNvPr>
@@ -6187,7 +6187,7 @@
           <p:cNvPr id="6" name="">
             <a:extLst xmlns:a="http://schemas.openxmlformats.org/drawingml/2006/main">
               <a:ext uri="{FF2B5EF4-FFF2-40B4-BE49-F238E27FC236}">
-                <a16:creationId xmlns:a16="http://schemas.microsoft.com/office/drawing/2014/main" id="{271647BE-0376-4507-B81F-DAB5941C517F}"/>
+                <a16:creationId xmlns:a16="http://schemas.microsoft.com/office/drawing/2014/main" id="{9BCF76E9-3B94-4C34-BAFB-F9E44A04DFD0}"/>
               </a:ext>
             </a:extLst>
           </p:cNvPr>
@@ -7046,7 +7046,7 @@
           <p:cNvPr id="7" name="">
             <a:extLst xmlns:a="http://schemas.openxmlformats.org/drawingml/2006/main">
               <a:ext uri="{FF2B5EF4-FFF2-40B4-BE49-F238E27FC236}">
-                <a16:creationId xmlns:a16="http://schemas.microsoft.com/office/drawing/2014/main" id="{41570CA9-A2AE-4413-85B3-CF50F9540578}"/>
+                <a16:creationId xmlns:a16="http://schemas.microsoft.com/office/drawing/2014/main" id="{9B710069-4235-450D-8844-0C55AA6AC5A1}"/>
               </a:ext>
             </a:extLst>
           </p:cNvPr>
@@ -7203,7 +7203,7 @@
           <p:cNvPr id="8" name="">
             <a:extLst xmlns:a="http://schemas.openxmlformats.org/drawingml/2006/main">
               <a:ext uri="{FF2B5EF4-FFF2-40B4-BE49-F238E27FC236}">
-                <a16:creationId xmlns:a16="http://schemas.microsoft.com/office/drawing/2014/main" id="{1198D554-CF49-45A3-809C-C5870FF56A08}"/>
+                <a16:creationId xmlns:a16="http://schemas.microsoft.com/office/drawing/2014/main" id="{858E5A91-E28E-47EF-9E14-7B66B9F3B12F}"/>
               </a:ext>
             </a:extLst>
           </p:cNvPr>
@@ -7360,7 +7360,7 @@
           <p:cNvPr id="9" name="">
             <a:extLst xmlns:a="http://schemas.openxmlformats.org/drawingml/2006/main">
               <a:ext uri="{FF2B5EF4-FFF2-40B4-BE49-F238E27FC236}">
-                <a16:creationId xmlns:a16="http://schemas.microsoft.com/office/drawing/2014/main" id="{53BD46FC-8E9E-4148-AE07-874C5867C6AA}"/>
+                <a16:creationId xmlns:a16="http://schemas.microsoft.com/office/drawing/2014/main" id="{F4C3FD1E-F797-455E-895D-93D0E89003AD}"/>
               </a:ext>
             </a:extLst>
           </p:cNvPr>
@@ -7517,7 +7517,7 @@
           <p:cNvPr id="10" name="">
             <a:extLst xmlns:a="http://schemas.openxmlformats.org/drawingml/2006/main">
               <a:ext uri="{FF2B5EF4-FFF2-40B4-BE49-F238E27FC236}">
-                <a16:creationId xmlns:a16="http://schemas.microsoft.com/office/drawing/2014/main" id="{EFE69C04-9245-4209-AFEF-3FBAD256DC0C}"/>
+                <a16:creationId xmlns:a16="http://schemas.microsoft.com/office/drawing/2014/main" id="{71DB0CC2-609D-4D83-86D8-E5DE4422DDD2}"/>
               </a:ext>
             </a:extLst>
           </p:cNvPr>
@@ -7674,7 +7674,7 @@
           <p:cNvPr id="11" name="">
             <a:extLst xmlns:a="http://schemas.openxmlformats.org/drawingml/2006/main">
               <a:ext uri="{FF2B5EF4-FFF2-40B4-BE49-F238E27FC236}">
-                <a16:creationId xmlns:a16="http://schemas.microsoft.com/office/drawing/2014/main" id="{1CBB38D4-5BFD-406A-A9C4-151EE358E473}"/>
+                <a16:creationId xmlns:a16="http://schemas.microsoft.com/office/drawing/2014/main" id="{3FD94DED-EF70-426A-9F77-D84D96D59C80}"/>
               </a:ext>
             </a:extLst>
           </p:cNvPr>
@@ -7831,7 +7831,7 @@
           <p:cNvPr id="12" name="">
             <a:extLst xmlns:a="http://schemas.openxmlformats.org/drawingml/2006/main">
               <a:ext uri="{FF2B5EF4-FFF2-40B4-BE49-F238E27FC236}">
-                <a16:creationId xmlns:a16="http://schemas.microsoft.com/office/drawing/2014/main" id="{0A0DACC3-4AEF-4B17-A69D-69A8DCBE8040}"/>
+                <a16:creationId xmlns:a16="http://schemas.microsoft.com/office/drawing/2014/main" id="{A0397CBD-42F6-4CA9-AD1F-84E98C134104}"/>
               </a:ext>
             </a:extLst>
           </p:cNvPr>
@@ -7988,7 +7988,7 @@
           <p:cNvPr id="13" name="">
             <a:extLst xmlns:a="http://schemas.openxmlformats.org/drawingml/2006/main">
               <a:ext uri="{FF2B5EF4-FFF2-40B4-BE49-F238E27FC236}">
-                <a16:creationId xmlns:a16="http://schemas.microsoft.com/office/drawing/2014/main" id="{C7CC7FB5-A4DE-4240-BAF5-D0441385DA5C}"/>
+                <a16:creationId xmlns:a16="http://schemas.microsoft.com/office/drawing/2014/main" id="{D5F2FADF-E6AC-42F8-99F8-067DD31EA560}"/>
               </a:ext>
             </a:extLst>
           </p:cNvPr>
@@ -8145,7 +8145,7 @@
           <p:cNvPr id="14" name="">
             <a:extLst xmlns:a="http://schemas.openxmlformats.org/drawingml/2006/main">
               <a:ext uri="{FF2B5EF4-FFF2-40B4-BE49-F238E27FC236}">
-                <a16:creationId xmlns:a16="http://schemas.microsoft.com/office/drawing/2014/main" id="{30C7AA50-0C30-4A4A-B5AA-F5986254130D}"/>
+                <a16:creationId xmlns:a16="http://schemas.microsoft.com/office/drawing/2014/main" id="{D1CF88BD-71E1-46E6-91E2-7A9943DF053E}"/>
               </a:ext>
             </a:extLst>
           </p:cNvPr>
@@ -8176,7 +8176,7 @@
           <p:cNvPr id="15" name="">
             <a:extLst xmlns:a="http://schemas.openxmlformats.org/drawingml/2006/main">
               <a:ext uri="{FF2B5EF4-FFF2-40B4-BE49-F238E27FC236}">
-                <a16:creationId xmlns:a16="http://schemas.microsoft.com/office/drawing/2014/main" id="{63B00504-D618-486A-AA76-E4E361EAAFA0}"/>
+                <a16:creationId xmlns:a16="http://schemas.microsoft.com/office/drawing/2014/main" id="{190E9C90-57CE-4CFE-86C1-55337D4FC2FD}"/>
               </a:ext>
             </a:extLst>
           </p:cNvPr>
@@ -8333,7 +8333,7 @@
           <p:cNvPr id="16" name="">
             <a:extLst xmlns:a="http://schemas.openxmlformats.org/drawingml/2006/main">
               <a:ext uri="{FF2B5EF4-FFF2-40B4-BE49-F238E27FC236}">
-                <a16:creationId xmlns:a16="http://schemas.microsoft.com/office/drawing/2014/main" id="{8AE2B471-FB0E-4B8F-84DB-073316195CCC}"/>
+                <a16:creationId xmlns:a16="http://schemas.microsoft.com/office/drawing/2014/main" id="{37CB98A3-E36E-42E4-AB47-C40862AD5050}"/>
               </a:ext>
             </a:extLst>
           </p:cNvPr>
@@ -8490,7 +8490,7 @@
           <p:cNvPr id="17" name="">
             <a:extLst xmlns:a="http://schemas.openxmlformats.org/drawingml/2006/main">
               <a:ext uri="{FF2B5EF4-FFF2-40B4-BE49-F238E27FC236}">
-                <a16:creationId xmlns:a16="http://schemas.microsoft.com/office/drawing/2014/main" id="{A61D0099-A20B-462C-AB86-577067B9EF80}"/>
+                <a16:creationId xmlns:a16="http://schemas.microsoft.com/office/drawing/2014/main" id="{187643B5-C487-4ACC-99B6-B70DB00EC61A}"/>
               </a:ext>
             </a:extLst>
           </p:cNvPr>
@@ -8501,8 +8501,8 @@
         </p:nvSpPr>
         <p:spPr>
           <a:xfrm xmlns:a="http://schemas.openxmlformats.org/drawingml/2006/main">
-            <a:off x="685800" y="5581650"/>
-            <a:ext cx="7239000" cy="571500"/>
+            <a:off x="685800" y="5410200"/>
+            <a:ext cx="7239000" cy="723900"/>
           </a:xfrm>
           <a:prstGeom xmlns:a="http://schemas.openxmlformats.org/drawingml/2006/main" prst="rect">
             <a:avLst/>
@@ -8517,7 +8517,7 @@
           <a:bodyPr xmlns:a="http://schemas.openxmlformats.org/drawingml/2006/main" lIns="0" tIns="0" rIns="0" bIns="0" anchor="t"/>
           <a:lstStyle xmlns:a="http://schemas.openxmlformats.org/drawingml/2006/main">
             <a:defPPr algn="l">
-              <a:defRPr sz="1350" b="0" i="0">
+              <a:defRPr sz="1140" b="0" i="0">
                 <a:solidFill>
                   <a:srgbClr val="617077"/>
                 </a:solidFill>
@@ -8527,7 +8527,7 @@
               </a:defRPr>
             </a:defPPr>
             <a:lvl1pPr algn="l">
-              <a:defRPr sz="1350" b="0" i="0">
+              <a:defRPr sz="1140" b="0" i="0">
                 <a:solidFill>
                   <a:srgbClr val="617077"/>
                 </a:solidFill>
@@ -8537,7 +8537,7 @@
               </a:defRPr>
             </a:lvl1pPr>
             <a:lvl2pPr algn="l">
-              <a:defRPr sz="1350" b="0" i="0">
+              <a:defRPr sz="1140" b="0" i="0">
                 <a:solidFill>
                   <a:srgbClr val="617077"/>
                 </a:solidFill>
@@ -8547,7 +8547,7 @@
               </a:defRPr>
             </a:lvl2pPr>
             <a:lvl3pPr algn="l">
-              <a:defRPr sz="1350" b="0" i="0">
+              <a:defRPr sz="1140" b="0" i="0">
                 <a:solidFill>
                   <a:srgbClr val="617077"/>
                 </a:solidFill>
@@ -8557,7 +8557,7 @@
               </a:defRPr>
             </a:lvl3pPr>
             <a:lvl4pPr algn="l">
-              <a:defRPr sz="1350" b="0" i="0">
+              <a:defRPr sz="1140" b="0" i="0">
                 <a:solidFill>
                   <a:srgbClr val="617077"/>
                 </a:solidFill>
@@ -8567,7 +8567,7 @@
               </a:defRPr>
             </a:lvl4pPr>
             <a:lvl5pPr algn="l">
-              <a:defRPr sz="1350" b="0" i="0">
+              <a:defRPr sz="1140" b="0" i="0">
                 <a:solidFill>
                   <a:srgbClr val="617077"/>
                 </a:solidFill>
@@ -8577,7 +8577,7 @@
               </a:defRPr>
             </a:lvl5pPr>
             <a:lvl6pPr algn="l">
-              <a:defRPr sz="1350" b="0" i="0">
+              <a:defRPr sz="1140" b="0" i="0">
                 <a:solidFill>
                   <a:srgbClr val="617077"/>
                 </a:solidFill>
@@ -8587,7 +8587,7 @@
               </a:defRPr>
             </a:lvl6pPr>
             <a:lvl7pPr algn="l">
-              <a:defRPr sz="1350" b="0" i="0">
+              <a:defRPr sz="1140" b="0" i="0">
                 <a:solidFill>
                   <a:srgbClr val="617077"/>
                 </a:solidFill>
@@ -8597,7 +8597,7 @@
               </a:defRPr>
             </a:lvl7pPr>
             <a:lvl8pPr algn="l">
-              <a:defRPr sz="1350" b="0" i="0">
+              <a:defRPr sz="1140" b="0" i="0">
                 <a:solidFill>
                   <a:srgbClr val="617077"/>
                 </a:solidFill>
@@ -8607,7 +8607,7 @@
               </a:defRPr>
             </a:lvl8pPr>
             <a:lvl9pPr algn="l">
-              <a:defRPr sz="1350" b="0" i="0">
+              <a:defRPr sz="1140" b="0" i="0">
                 <a:solidFill>
                   <a:srgbClr val="617077"/>
                 </a:solidFill>
@@ -8619,7 +8619,7 @@
           </a:lstStyle>
           <a:p xmlns:a="http://schemas.openxmlformats.org/drawingml/2006/main">
             <a:pPr algn="l">
-              <a:defRPr sz="1350" b="0" i="0">
+              <a:defRPr sz="1140" b="0" i="0">
                 <a:solidFill>
                   <a:srgbClr val="617077"/>
                 </a:solidFill>
@@ -8629,7 +8629,7 @@
               </a:defRPr>
             </a:pPr>
             <a:r>
-              <a:rPr sz="1350" b="0" i="0">
+              <a:rPr sz="1140" b="0" i="0">
                 <a:solidFill>
                   <a:srgbClr val="617077"/>
                 </a:solidFill>
@@ -8637,7 +8637,30 @@
                 <a:ea typeface="Songti SC"/>
                 <a:cs typeface="Songti SC"/>
               </a:rPr>
-              <a:t>下一步：Windows 实机、Neo4j 现场重连、PowerPoint 原生检查、成员信息。</a:t>
+              <a:t>P2 已在真实 Neo4j 完成扩展分片四跳验收；生产图仍为旧 1.4.1，新实体来自真实新数据版本重放。</a:t>
+            </a:r>
+          </a:p>
+          <a:p xmlns:a="http://schemas.openxmlformats.org/drawingml/2006/main">
+            <a:pPr algn="l">
+              <a:defRPr sz="1140" b="0" i="0">
+                <a:solidFill>
+                  <a:srgbClr val="617077"/>
+                </a:solidFill>
+                <a:latin typeface="Songti SC"/>
+                <a:ea typeface="Songti SC"/>
+                <a:cs typeface="Songti SC"/>
+              </a:defRPr>
+            </a:pPr>
+            <a:r>
+              <a:rPr sz="1140" b="0" i="0">
+                <a:solidFill>
+                  <a:srgbClr val="617077"/>
+                </a:solidFill>
+                <a:latin typeface="Songti SC"/>
+                <a:ea typeface="Songti SC"/>
+                <a:cs typeface="Songti SC"/>
+              </a:rPr>
+              <a:t>下一步：Windows 实机、PowerPoint 原生检查、课堂彩排、成员信息。</a:t>
             </a:r>
           </a:p>
         </p:txBody>
@@ -8647,7 +8670,7 @@
           <p:cNvPr id="18" name="">
             <a:extLst xmlns:a="http://schemas.openxmlformats.org/drawingml/2006/main">
               <a:ext uri="{FF2B5EF4-FFF2-40B4-BE49-F238E27FC236}">
-                <a16:creationId xmlns:a16="http://schemas.microsoft.com/office/drawing/2014/main" id="{C96FD164-1476-491E-8673-CF920B3667B1}"/>
+                <a16:creationId xmlns:a16="http://schemas.microsoft.com/office/drawing/2014/main" id="{09FF3A46-6CDA-4A89-BB60-13BD00516050}"/>
               </a:ext>
             </a:extLst>
           </p:cNvPr>
@@ -8804,7 +8827,7 @@
           <p:cNvPr id="19" name="">
             <a:extLst xmlns:a="http://schemas.openxmlformats.org/drawingml/2006/main">
               <a:ext uri="{FF2B5EF4-FFF2-40B4-BE49-F238E27FC236}">
-                <a16:creationId xmlns:a16="http://schemas.microsoft.com/office/drawing/2014/main" id="{740B42B0-6594-46E0-8263-174EEEDB73C1}"/>
+                <a16:creationId xmlns:a16="http://schemas.microsoft.com/office/drawing/2014/main" id="{C56BF177-BC2C-4133-9DF7-A5A9C6242FF8}"/>
               </a:ext>
             </a:extLst>
           </p:cNvPr>
@@ -8959,7 +8982,7 @@
     </p:spTree>
     <p:extLst>
       <p:ext uri="{BB962C8B-B14F-4D97-AF65-F5344CB8AC3E}">
-        <p14:creationId xmlns:p14="http://schemas.microsoft.com/office/powerpoint/2010/main" val="1002141494"/>
+        <p14:creationId xmlns:p14="http://schemas.microsoft.com/office/powerpoint/2010/main" val="263178689"/>
       </p:ext>
     </p:extLst>
   </p:cSld>
@@ -8990,7 +9013,7 @@
           <p:cNvPr id="25" name="">
             <a:extLst xmlns:a="http://schemas.openxmlformats.org/drawingml/2006/main">
               <a:ext uri="{FF2B5EF4-FFF2-40B4-BE49-F238E27FC236}">
-                <a16:creationId xmlns:a16="http://schemas.microsoft.com/office/drawing/2014/main" id="{EE83CCB0-1467-4EBC-B672-353B4A147B7B}"/>
+                <a16:creationId xmlns:a16="http://schemas.microsoft.com/office/drawing/2014/main" id="{98281917-79CF-4889-81B4-49F6AFEF3F62}"/>
               </a:ext>
             </a:extLst>
           </p:cNvPr>
@@ -9147,7 +9170,7 @@
           <p:cNvPr id="2" name="">
             <a:extLst xmlns:a="http://schemas.openxmlformats.org/drawingml/2006/main">
               <a:ext uri="{FF2B5EF4-FFF2-40B4-BE49-F238E27FC236}">
-                <a16:creationId xmlns:a16="http://schemas.microsoft.com/office/drawing/2014/main" id="{EC383CCC-B98D-4294-9D6B-60301B1D94F8}"/>
+                <a16:creationId xmlns:a16="http://schemas.microsoft.com/office/drawing/2014/main" id="{28EE9FA5-2A3E-425A-B75B-40F7097A77F7}"/>
               </a:ext>
             </a:extLst>
           </p:cNvPr>
@@ -9178,7 +9201,7 @@
           <p:cNvPr id="3" name="">
             <a:extLst xmlns:a="http://schemas.openxmlformats.org/drawingml/2006/main">
               <a:ext uri="{FF2B5EF4-FFF2-40B4-BE49-F238E27FC236}">
-                <a16:creationId xmlns:a16="http://schemas.microsoft.com/office/drawing/2014/main" id="{C3585B4E-F033-416B-B744-1A2C3A8302F4}"/>
+                <a16:creationId xmlns:a16="http://schemas.microsoft.com/office/drawing/2014/main" id="{946AB2A9-0EA9-490A-86B2-B50CDCD533A6}"/>
               </a:ext>
             </a:extLst>
           </p:cNvPr>
@@ -9335,7 +9358,7 @@
           <p:cNvPr id="4" name="">
             <a:extLst xmlns:a="http://schemas.openxmlformats.org/drawingml/2006/main">
               <a:ext uri="{FF2B5EF4-FFF2-40B4-BE49-F238E27FC236}">
-                <a16:creationId xmlns:a16="http://schemas.microsoft.com/office/drawing/2014/main" id="{94464FE2-5982-4CC3-ADA8-3B6B00260FF1}"/>
+                <a16:creationId xmlns:a16="http://schemas.microsoft.com/office/drawing/2014/main" id="{F2067479-8F6C-46E1-91B9-1D125DC784B6}"/>
               </a:ext>
             </a:extLst>
           </p:cNvPr>
@@ -9492,7 +9515,7 @@
           <p:cNvPr id="5" name="">
             <a:extLst xmlns:a="http://schemas.openxmlformats.org/drawingml/2006/main">
               <a:ext uri="{FF2B5EF4-FFF2-40B4-BE49-F238E27FC236}">
-                <a16:creationId xmlns:a16="http://schemas.microsoft.com/office/drawing/2014/main" id="{E5840865-B8F5-46FF-B698-C3D80866D37A}"/>
+                <a16:creationId xmlns:a16="http://schemas.microsoft.com/office/drawing/2014/main" id="{9AE6DB47-EAF8-486A-AD7D-D134A37B2AA0}"/>
               </a:ext>
             </a:extLst>
           </p:cNvPr>
@@ -9649,7 +9672,7 @@
           <p:cNvPr id="6" name="">
             <a:extLst xmlns:a="http://schemas.openxmlformats.org/drawingml/2006/main">
               <a:ext uri="{FF2B5EF4-FFF2-40B4-BE49-F238E27FC236}">
-                <a16:creationId xmlns:a16="http://schemas.microsoft.com/office/drawing/2014/main" id="{B4B8B3C4-7F41-418B-BA5B-CBBF527D7FA0}"/>
+                <a16:creationId xmlns:a16="http://schemas.microsoft.com/office/drawing/2014/main" id="{10EE4ED0-681F-4564-B355-C43A2D0F5780}"/>
               </a:ext>
             </a:extLst>
           </p:cNvPr>
@@ -9806,7 +9829,7 @@
           <p:cNvPr id="7" name="">
             <a:extLst xmlns:a="http://schemas.openxmlformats.org/drawingml/2006/main">
               <a:ext uri="{FF2B5EF4-FFF2-40B4-BE49-F238E27FC236}">
-                <a16:creationId xmlns:a16="http://schemas.microsoft.com/office/drawing/2014/main" id="{0A2A0E32-740F-4034-AD2F-985B9B547897}"/>
+                <a16:creationId xmlns:a16="http://schemas.microsoft.com/office/drawing/2014/main" id="{E48BF4BB-1233-4168-80CB-50FCE2F31A92}"/>
               </a:ext>
             </a:extLst>
           </p:cNvPr>
@@ -9963,7 +9986,7 @@
           <p:cNvPr id="8" name="">
             <a:extLst xmlns:a="http://schemas.openxmlformats.org/drawingml/2006/main">
               <a:ext uri="{FF2B5EF4-FFF2-40B4-BE49-F238E27FC236}">
-                <a16:creationId xmlns:a16="http://schemas.microsoft.com/office/drawing/2014/main" id="{2027C18F-ED09-4CE1-B2EB-CCE532D170CA}"/>
+                <a16:creationId xmlns:a16="http://schemas.microsoft.com/office/drawing/2014/main" id="{DDBF969F-D52C-4792-888B-668B7361A01C}"/>
               </a:ext>
             </a:extLst>
           </p:cNvPr>
@@ -9994,7 +10017,7 @@
           <p:cNvPr id="9" name="">
             <a:extLst xmlns:a="http://schemas.openxmlformats.org/drawingml/2006/main">
               <a:ext uri="{FF2B5EF4-FFF2-40B4-BE49-F238E27FC236}">
-                <a16:creationId xmlns:a16="http://schemas.microsoft.com/office/drawing/2014/main" id="{48E159FB-1659-46EF-A178-119FD430B674}"/>
+                <a16:creationId xmlns:a16="http://schemas.microsoft.com/office/drawing/2014/main" id="{A1EFFE71-FF60-43B3-8ADB-9EAB8E2DEF56}"/>
               </a:ext>
             </a:extLst>
           </p:cNvPr>
@@ -10151,7 +10174,7 @@
           <p:cNvPr id="10" name="">
             <a:extLst xmlns:a="http://schemas.openxmlformats.org/drawingml/2006/main">
               <a:ext uri="{FF2B5EF4-FFF2-40B4-BE49-F238E27FC236}">
-                <a16:creationId xmlns:a16="http://schemas.microsoft.com/office/drawing/2014/main" id="{48FC8CE3-D882-4E3C-909F-5EA8B1A46E02}"/>
+                <a16:creationId xmlns:a16="http://schemas.microsoft.com/office/drawing/2014/main" id="{E0432049-906F-4670-B1B6-917B950CB1B2}"/>
               </a:ext>
             </a:extLst>
           </p:cNvPr>
@@ -10308,7 +10331,7 @@
           <p:cNvPr id="11" name="">
             <a:extLst xmlns:a="http://schemas.openxmlformats.org/drawingml/2006/main">
               <a:ext uri="{FF2B5EF4-FFF2-40B4-BE49-F238E27FC236}">
-                <a16:creationId xmlns:a16="http://schemas.microsoft.com/office/drawing/2014/main" id="{89BC7FC2-9F50-4683-8D5E-D9F53E1ADEF7}"/>
+                <a16:creationId xmlns:a16="http://schemas.microsoft.com/office/drawing/2014/main" id="{4E4F96BD-4F3A-4878-90FD-D489355902B5}"/>
               </a:ext>
             </a:extLst>
           </p:cNvPr>
@@ -10339,7 +10362,7 @@
           <p:cNvPr id="12" name="">
             <a:extLst xmlns:a="http://schemas.openxmlformats.org/drawingml/2006/main">
               <a:ext uri="{FF2B5EF4-FFF2-40B4-BE49-F238E27FC236}">
-                <a16:creationId xmlns:a16="http://schemas.microsoft.com/office/drawing/2014/main" id="{B2DED518-2BCC-4DE4-BD49-7CB474206A13}"/>
+                <a16:creationId xmlns:a16="http://schemas.microsoft.com/office/drawing/2014/main" id="{23911C3A-ABD7-4867-97B0-CE51B3BB1903}"/>
               </a:ext>
             </a:extLst>
           </p:cNvPr>
@@ -10496,7 +10519,7 @@
           <p:cNvPr id="13" name="">
             <a:extLst xmlns:a="http://schemas.openxmlformats.org/drawingml/2006/main">
               <a:ext uri="{FF2B5EF4-FFF2-40B4-BE49-F238E27FC236}">
-                <a16:creationId xmlns:a16="http://schemas.microsoft.com/office/drawing/2014/main" id="{BDEB1BC3-20D9-4359-BA70-38941BCF40C6}"/>
+                <a16:creationId xmlns:a16="http://schemas.microsoft.com/office/drawing/2014/main" id="{FD14CF96-1B60-4C64-A91C-0EB5242724B3}"/>
               </a:ext>
             </a:extLst>
           </p:cNvPr>
@@ -10653,7 +10676,7 @@
           <p:cNvPr id="14" name="">
             <a:extLst xmlns:a="http://schemas.openxmlformats.org/drawingml/2006/main">
               <a:ext uri="{FF2B5EF4-FFF2-40B4-BE49-F238E27FC236}">
-                <a16:creationId xmlns:a16="http://schemas.microsoft.com/office/drawing/2014/main" id="{94A06E7F-7180-4F8D-9BF9-D3DA16C4F23B}"/>
+                <a16:creationId xmlns:a16="http://schemas.microsoft.com/office/drawing/2014/main" id="{1CFD7E82-74CA-40C6-A8FF-DF4C7923FA68}"/>
               </a:ext>
             </a:extLst>
           </p:cNvPr>
@@ -10684,7 +10707,7 @@
           <p:cNvPr id="15" name="">
             <a:extLst xmlns:a="http://schemas.openxmlformats.org/drawingml/2006/main">
               <a:ext uri="{FF2B5EF4-FFF2-40B4-BE49-F238E27FC236}">
-                <a16:creationId xmlns:a16="http://schemas.microsoft.com/office/drawing/2014/main" id="{E883E3CA-5322-48FA-AA9E-2CB9068ED987}"/>
+                <a16:creationId xmlns:a16="http://schemas.microsoft.com/office/drawing/2014/main" id="{DF6793B9-6260-4283-B78F-BB307343D3BF}"/>
               </a:ext>
             </a:extLst>
           </p:cNvPr>
@@ -10841,7 +10864,7 @@
           <p:cNvPr id="16" name="">
             <a:extLst xmlns:a="http://schemas.openxmlformats.org/drawingml/2006/main">
               <a:ext uri="{FF2B5EF4-FFF2-40B4-BE49-F238E27FC236}">
-                <a16:creationId xmlns:a16="http://schemas.microsoft.com/office/drawing/2014/main" id="{1A11F26D-14DF-4F2A-B7FD-FA5DD0E99247}"/>
+                <a16:creationId xmlns:a16="http://schemas.microsoft.com/office/drawing/2014/main" id="{DFDD5693-E35A-47A6-A9E8-A736903A84B2}"/>
               </a:ext>
             </a:extLst>
           </p:cNvPr>
@@ -10998,7 +11021,7 @@
           <p:cNvPr id="17" name="">
             <a:extLst xmlns:a="http://schemas.openxmlformats.org/drawingml/2006/main">
               <a:ext uri="{FF2B5EF4-FFF2-40B4-BE49-F238E27FC236}">
-                <a16:creationId xmlns:a16="http://schemas.microsoft.com/office/drawing/2014/main" id="{35F37844-95B9-4EE1-89C6-B4CC1805E711}"/>
+                <a16:creationId xmlns:a16="http://schemas.microsoft.com/office/drawing/2014/main" id="{57053431-FD9B-469A-9943-391478D2B10B}"/>
               </a:ext>
             </a:extLst>
           </p:cNvPr>
@@ -11029,7 +11052,7 @@
           <p:cNvPr id="18" name="">
             <a:extLst xmlns:a="http://schemas.openxmlformats.org/drawingml/2006/main">
               <a:ext uri="{FF2B5EF4-FFF2-40B4-BE49-F238E27FC236}">
-                <a16:creationId xmlns:a16="http://schemas.microsoft.com/office/drawing/2014/main" id="{291DC32A-2ECB-405E-81A2-537713FAC8AC}"/>
+                <a16:creationId xmlns:a16="http://schemas.microsoft.com/office/drawing/2014/main" id="{E4DB1C77-4BD4-4E0A-BC65-D7FD102F0643}"/>
               </a:ext>
             </a:extLst>
           </p:cNvPr>
@@ -11186,7 +11209,7 @@
           <p:cNvPr id="19" name="">
             <a:extLst xmlns:a="http://schemas.openxmlformats.org/drawingml/2006/main">
               <a:ext uri="{FF2B5EF4-FFF2-40B4-BE49-F238E27FC236}">
-                <a16:creationId xmlns:a16="http://schemas.microsoft.com/office/drawing/2014/main" id="{687CDF99-F5E0-4D3F-B569-35F5EB874CDC}"/>
+                <a16:creationId xmlns:a16="http://schemas.microsoft.com/office/drawing/2014/main" id="{944D93B4-4D59-43D9-86A4-1860207CBF67}"/>
               </a:ext>
             </a:extLst>
           </p:cNvPr>
@@ -11343,7 +11366,7 @@
           <p:cNvPr id="20" name="">
             <a:extLst xmlns:a="http://schemas.openxmlformats.org/drawingml/2006/main">
               <a:ext uri="{FF2B5EF4-FFF2-40B4-BE49-F238E27FC236}">
-                <a16:creationId xmlns:a16="http://schemas.microsoft.com/office/drawing/2014/main" id="{8F8A2447-10AD-46B7-AD4D-DB04CC031CE2}"/>
+                <a16:creationId xmlns:a16="http://schemas.microsoft.com/office/drawing/2014/main" id="{7F92C1AC-E40C-422D-9E2F-665BF3DB4EF2}"/>
               </a:ext>
             </a:extLst>
           </p:cNvPr>
@@ -11500,7 +11523,7 @@
           <p:cNvPr id="21" name="">
             <a:extLst xmlns:a="http://schemas.openxmlformats.org/drawingml/2006/main">
               <a:ext uri="{FF2B5EF4-FFF2-40B4-BE49-F238E27FC236}">
-                <a16:creationId xmlns:a16="http://schemas.microsoft.com/office/drawing/2014/main" id="{67882A56-4363-4F27-92DE-B6A9CF53916B}"/>
+                <a16:creationId xmlns:a16="http://schemas.microsoft.com/office/drawing/2014/main" id="{10FE38A3-A3CF-49E1-B1D4-878F072B68CF}"/>
               </a:ext>
             </a:extLst>
           </p:cNvPr>
@@ -11657,7 +11680,7 @@
           <p:cNvPr id="22" name="">
             <a:extLst xmlns:a="http://schemas.openxmlformats.org/drawingml/2006/main">
               <a:ext uri="{FF2B5EF4-FFF2-40B4-BE49-F238E27FC236}">
-                <a16:creationId xmlns:a16="http://schemas.microsoft.com/office/drawing/2014/main" id="{31C8B890-C2BC-4420-89E0-1C3C69A70126}"/>
+                <a16:creationId xmlns:a16="http://schemas.microsoft.com/office/drawing/2014/main" id="{E597A995-5515-4D74-8023-8542C3705011}"/>
               </a:ext>
             </a:extLst>
           </p:cNvPr>
@@ -11688,7 +11711,7 @@
           <p:cNvPr id="23" name="">
             <a:extLst xmlns:a="http://schemas.openxmlformats.org/drawingml/2006/main">
               <a:ext uri="{FF2B5EF4-FFF2-40B4-BE49-F238E27FC236}">
-                <a16:creationId xmlns:a16="http://schemas.microsoft.com/office/drawing/2014/main" id="{FA735DB8-CE8B-4110-A488-413BB07B2C76}"/>
+                <a16:creationId xmlns:a16="http://schemas.microsoft.com/office/drawing/2014/main" id="{4DA83BFB-C91F-4FF6-8073-D8CC60258416}"/>
               </a:ext>
             </a:extLst>
           </p:cNvPr>
@@ -11845,7 +11868,7 @@
           <p:cNvPr id="24" name="">
             <a:extLst xmlns:a="http://schemas.openxmlformats.org/drawingml/2006/main">
               <a:ext uri="{FF2B5EF4-FFF2-40B4-BE49-F238E27FC236}">
-                <a16:creationId xmlns:a16="http://schemas.microsoft.com/office/drawing/2014/main" id="{3BB9EFB6-3162-4E16-BFA1-643E60279274}"/>
+                <a16:creationId xmlns:a16="http://schemas.microsoft.com/office/drawing/2014/main" id="{7EA11697-7CDA-49A1-B786-2E694D72AEBD}"/>
               </a:ext>
             </a:extLst>
           </p:cNvPr>
@@ -12000,7 +12023,7 @@
     </p:spTree>
     <p:extLst>
       <p:ext uri="{BB962C8B-B14F-4D97-AF65-F5344CB8AC3E}">
-        <p14:creationId xmlns:p14="http://schemas.microsoft.com/office/powerpoint/2010/main" val="319776351"/>
+        <p14:creationId xmlns:p14="http://schemas.microsoft.com/office/powerpoint/2010/main" val="1804128498"/>
       </p:ext>
     </p:extLst>
   </p:cSld>
@@ -12031,7 +12054,7 @@
           <p:cNvPr id="32" name="">
             <a:extLst xmlns:a="http://schemas.openxmlformats.org/drawingml/2006/main">
               <a:ext uri="{FF2B5EF4-FFF2-40B4-BE49-F238E27FC236}">
-                <a16:creationId xmlns:a16="http://schemas.microsoft.com/office/drawing/2014/main" id="{AB8BE954-95EC-495D-B9C7-243CEA401413}"/>
+                <a16:creationId xmlns:a16="http://schemas.microsoft.com/office/drawing/2014/main" id="{D8FDE69A-6088-4B9C-AC87-7EA4869CB60B}"/>
               </a:ext>
             </a:extLst>
           </p:cNvPr>
@@ -12188,7 +12211,7 @@
           <p:cNvPr id="2" name="">
             <a:extLst xmlns:a="http://schemas.openxmlformats.org/drawingml/2006/main">
               <a:ext uri="{FF2B5EF4-FFF2-40B4-BE49-F238E27FC236}">
-                <a16:creationId xmlns:a16="http://schemas.microsoft.com/office/drawing/2014/main" id="{91C09E95-13B2-47FB-8E4A-46012A66EBA3}"/>
+                <a16:creationId xmlns:a16="http://schemas.microsoft.com/office/drawing/2014/main" id="{D0BD35A3-3C4A-41C7-BE11-62E8C5BD5FAD}"/>
               </a:ext>
             </a:extLst>
           </p:cNvPr>
@@ -12219,7 +12242,7 @@
           <p:cNvPr id="3" name="">
             <a:extLst xmlns:a="http://schemas.openxmlformats.org/drawingml/2006/main">
               <a:ext uri="{FF2B5EF4-FFF2-40B4-BE49-F238E27FC236}">
-                <a16:creationId xmlns:a16="http://schemas.microsoft.com/office/drawing/2014/main" id="{7E905802-C207-4CB5-97E8-E33C4F6AE6C4}"/>
+                <a16:creationId xmlns:a16="http://schemas.microsoft.com/office/drawing/2014/main" id="{3A05098A-7900-4065-A801-E30182F50DAD}"/>
               </a:ext>
             </a:extLst>
           </p:cNvPr>
@@ -12376,7 +12399,7 @@
           <p:cNvPr id="4" name="">
             <a:extLst xmlns:a="http://schemas.openxmlformats.org/drawingml/2006/main">
               <a:ext uri="{FF2B5EF4-FFF2-40B4-BE49-F238E27FC236}">
-                <a16:creationId xmlns:a16="http://schemas.microsoft.com/office/drawing/2014/main" id="{142C0750-B2ED-4748-9BFB-4BE9CD0DE5C9}"/>
+                <a16:creationId xmlns:a16="http://schemas.microsoft.com/office/drawing/2014/main" id="{53381319-7125-4281-BB16-07607C32DE0A}"/>
               </a:ext>
             </a:extLst>
           </p:cNvPr>
@@ -12533,7 +12556,7 @@
           <p:cNvPr id="5" name="">
             <a:extLst xmlns:a="http://schemas.openxmlformats.org/drawingml/2006/main">
               <a:ext uri="{FF2B5EF4-FFF2-40B4-BE49-F238E27FC236}">
-                <a16:creationId xmlns:a16="http://schemas.microsoft.com/office/drawing/2014/main" id="{9F846C03-BA24-4645-92A9-999F4FEBB457}"/>
+                <a16:creationId xmlns:a16="http://schemas.microsoft.com/office/drawing/2014/main" id="{DA1CB838-FA7E-4DF6-B157-852550CB623F}"/>
               </a:ext>
             </a:extLst>
           </p:cNvPr>
@@ -12690,7 +12713,7 @@
           <p:cNvPr id="6" name="">
             <a:extLst xmlns:a="http://schemas.openxmlformats.org/drawingml/2006/main">
               <a:ext uri="{FF2B5EF4-FFF2-40B4-BE49-F238E27FC236}">
-                <a16:creationId xmlns:a16="http://schemas.microsoft.com/office/drawing/2014/main" id="{9EB303A6-C838-43D8-B64E-8847111AACA7}"/>
+                <a16:creationId xmlns:a16="http://schemas.microsoft.com/office/drawing/2014/main" id="{B2E9407A-4649-4FF6-B695-D923D7E9C3D6}"/>
               </a:ext>
             </a:extLst>
           </p:cNvPr>
@@ -12847,7 +12870,7 @@
           <p:cNvPr id="7" name="">
             <a:extLst xmlns:a="http://schemas.openxmlformats.org/drawingml/2006/main">
               <a:ext uri="{FF2B5EF4-FFF2-40B4-BE49-F238E27FC236}">
-                <a16:creationId xmlns:a16="http://schemas.microsoft.com/office/drawing/2014/main" id="{0A51D4DE-8B7B-4E0F-B852-27FB69B4A677}"/>
+                <a16:creationId xmlns:a16="http://schemas.microsoft.com/office/drawing/2014/main" id="{DFD251B6-04CE-4D96-BC98-8FC7B5F28C33}"/>
               </a:ext>
             </a:extLst>
           </p:cNvPr>
@@ -12878,7 +12901,7 @@
           <p:cNvPr id="8" name="">
             <a:extLst xmlns:a="http://schemas.openxmlformats.org/drawingml/2006/main">
               <a:ext uri="{FF2B5EF4-FFF2-40B4-BE49-F238E27FC236}">
-                <a16:creationId xmlns:a16="http://schemas.microsoft.com/office/drawing/2014/main" id="{7D508F39-57B7-4840-8F5C-3E7FD537AC03}"/>
+                <a16:creationId xmlns:a16="http://schemas.microsoft.com/office/drawing/2014/main" id="{6787CC88-05D2-4CD7-940C-9EE2FCD71F0C}"/>
               </a:ext>
             </a:extLst>
           </p:cNvPr>
@@ -13037,7 +13060,7 @@
           <p:cNvPr id="9" name="">
             <a:extLst xmlns:a="http://schemas.openxmlformats.org/drawingml/2006/main">
               <a:ext uri="{FF2B5EF4-FFF2-40B4-BE49-F238E27FC236}">
-                <a16:creationId xmlns:a16="http://schemas.microsoft.com/office/drawing/2014/main" id="{ADF762E7-A6E6-4B4B-B5ED-DBF28E603E76}"/>
+                <a16:creationId xmlns:a16="http://schemas.microsoft.com/office/drawing/2014/main" id="{20F17926-4C01-4EA7-91A9-4C16DC25E1D5}"/>
               </a:ext>
             </a:extLst>
           </p:cNvPr>
@@ -13194,7 +13217,7 @@
           <p:cNvPr id="10" name="">
             <a:extLst xmlns:a="http://schemas.openxmlformats.org/drawingml/2006/main">
               <a:ext uri="{FF2B5EF4-FFF2-40B4-BE49-F238E27FC236}">
-                <a16:creationId xmlns:a16="http://schemas.microsoft.com/office/drawing/2014/main" id="{935D3D70-9A3D-4053-8A3D-0DBD1498FDF2}"/>
+                <a16:creationId xmlns:a16="http://schemas.microsoft.com/office/drawing/2014/main" id="{88CEF98E-B8C9-48B9-BA21-CBE44D41F38D}"/>
               </a:ext>
             </a:extLst>
           </p:cNvPr>
@@ -13351,7 +13374,7 @@
           <p:cNvPr id="11" name="">
             <a:extLst xmlns:a="http://schemas.openxmlformats.org/drawingml/2006/main">
               <a:ext uri="{FF2B5EF4-FFF2-40B4-BE49-F238E27FC236}">
-                <a16:creationId xmlns:a16="http://schemas.microsoft.com/office/drawing/2014/main" id="{D29F66E5-2C0B-4F5E-99F6-98C46B7DA47A}"/>
+                <a16:creationId xmlns:a16="http://schemas.microsoft.com/office/drawing/2014/main" id="{5E4C063B-31BC-496D-9FDC-68192FCB5998}"/>
               </a:ext>
             </a:extLst>
           </p:cNvPr>
@@ -13510,7 +13533,7 @@
           <p:cNvPr id="12" name="">
             <a:extLst xmlns:a="http://schemas.openxmlformats.org/drawingml/2006/main">
               <a:ext uri="{FF2B5EF4-FFF2-40B4-BE49-F238E27FC236}">
-                <a16:creationId xmlns:a16="http://schemas.microsoft.com/office/drawing/2014/main" id="{996F9C36-8DAE-44F8-9323-29E471A97D4A}"/>
+                <a16:creationId xmlns:a16="http://schemas.microsoft.com/office/drawing/2014/main" id="{811993F5-0E6F-4129-8D27-85E039EAF341}"/>
               </a:ext>
             </a:extLst>
           </p:cNvPr>
@@ -13667,7 +13690,7 @@
           <p:cNvPr id="13" name="">
             <a:extLst xmlns:a="http://schemas.openxmlformats.org/drawingml/2006/main">
               <a:ext uri="{FF2B5EF4-FFF2-40B4-BE49-F238E27FC236}">
-                <a16:creationId xmlns:a16="http://schemas.microsoft.com/office/drawing/2014/main" id="{A25307DC-1787-45F8-A082-41F069AAD8C9}"/>
+                <a16:creationId xmlns:a16="http://schemas.microsoft.com/office/drawing/2014/main" id="{CB2DF785-F8B9-4EEC-9157-90499E1CA489}"/>
               </a:ext>
             </a:extLst>
           </p:cNvPr>
@@ -13824,7 +13847,7 @@
           <p:cNvPr id="14" name="">
             <a:extLst xmlns:a="http://schemas.openxmlformats.org/drawingml/2006/main">
               <a:ext uri="{FF2B5EF4-FFF2-40B4-BE49-F238E27FC236}">
-                <a16:creationId xmlns:a16="http://schemas.microsoft.com/office/drawing/2014/main" id="{B48F5FD7-08C2-4156-8882-759AFF699E29}"/>
+                <a16:creationId xmlns:a16="http://schemas.microsoft.com/office/drawing/2014/main" id="{DDBCF0AC-8CD8-4E5C-B943-86A249B385DF}"/>
               </a:ext>
             </a:extLst>
           </p:cNvPr>
@@ -13983,7 +14006,7 @@
           <p:cNvPr id="15" name="">
             <a:extLst xmlns:a="http://schemas.openxmlformats.org/drawingml/2006/main">
               <a:ext uri="{FF2B5EF4-FFF2-40B4-BE49-F238E27FC236}">
-                <a16:creationId xmlns:a16="http://schemas.microsoft.com/office/drawing/2014/main" id="{BC18FD73-46B3-47E2-948E-4565BFA20EAB}"/>
+                <a16:creationId xmlns:a16="http://schemas.microsoft.com/office/drawing/2014/main" id="{4EAD6582-2D7D-4E6E-8457-A40C54A6F42D}"/>
               </a:ext>
             </a:extLst>
           </p:cNvPr>
@@ -14140,7 +14163,7 @@
           <p:cNvPr id="16" name="">
             <a:extLst xmlns:a="http://schemas.openxmlformats.org/drawingml/2006/main">
               <a:ext uri="{FF2B5EF4-FFF2-40B4-BE49-F238E27FC236}">
-                <a16:creationId xmlns:a16="http://schemas.microsoft.com/office/drawing/2014/main" id="{A2A2DB69-A2B0-4A50-BC1B-9E794B71F414}"/>
+                <a16:creationId xmlns:a16="http://schemas.microsoft.com/office/drawing/2014/main" id="{20665093-846E-4D38-9A9F-BA9FCE866212}"/>
               </a:ext>
             </a:extLst>
           </p:cNvPr>
@@ -14297,7 +14320,7 @@
           <p:cNvPr id="17" name="">
             <a:extLst xmlns:a="http://schemas.openxmlformats.org/drawingml/2006/main">
               <a:ext uri="{FF2B5EF4-FFF2-40B4-BE49-F238E27FC236}">
-                <a16:creationId xmlns:a16="http://schemas.microsoft.com/office/drawing/2014/main" id="{CAA8EAC3-086B-4045-8CB5-32A210FA1EEB}"/>
+                <a16:creationId xmlns:a16="http://schemas.microsoft.com/office/drawing/2014/main" id="{04702839-5648-4998-B029-A341899CF7A5}"/>
               </a:ext>
             </a:extLst>
           </p:cNvPr>
@@ -14456,7 +14479,7 @@
           <p:cNvPr id="18" name="">
             <a:extLst xmlns:a="http://schemas.openxmlformats.org/drawingml/2006/main">
               <a:ext uri="{FF2B5EF4-FFF2-40B4-BE49-F238E27FC236}">
-                <a16:creationId xmlns:a16="http://schemas.microsoft.com/office/drawing/2014/main" id="{5D61F916-F972-4B5F-9A2D-63E13D900980}"/>
+                <a16:creationId xmlns:a16="http://schemas.microsoft.com/office/drawing/2014/main" id="{02497C74-95C8-498B-A107-71B7A7DB5562}"/>
               </a:ext>
             </a:extLst>
           </p:cNvPr>
@@ -14613,7 +14636,7 @@
           <p:cNvPr id="19" name="">
             <a:extLst xmlns:a="http://schemas.openxmlformats.org/drawingml/2006/main">
               <a:ext uri="{FF2B5EF4-FFF2-40B4-BE49-F238E27FC236}">
-                <a16:creationId xmlns:a16="http://schemas.microsoft.com/office/drawing/2014/main" id="{3986A056-BFBC-45A7-87A1-D5200DE8E8F7}"/>
+                <a16:creationId xmlns:a16="http://schemas.microsoft.com/office/drawing/2014/main" id="{8DF5E1DD-EC33-49DC-93F8-66F6586C6F39}"/>
               </a:ext>
             </a:extLst>
           </p:cNvPr>
@@ -14770,7 +14793,7 @@
           <p:cNvPr id="20" name="">
             <a:extLst xmlns:a="http://schemas.openxmlformats.org/drawingml/2006/main">
               <a:ext uri="{FF2B5EF4-FFF2-40B4-BE49-F238E27FC236}">
-                <a16:creationId xmlns:a16="http://schemas.microsoft.com/office/drawing/2014/main" id="{41C68B8B-1FC2-4878-9F5D-3B985F64D963}"/>
+                <a16:creationId xmlns:a16="http://schemas.microsoft.com/office/drawing/2014/main" id="{7A376A32-0B83-48C3-85AD-C0A9D407663A}"/>
               </a:ext>
             </a:extLst>
           </p:cNvPr>
@@ -14929,7 +14952,7 @@
           <p:cNvPr id="21" name="">
             <a:extLst xmlns:a="http://schemas.openxmlformats.org/drawingml/2006/main">
               <a:ext uri="{FF2B5EF4-FFF2-40B4-BE49-F238E27FC236}">
-                <a16:creationId xmlns:a16="http://schemas.microsoft.com/office/drawing/2014/main" id="{D9BCE3F1-6463-4309-BBAA-0E534B52AA05}"/>
+                <a16:creationId xmlns:a16="http://schemas.microsoft.com/office/drawing/2014/main" id="{2F981380-2B8D-4975-AD8A-12D88C90D559}"/>
               </a:ext>
             </a:extLst>
           </p:cNvPr>
@@ -15086,7 +15109,7 @@
           <p:cNvPr id="22" name="">
             <a:extLst xmlns:a="http://schemas.openxmlformats.org/drawingml/2006/main">
               <a:ext uri="{FF2B5EF4-FFF2-40B4-BE49-F238E27FC236}">
-                <a16:creationId xmlns:a16="http://schemas.microsoft.com/office/drawing/2014/main" id="{3BE57BE7-3DE3-4286-9A37-F4DE65808FD8}"/>
+                <a16:creationId xmlns:a16="http://schemas.microsoft.com/office/drawing/2014/main" id="{5576E176-A228-4F9E-BF13-14C6C73E0C8D}"/>
               </a:ext>
             </a:extLst>
           </p:cNvPr>
@@ -15243,7 +15266,7 @@
           <p:cNvPr id="23" name="">
             <a:extLst xmlns:a="http://schemas.openxmlformats.org/drawingml/2006/main">
               <a:ext uri="{FF2B5EF4-FFF2-40B4-BE49-F238E27FC236}">
-                <a16:creationId xmlns:a16="http://schemas.microsoft.com/office/drawing/2014/main" id="{A9E114C5-A165-47A5-99C3-97659812D866}"/>
+                <a16:creationId xmlns:a16="http://schemas.microsoft.com/office/drawing/2014/main" id="{8E926D70-DB54-4485-9DEC-EC97AEB0F558}"/>
               </a:ext>
             </a:extLst>
           </p:cNvPr>
@@ -15402,7 +15425,7 @@
           <p:cNvPr id="24" name="">
             <a:extLst xmlns:a="http://schemas.openxmlformats.org/drawingml/2006/main">
               <a:ext uri="{FF2B5EF4-FFF2-40B4-BE49-F238E27FC236}">
-                <a16:creationId xmlns:a16="http://schemas.microsoft.com/office/drawing/2014/main" id="{85EFB2DA-3032-4EBD-B2E1-51C0B7589BE6}"/>
+                <a16:creationId xmlns:a16="http://schemas.microsoft.com/office/drawing/2014/main" id="{88C29F40-69A2-49C0-83D8-AA9AADA70614}"/>
               </a:ext>
             </a:extLst>
           </p:cNvPr>
@@ -15559,7 +15582,7 @@
           <p:cNvPr id="25" name="">
             <a:extLst xmlns:a="http://schemas.openxmlformats.org/drawingml/2006/main">
               <a:ext uri="{FF2B5EF4-FFF2-40B4-BE49-F238E27FC236}">
-                <a16:creationId xmlns:a16="http://schemas.microsoft.com/office/drawing/2014/main" id="{380BFACC-C734-4D76-B99C-9D6DD6E73ACE}"/>
+                <a16:creationId xmlns:a16="http://schemas.microsoft.com/office/drawing/2014/main" id="{D787E200-E9A7-496F-AA54-1C658E1CF2AC}"/>
               </a:ext>
             </a:extLst>
           </p:cNvPr>
@@ -15716,7 +15739,7 @@
           <p:cNvPr id="26" name="">
             <a:extLst xmlns:a="http://schemas.openxmlformats.org/drawingml/2006/main">
               <a:ext uri="{FF2B5EF4-FFF2-40B4-BE49-F238E27FC236}">
-                <a16:creationId xmlns:a16="http://schemas.microsoft.com/office/drawing/2014/main" id="{77C0C723-5A35-4757-BA08-DD9A38D0D32A}"/>
+                <a16:creationId xmlns:a16="http://schemas.microsoft.com/office/drawing/2014/main" id="{99663A58-E175-4BD5-9C7A-B697BFDEF2C8}"/>
               </a:ext>
             </a:extLst>
           </p:cNvPr>
@@ -15756,7 +15779,7 @@
           <p:cNvPr id="27" name="">
             <a:extLst xmlns:a="http://schemas.openxmlformats.org/drawingml/2006/main">
               <a:ext uri="{FF2B5EF4-FFF2-40B4-BE49-F238E27FC236}">
-                <a16:creationId xmlns:a16="http://schemas.microsoft.com/office/drawing/2014/main" id="{662F0606-1B69-480C-9786-5B82C57AAE6A}"/>
+                <a16:creationId xmlns:a16="http://schemas.microsoft.com/office/drawing/2014/main" id="{27D4EC0D-FE7E-43DA-9896-6E42AB538911}"/>
               </a:ext>
             </a:extLst>
           </p:cNvPr>
@@ -15913,7 +15936,7 @@
           <p:cNvPr id="28" name="">
             <a:extLst xmlns:a="http://schemas.openxmlformats.org/drawingml/2006/main">
               <a:ext uri="{FF2B5EF4-FFF2-40B4-BE49-F238E27FC236}">
-                <a16:creationId xmlns:a16="http://schemas.microsoft.com/office/drawing/2014/main" id="{0FF016EB-4666-44C3-B2B7-0B7995CE9A54}"/>
+                <a16:creationId xmlns:a16="http://schemas.microsoft.com/office/drawing/2014/main" id="{4F81C283-18C2-41ED-B137-A168352A4F8D}"/>
               </a:ext>
             </a:extLst>
           </p:cNvPr>
@@ -16070,7 +16093,7 @@
           <p:cNvPr id="29" name="">
             <a:extLst xmlns:a="http://schemas.openxmlformats.org/drawingml/2006/main">
               <a:ext uri="{FF2B5EF4-FFF2-40B4-BE49-F238E27FC236}">
-                <a16:creationId xmlns:a16="http://schemas.microsoft.com/office/drawing/2014/main" id="{CD94194F-94BC-49F0-B843-1245FE4F3BA7}"/>
+                <a16:creationId xmlns:a16="http://schemas.microsoft.com/office/drawing/2014/main" id="{3042A3FF-1290-43FE-AC55-118CB65E8A8E}"/>
               </a:ext>
             </a:extLst>
           </p:cNvPr>
@@ -16101,7 +16124,7 @@
           <p:cNvPr id="30" name="">
             <a:extLst xmlns:a="http://schemas.openxmlformats.org/drawingml/2006/main">
               <a:ext uri="{FF2B5EF4-FFF2-40B4-BE49-F238E27FC236}">
-                <a16:creationId xmlns:a16="http://schemas.microsoft.com/office/drawing/2014/main" id="{2CE8DD7D-FD65-4B1C-A100-0564A76EF818}"/>
+                <a16:creationId xmlns:a16="http://schemas.microsoft.com/office/drawing/2014/main" id="{ECDCBCD2-A016-4FD5-9835-B48285EB4D0A}"/>
               </a:ext>
             </a:extLst>
           </p:cNvPr>
@@ -16258,7 +16281,7 @@
           <p:cNvPr id="31" name="">
             <a:extLst xmlns:a="http://schemas.openxmlformats.org/drawingml/2006/main">
               <a:ext uri="{FF2B5EF4-FFF2-40B4-BE49-F238E27FC236}">
-                <a16:creationId xmlns:a16="http://schemas.microsoft.com/office/drawing/2014/main" id="{18A85340-173F-43B4-8DCD-8F9BA1137CC9}"/>
+                <a16:creationId xmlns:a16="http://schemas.microsoft.com/office/drawing/2014/main" id="{3D10AE98-6D00-4512-B3FF-427D9199B7AD}"/>
               </a:ext>
             </a:extLst>
           </p:cNvPr>
@@ -16413,7 +16436,7 @@
     </p:spTree>
     <p:extLst>
       <p:ext uri="{BB962C8B-B14F-4D97-AF65-F5344CB8AC3E}">
-        <p14:creationId xmlns:p14="http://schemas.microsoft.com/office/powerpoint/2010/main" val="1660286004"/>
+        <p14:creationId xmlns:p14="http://schemas.microsoft.com/office/powerpoint/2010/main" val="1087181520"/>
       </p:ext>
     </p:extLst>
   </p:cSld>
@@ -16444,7 +16467,7 @@
           <p:cNvPr id="22" name="">
             <a:extLst xmlns:a="http://schemas.openxmlformats.org/drawingml/2006/main">
               <a:ext uri="{FF2B5EF4-FFF2-40B4-BE49-F238E27FC236}">
-                <a16:creationId xmlns:a16="http://schemas.microsoft.com/office/drawing/2014/main" id="{65F800E0-4425-4C9C-A76F-78DCA92346E3}"/>
+                <a16:creationId xmlns:a16="http://schemas.microsoft.com/office/drawing/2014/main" id="{AE763756-0E5D-4F12-914A-BC9CAEE37ECE}"/>
               </a:ext>
             </a:extLst>
           </p:cNvPr>
@@ -16601,7 +16624,7 @@
           <p:cNvPr id="2" name="">
             <a:extLst xmlns:a="http://schemas.openxmlformats.org/drawingml/2006/main">
               <a:ext uri="{FF2B5EF4-FFF2-40B4-BE49-F238E27FC236}">
-                <a16:creationId xmlns:a16="http://schemas.microsoft.com/office/drawing/2014/main" id="{5FC872AB-1290-4D42-A03B-4C573FDB9C81}"/>
+                <a16:creationId xmlns:a16="http://schemas.microsoft.com/office/drawing/2014/main" id="{552E2591-C2C7-4D71-ACB9-8B85B58C717E}"/>
               </a:ext>
             </a:extLst>
           </p:cNvPr>
@@ -16632,7 +16655,7 @@
           <p:cNvPr id="3" name="">
             <a:extLst xmlns:a="http://schemas.openxmlformats.org/drawingml/2006/main">
               <a:ext uri="{FF2B5EF4-FFF2-40B4-BE49-F238E27FC236}">
-                <a16:creationId xmlns:a16="http://schemas.microsoft.com/office/drawing/2014/main" id="{7272594A-9FB7-4192-A8A9-A4BD65D883E3}"/>
+                <a16:creationId xmlns:a16="http://schemas.microsoft.com/office/drawing/2014/main" id="{F0A8D1E6-2AED-4FA9-AD40-9FA5C1C30FC8}"/>
               </a:ext>
             </a:extLst>
           </p:cNvPr>
@@ -16789,7 +16812,7 @@
           <p:cNvPr id="4" name="">
             <a:extLst xmlns:a="http://schemas.openxmlformats.org/drawingml/2006/main">
               <a:ext uri="{FF2B5EF4-FFF2-40B4-BE49-F238E27FC236}">
-                <a16:creationId xmlns:a16="http://schemas.microsoft.com/office/drawing/2014/main" id="{327FA98F-3EC2-40A2-8AE2-3AE981D85F8A}"/>
+                <a16:creationId xmlns:a16="http://schemas.microsoft.com/office/drawing/2014/main" id="{B699760E-D8C9-41A6-890C-C9B7693922F8}"/>
               </a:ext>
             </a:extLst>
           </p:cNvPr>
@@ -16946,7 +16969,7 @@
           <p:cNvPr id="5" name="">
             <a:extLst xmlns:a="http://schemas.openxmlformats.org/drawingml/2006/main">
               <a:ext uri="{FF2B5EF4-FFF2-40B4-BE49-F238E27FC236}">
-                <a16:creationId xmlns:a16="http://schemas.microsoft.com/office/drawing/2014/main" id="{3D39FC62-598E-4FB8-992C-2DF125687362}"/>
+                <a16:creationId xmlns:a16="http://schemas.microsoft.com/office/drawing/2014/main" id="{043EFCFD-5C12-4515-B23C-1F81D64DC8BC}"/>
               </a:ext>
             </a:extLst>
           </p:cNvPr>
@@ -17103,7 +17126,7 @@
           <p:cNvPr id="6" name="">
             <a:extLst xmlns:a="http://schemas.openxmlformats.org/drawingml/2006/main">
               <a:ext uri="{FF2B5EF4-FFF2-40B4-BE49-F238E27FC236}">
-                <a16:creationId xmlns:a16="http://schemas.microsoft.com/office/drawing/2014/main" id="{C83DC847-F53D-4FC7-93D2-9CAA0CD5D9EB}"/>
+                <a16:creationId xmlns:a16="http://schemas.microsoft.com/office/drawing/2014/main" id="{3105E7E7-8114-4B52-A118-7FE4D4815DC5}"/>
               </a:ext>
             </a:extLst>
           </p:cNvPr>
@@ -18194,7 +18217,7 @@
           <p:cNvPr id="7" name="">
             <a:extLst xmlns:a="http://schemas.openxmlformats.org/drawingml/2006/main">
               <a:ext uri="{FF2B5EF4-FFF2-40B4-BE49-F238E27FC236}">
-                <a16:creationId xmlns:a16="http://schemas.microsoft.com/office/drawing/2014/main" id="{1C10BA0A-D698-447D-AD8B-A25181242719}"/>
+                <a16:creationId xmlns:a16="http://schemas.microsoft.com/office/drawing/2014/main" id="{A603E200-9354-4570-8258-69E5FB187822}"/>
               </a:ext>
             </a:extLst>
           </p:cNvPr>
@@ -18351,7 +18374,7 @@
           <p:cNvPr id="8" name="">
             <a:extLst xmlns:a="http://schemas.openxmlformats.org/drawingml/2006/main">
               <a:ext uri="{FF2B5EF4-FFF2-40B4-BE49-F238E27FC236}">
-                <a16:creationId xmlns:a16="http://schemas.microsoft.com/office/drawing/2014/main" id="{2B3E64BC-370E-4548-A677-2E011E6AA0D5}"/>
+                <a16:creationId xmlns:a16="http://schemas.microsoft.com/office/drawing/2014/main" id="{B564D98C-92FC-4A01-B659-1F97E61F744C}"/>
               </a:ext>
             </a:extLst>
           </p:cNvPr>
@@ -18508,7 +18531,7 @@
           <p:cNvPr id="9" name="">
             <a:extLst xmlns:a="http://schemas.openxmlformats.org/drawingml/2006/main">
               <a:ext uri="{FF2B5EF4-FFF2-40B4-BE49-F238E27FC236}">
-                <a16:creationId xmlns:a16="http://schemas.microsoft.com/office/drawing/2014/main" id="{4C66CD61-BD4D-4762-A5F4-47C39BC95F82}"/>
+                <a16:creationId xmlns:a16="http://schemas.microsoft.com/office/drawing/2014/main" id="{38CA7DD7-81B5-40FB-98E3-ADE66588A29D}"/>
               </a:ext>
             </a:extLst>
           </p:cNvPr>
@@ -18688,7 +18711,7 @@
           <p:cNvPr id="10" name="">
             <a:extLst xmlns:a="http://schemas.openxmlformats.org/drawingml/2006/main">
               <a:ext uri="{FF2B5EF4-FFF2-40B4-BE49-F238E27FC236}">
-                <a16:creationId xmlns:a16="http://schemas.microsoft.com/office/drawing/2014/main" id="{E6167643-DED4-4A4F-B681-70D47EFADBBA}"/>
+                <a16:creationId xmlns:a16="http://schemas.microsoft.com/office/drawing/2014/main" id="{816AE2E4-89AC-47CA-9DD1-D1C46C06C4C3}"/>
               </a:ext>
             </a:extLst>
           </p:cNvPr>
@@ -18719,7 +18742,7 @@
           <p:cNvPr id="11" name="">
             <a:extLst xmlns:a="http://schemas.openxmlformats.org/drawingml/2006/main">
               <a:ext uri="{FF2B5EF4-FFF2-40B4-BE49-F238E27FC236}">
-                <a16:creationId xmlns:a16="http://schemas.microsoft.com/office/drawing/2014/main" id="{5FA3202E-5ADA-410A-86C3-0FC2EECC1625}"/>
+                <a16:creationId xmlns:a16="http://schemas.microsoft.com/office/drawing/2014/main" id="{4A997F0D-758C-4E40-A2AB-24AE47F61903}"/>
               </a:ext>
             </a:extLst>
           </p:cNvPr>
@@ -18876,7 +18899,7 @@
           <p:cNvPr id="12" name="">
             <a:extLst xmlns:a="http://schemas.openxmlformats.org/drawingml/2006/main">
               <a:ext uri="{FF2B5EF4-FFF2-40B4-BE49-F238E27FC236}">
-                <a16:creationId xmlns:a16="http://schemas.microsoft.com/office/drawing/2014/main" id="{7B0E2842-6301-4AF8-8C06-6DC8A328BD7E}"/>
+                <a16:creationId xmlns:a16="http://schemas.microsoft.com/office/drawing/2014/main" id="{1BF2A2D7-5A6A-4C8C-BAC7-CD233814E524}"/>
               </a:ext>
             </a:extLst>
           </p:cNvPr>
@@ -19033,7 +19056,7 @@
           <p:cNvPr id="13" name="">
             <a:extLst xmlns:a="http://schemas.openxmlformats.org/drawingml/2006/main">
               <a:ext uri="{FF2B5EF4-FFF2-40B4-BE49-F238E27FC236}">
-                <a16:creationId xmlns:a16="http://schemas.microsoft.com/office/drawing/2014/main" id="{5628E260-7AE1-47E5-9FC8-07EA36712E3A}"/>
+                <a16:creationId xmlns:a16="http://schemas.microsoft.com/office/drawing/2014/main" id="{AA10BD26-8AAE-45E3-A736-20726E59236D}"/>
               </a:ext>
             </a:extLst>
           </p:cNvPr>
@@ -19190,7 +19213,7 @@
           <p:cNvPr id="14" name="">
             <a:extLst xmlns:a="http://schemas.openxmlformats.org/drawingml/2006/main">
               <a:ext uri="{FF2B5EF4-FFF2-40B4-BE49-F238E27FC236}">
-                <a16:creationId xmlns:a16="http://schemas.microsoft.com/office/drawing/2014/main" id="{1183CFD6-801C-49B3-9D0B-69C80C5E3C40}"/>
+                <a16:creationId xmlns:a16="http://schemas.microsoft.com/office/drawing/2014/main" id="{7EE56585-643A-4173-A018-ECFA0C274A36}"/>
               </a:ext>
             </a:extLst>
           </p:cNvPr>
@@ -19347,7 +19370,7 @@
           <p:cNvPr id="15" name="">
             <a:extLst xmlns:a="http://schemas.openxmlformats.org/drawingml/2006/main">
               <a:ext uri="{FF2B5EF4-FFF2-40B4-BE49-F238E27FC236}">
-                <a16:creationId xmlns:a16="http://schemas.microsoft.com/office/drawing/2014/main" id="{DC3D0D80-7A20-4B83-8E29-154EB287EA53}"/>
+                <a16:creationId xmlns:a16="http://schemas.microsoft.com/office/drawing/2014/main" id="{5D1950E8-FBDC-48DB-855B-6E3F7974666C}"/>
               </a:ext>
             </a:extLst>
           </p:cNvPr>
@@ -19504,7 +19527,7 @@
           <p:cNvPr id="16" name="">
             <a:extLst xmlns:a="http://schemas.openxmlformats.org/drawingml/2006/main">
               <a:ext uri="{FF2B5EF4-FFF2-40B4-BE49-F238E27FC236}">
-                <a16:creationId xmlns:a16="http://schemas.microsoft.com/office/drawing/2014/main" id="{0A6611FD-B531-43E8-81FC-51AD73FB5FA8}"/>
+                <a16:creationId xmlns:a16="http://schemas.microsoft.com/office/drawing/2014/main" id="{B274B47B-2A8F-4800-9911-553AD04D2ECA}"/>
               </a:ext>
             </a:extLst>
           </p:cNvPr>
@@ -19661,7 +19684,7 @@
           <p:cNvPr id="17" name="">
             <a:extLst xmlns:a="http://schemas.openxmlformats.org/drawingml/2006/main">
               <a:ext uri="{FF2B5EF4-FFF2-40B4-BE49-F238E27FC236}">
-                <a16:creationId xmlns:a16="http://schemas.microsoft.com/office/drawing/2014/main" id="{F7DDF2B3-811C-43EE-91DA-3586F4B831C1}"/>
+                <a16:creationId xmlns:a16="http://schemas.microsoft.com/office/drawing/2014/main" id="{C28F2BF0-F7A5-405F-8871-BF8B994FED22}"/>
               </a:ext>
             </a:extLst>
           </p:cNvPr>
@@ -19818,7 +19841,7 @@
           <p:cNvPr id="18" name="">
             <a:extLst xmlns:a="http://schemas.openxmlformats.org/drawingml/2006/main">
               <a:ext uri="{FF2B5EF4-FFF2-40B4-BE49-F238E27FC236}">
-                <a16:creationId xmlns:a16="http://schemas.microsoft.com/office/drawing/2014/main" id="{C8B9CB66-05AE-403F-970F-33B2E51BD00F}"/>
+                <a16:creationId xmlns:a16="http://schemas.microsoft.com/office/drawing/2014/main" id="{41F3A24E-EF93-488C-B4E0-61E12092EAD7}"/>
               </a:ext>
             </a:extLst>
           </p:cNvPr>
@@ -19975,7 +19998,7 @@
           <p:cNvPr id="19" name="">
             <a:extLst xmlns:a="http://schemas.openxmlformats.org/drawingml/2006/main">
               <a:ext uri="{FF2B5EF4-FFF2-40B4-BE49-F238E27FC236}">
-                <a16:creationId xmlns:a16="http://schemas.microsoft.com/office/drawing/2014/main" id="{B44DFE7F-D346-46FD-A3D2-DCDFB3DD1194}"/>
+                <a16:creationId xmlns:a16="http://schemas.microsoft.com/office/drawing/2014/main" id="{931470E6-BAEB-4C85-A3BD-AF4044854EE7}"/>
               </a:ext>
             </a:extLst>
           </p:cNvPr>
@@ -20132,7 +20155,7 @@
           <p:cNvPr id="20" name="">
             <a:extLst xmlns:a="http://schemas.openxmlformats.org/drawingml/2006/main">
               <a:ext uri="{FF2B5EF4-FFF2-40B4-BE49-F238E27FC236}">
-                <a16:creationId xmlns:a16="http://schemas.microsoft.com/office/drawing/2014/main" id="{5DB8F179-15DE-4F3A-97A7-D64E954DA8F1}"/>
+                <a16:creationId xmlns:a16="http://schemas.microsoft.com/office/drawing/2014/main" id="{22B6742A-3685-4B5F-B954-FAB697B8BDC8}"/>
               </a:ext>
             </a:extLst>
           </p:cNvPr>
@@ -20312,7 +20335,7 @@
           <p:cNvPr id="21" name="">
             <a:extLst xmlns:a="http://schemas.openxmlformats.org/drawingml/2006/main">
               <a:ext uri="{FF2B5EF4-FFF2-40B4-BE49-F238E27FC236}">
-                <a16:creationId xmlns:a16="http://schemas.microsoft.com/office/drawing/2014/main" id="{BCF21C97-EE75-43EA-8FA0-1B4E81406455}"/>
+                <a16:creationId xmlns:a16="http://schemas.microsoft.com/office/drawing/2014/main" id="{98373B78-C21A-4343-96FA-348660482B8D}"/>
               </a:ext>
             </a:extLst>
           </p:cNvPr>
@@ -20467,7 +20490,7 @@
     </p:spTree>
     <p:extLst>
       <p:ext uri="{BB962C8B-B14F-4D97-AF65-F5344CB8AC3E}">
-        <p14:creationId xmlns:p14="http://schemas.microsoft.com/office/powerpoint/2010/main" val="1320248957"/>
+        <p14:creationId xmlns:p14="http://schemas.microsoft.com/office/powerpoint/2010/main" val="244018507"/>
       </p:ext>
     </p:extLst>
   </p:cSld>
@@ -20498,7 +20521,7 @@
           <p:cNvPr id="27" name="">
             <a:extLst xmlns:a="http://schemas.openxmlformats.org/drawingml/2006/main">
               <a:ext uri="{FF2B5EF4-FFF2-40B4-BE49-F238E27FC236}">
-                <a16:creationId xmlns:a16="http://schemas.microsoft.com/office/drawing/2014/main" id="{7C74FC92-9479-4087-9816-42487C498B33}"/>
+                <a16:creationId xmlns:a16="http://schemas.microsoft.com/office/drawing/2014/main" id="{BA2D0071-1B66-4144-AC16-2225344CAEFC}"/>
               </a:ext>
             </a:extLst>
           </p:cNvPr>
@@ -20655,7 +20678,7 @@
           <p:cNvPr id="2" name="">
             <a:extLst xmlns:a="http://schemas.openxmlformats.org/drawingml/2006/main">
               <a:ext uri="{FF2B5EF4-FFF2-40B4-BE49-F238E27FC236}">
-                <a16:creationId xmlns:a16="http://schemas.microsoft.com/office/drawing/2014/main" id="{F0ACA338-3C7E-4DE4-AC8B-082E6EBFA26A}"/>
+                <a16:creationId xmlns:a16="http://schemas.microsoft.com/office/drawing/2014/main" id="{B8F910AB-4821-458B-B197-BE5C4D042122}"/>
               </a:ext>
             </a:extLst>
           </p:cNvPr>
@@ -20686,7 +20709,7 @@
           <p:cNvPr id="3" name="">
             <a:extLst xmlns:a="http://schemas.openxmlformats.org/drawingml/2006/main">
               <a:ext uri="{FF2B5EF4-FFF2-40B4-BE49-F238E27FC236}">
-                <a16:creationId xmlns:a16="http://schemas.microsoft.com/office/drawing/2014/main" id="{E695AB94-20EC-490D-AAE7-B8B20961796C}"/>
+                <a16:creationId xmlns:a16="http://schemas.microsoft.com/office/drawing/2014/main" id="{F8DA591B-C629-4E90-8198-368F3B78A5E7}"/>
               </a:ext>
             </a:extLst>
           </p:cNvPr>
@@ -20843,7 +20866,7 @@
           <p:cNvPr id="4" name="">
             <a:extLst xmlns:a="http://schemas.openxmlformats.org/drawingml/2006/main">
               <a:ext uri="{FF2B5EF4-FFF2-40B4-BE49-F238E27FC236}">
-                <a16:creationId xmlns:a16="http://schemas.microsoft.com/office/drawing/2014/main" id="{E68FA4B3-FF52-45CB-86AA-F94291F7E3AE}"/>
+                <a16:creationId xmlns:a16="http://schemas.microsoft.com/office/drawing/2014/main" id="{55B3655E-3E92-4249-BC4C-7389B69E3F6D}"/>
               </a:ext>
             </a:extLst>
           </p:cNvPr>
@@ -21000,7 +21023,7 @@
           <p:cNvPr id="5" name="">
             <a:extLst xmlns:a="http://schemas.openxmlformats.org/drawingml/2006/main">
               <a:ext uri="{FF2B5EF4-FFF2-40B4-BE49-F238E27FC236}">
-                <a16:creationId xmlns:a16="http://schemas.microsoft.com/office/drawing/2014/main" id="{D1FD62D9-F765-4B9E-A8B0-80F749FD7D29}"/>
+                <a16:creationId xmlns:a16="http://schemas.microsoft.com/office/drawing/2014/main" id="{4FB016AD-610A-4D59-93FF-F39D99C26748}"/>
               </a:ext>
             </a:extLst>
           </p:cNvPr>
@@ -21157,7 +21180,7 @@
           <p:cNvPr id="6" name="">
             <a:extLst xmlns:a="http://schemas.openxmlformats.org/drawingml/2006/main">
               <a:ext uri="{FF2B5EF4-FFF2-40B4-BE49-F238E27FC236}">
-                <a16:creationId xmlns:a16="http://schemas.microsoft.com/office/drawing/2014/main" id="{6269CB20-74C6-4118-A226-E58E22F27635}"/>
+                <a16:creationId xmlns:a16="http://schemas.microsoft.com/office/drawing/2014/main" id="{9CA6062E-4C52-466A-88C4-641119FAB35B}"/>
               </a:ext>
             </a:extLst>
           </p:cNvPr>
@@ -21314,7 +21337,7 @@
           <p:cNvPr id="7" name="">
             <a:extLst xmlns:a="http://schemas.openxmlformats.org/drawingml/2006/main">
               <a:ext uri="{FF2B5EF4-FFF2-40B4-BE49-F238E27FC236}">
-                <a16:creationId xmlns:a16="http://schemas.microsoft.com/office/drawing/2014/main" id="{32F39B53-66D3-407C-8A8D-8AE3CA50828D}"/>
+                <a16:creationId xmlns:a16="http://schemas.microsoft.com/office/drawing/2014/main" id="{68D60D95-BC81-4397-996F-90DA053EC9AB}"/>
               </a:ext>
             </a:extLst>
           </p:cNvPr>
@@ -21471,7 +21494,7 @@
           <p:cNvPr id="8" name="">
             <a:extLst xmlns:a="http://schemas.openxmlformats.org/drawingml/2006/main">
               <a:ext uri="{FF2B5EF4-FFF2-40B4-BE49-F238E27FC236}">
-                <a16:creationId xmlns:a16="http://schemas.microsoft.com/office/drawing/2014/main" id="{75BC4F95-0834-4AC7-B0A9-DF436551B38D}"/>
+                <a16:creationId xmlns:a16="http://schemas.microsoft.com/office/drawing/2014/main" id="{5D94283C-DE25-4429-8F7A-93DC8926D417}"/>
               </a:ext>
             </a:extLst>
           </p:cNvPr>
@@ -21628,7 +21651,7 @@
           <p:cNvPr id="9" name="">
             <a:extLst xmlns:a="http://schemas.openxmlformats.org/drawingml/2006/main">
               <a:ext uri="{FF2B5EF4-FFF2-40B4-BE49-F238E27FC236}">
-                <a16:creationId xmlns:a16="http://schemas.microsoft.com/office/drawing/2014/main" id="{075DB53B-3A4E-4852-95D2-D787622A7314}"/>
+                <a16:creationId xmlns:a16="http://schemas.microsoft.com/office/drawing/2014/main" id="{F860182A-65C1-4C44-A747-F5270C16BD63}"/>
               </a:ext>
             </a:extLst>
           </p:cNvPr>
@@ -21785,7 +21808,7 @@
           <p:cNvPr id="10" name="">
             <a:extLst xmlns:a="http://schemas.openxmlformats.org/drawingml/2006/main">
               <a:ext uri="{FF2B5EF4-FFF2-40B4-BE49-F238E27FC236}">
-                <a16:creationId xmlns:a16="http://schemas.microsoft.com/office/drawing/2014/main" id="{70782625-2653-436C-B305-C36DF0E0BFA6}"/>
+                <a16:creationId xmlns:a16="http://schemas.microsoft.com/office/drawing/2014/main" id="{225FC757-7158-457E-8C7C-8B8C41B49D79}"/>
               </a:ext>
             </a:extLst>
           </p:cNvPr>
@@ -21942,7 +21965,7 @@
           <p:cNvPr id="11" name="">
             <a:extLst xmlns:a="http://schemas.openxmlformats.org/drawingml/2006/main">
               <a:ext uri="{FF2B5EF4-FFF2-40B4-BE49-F238E27FC236}">
-                <a16:creationId xmlns:a16="http://schemas.microsoft.com/office/drawing/2014/main" id="{5DCF61F3-F356-48FA-95A2-EFDEBFBDAE23}"/>
+                <a16:creationId xmlns:a16="http://schemas.microsoft.com/office/drawing/2014/main" id="{41D1AA90-7A85-4525-90EB-BDF2E6E825F1}"/>
               </a:ext>
             </a:extLst>
           </p:cNvPr>
@@ -22099,7 +22122,7 @@
           <p:cNvPr id="12" name="">
             <a:extLst xmlns:a="http://schemas.openxmlformats.org/drawingml/2006/main">
               <a:ext uri="{FF2B5EF4-FFF2-40B4-BE49-F238E27FC236}">
-                <a16:creationId xmlns:a16="http://schemas.microsoft.com/office/drawing/2014/main" id="{211F07CA-8B9C-40CD-A73B-206223732B0C}"/>
+                <a16:creationId xmlns:a16="http://schemas.microsoft.com/office/drawing/2014/main" id="{CAE2A002-12FF-4896-AEE2-D0C01BB98E0B}"/>
               </a:ext>
             </a:extLst>
           </p:cNvPr>
@@ -22256,7 +22279,7 @@
           <p:cNvPr id="13" name="">
             <a:extLst xmlns:a="http://schemas.openxmlformats.org/drawingml/2006/main">
               <a:ext uri="{FF2B5EF4-FFF2-40B4-BE49-F238E27FC236}">
-                <a16:creationId xmlns:a16="http://schemas.microsoft.com/office/drawing/2014/main" id="{B1DFAF4F-EF75-4501-A47C-A9D865CC6189}"/>
+                <a16:creationId xmlns:a16="http://schemas.microsoft.com/office/drawing/2014/main" id="{5F23CCD4-6CEE-4710-87A9-7193A6635383}"/>
               </a:ext>
             </a:extLst>
           </p:cNvPr>
@@ -22413,7 +22436,7 @@
           <p:cNvPr id="14" name="">
             <a:extLst xmlns:a="http://schemas.openxmlformats.org/drawingml/2006/main">
               <a:ext uri="{FF2B5EF4-FFF2-40B4-BE49-F238E27FC236}">
-                <a16:creationId xmlns:a16="http://schemas.microsoft.com/office/drawing/2014/main" id="{6CB680B9-EB80-443A-8CE9-7D1B9ED16D6A}"/>
+                <a16:creationId xmlns:a16="http://schemas.microsoft.com/office/drawing/2014/main" id="{95879D67-86BF-4B16-AE38-38B13C77B36D}"/>
               </a:ext>
             </a:extLst>
           </p:cNvPr>
@@ -22570,7 +22593,7 @@
           <p:cNvPr id="15" name="">
             <a:extLst xmlns:a="http://schemas.openxmlformats.org/drawingml/2006/main">
               <a:ext uri="{FF2B5EF4-FFF2-40B4-BE49-F238E27FC236}">
-                <a16:creationId xmlns:a16="http://schemas.microsoft.com/office/drawing/2014/main" id="{37C320AF-CF3F-4342-A9B7-D96378F2B127}"/>
+                <a16:creationId xmlns:a16="http://schemas.microsoft.com/office/drawing/2014/main" id="{76565E3E-4E0F-486E-BED7-2D6F986A803D}"/>
               </a:ext>
             </a:extLst>
           </p:cNvPr>
@@ -22727,7 +22750,7 @@
           <p:cNvPr id="16" name="">
             <a:extLst xmlns:a="http://schemas.openxmlformats.org/drawingml/2006/main">
               <a:ext uri="{FF2B5EF4-FFF2-40B4-BE49-F238E27FC236}">
-                <a16:creationId xmlns:a16="http://schemas.microsoft.com/office/drawing/2014/main" id="{A994DA4A-4100-40E5-881C-485D3DBE2059}"/>
+                <a16:creationId xmlns:a16="http://schemas.microsoft.com/office/drawing/2014/main" id="{EB5C0A8C-1752-4DFD-A3DB-80A4AB800647}"/>
               </a:ext>
             </a:extLst>
           </p:cNvPr>
@@ -22884,7 +22907,7 @@
           <p:cNvPr id="17" name="">
             <a:extLst xmlns:a="http://schemas.openxmlformats.org/drawingml/2006/main">
               <a:ext uri="{FF2B5EF4-FFF2-40B4-BE49-F238E27FC236}">
-                <a16:creationId xmlns:a16="http://schemas.microsoft.com/office/drawing/2014/main" id="{378D38FC-8397-441B-884D-1F2254D87D76}"/>
+                <a16:creationId xmlns:a16="http://schemas.microsoft.com/office/drawing/2014/main" id="{ED8552B0-EBC4-4BAA-8D26-A5E343E3B5BA}"/>
               </a:ext>
             </a:extLst>
           </p:cNvPr>
@@ -23041,7 +23064,7 @@
           <p:cNvPr id="18" name="">
             <a:extLst xmlns:a="http://schemas.openxmlformats.org/drawingml/2006/main">
               <a:ext uri="{FF2B5EF4-FFF2-40B4-BE49-F238E27FC236}">
-                <a16:creationId xmlns:a16="http://schemas.microsoft.com/office/drawing/2014/main" id="{A32E94EE-2EDA-4D93-B355-6D1D7699E9C7}"/>
+                <a16:creationId xmlns:a16="http://schemas.microsoft.com/office/drawing/2014/main" id="{3746BAB2-A0BE-4540-A8BD-5103FC5574F2}"/>
               </a:ext>
             </a:extLst>
           </p:cNvPr>
@@ -23072,7 +23095,7 @@
           <p:cNvPr id="19" name="">
             <a:extLst xmlns:a="http://schemas.openxmlformats.org/drawingml/2006/main">
               <a:ext uri="{FF2B5EF4-FFF2-40B4-BE49-F238E27FC236}">
-                <a16:creationId xmlns:a16="http://schemas.microsoft.com/office/drawing/2014/main" id="{796A1239-0068-4B96-8DF8-D58480DE2309}"/>
+                <a16:creationId xmlns:a16="http://schemas.microsoft.com/office/drawing/2014/main" id="{8CCFB816-D73E-4EF3-BAE7-83DC8318D604}"/>
               </a:ext>
             </a:extLst>
           </p:cNvPr>
@@ -23229,7 +23252,7 @@
           <p:cNvPr id="20" name="">
             <a:extLst xmlns:a="http://schemas.openxmlformats.org/drawingml/2006/main">
               <a:ext uri="{FF2B5EF4-FFF2-40B4-BE49-F238E27FC236}">
-                <a16:creationId xmlns:a16="http://schemas.microsoft.com/office/drawing/2014/main" id="{F9619865-A29B-4267-89D6-E26593A382DD}"/>
+                <a16:creationId xmlns:a16="http://schemas.microsoft.com/office/drawing/2014/main" id="{662D8467-90C9-4D2F-97A6-CF27465F7507}"/>
               </a:ext>
             </a:extLst>
           </p:cNvPr>
@@ -23386,7 +23409,7 @@
           <p:cNvPr id="21" name="">
             <a:extLst xmlns:a="http://schemas.openxmlformats.org/drawingml/2006/main">
               <a:ext uri="{FF2B5EF4-FFF2-40B4-BE49-F238E27FC236}">
-                <a16:creationId xmlns:a16="http://schemas.microsoft.com/office/drawing/2014/main" id="{A074E0CA-8760-46C2-8DBD-86045DAE6965}"/>
+                <a16:creationId xmlns:a16="http://schemas.microsoft.com/office/drawing/2014/main" id="{AEDA0A9F-C4AA-42BB-A066-C281CA7E983D}"/>
               </a:ext>
             </a:extLst>
           </p:cNvPr>
@@ -23543,7 +23566,7 @@
           <p:cNvPr id="22" name="">
             <a:extLst xmlns:a="http://schemas.openxmlformats.org/drawingml/2006/main">
               <a:ext uri="{FF2B5EF4-FFF2-40B4-BE49-F238E27FC236}">
-                <a16:creationId xmlns:a16="http://schemas.microsoft.com/office/drawing/2014/main" id="{9EBCAC46-9A80-439A-8061-4D816193AFF0}"/>
+                <a16:creationId xmlns:a16="http://schemas.microsoft.com/office/drawing/2014/main" id="{0F089C31-9B8B-4DC2-9D55-1DEE68595589}"/>
               </a:ext>
             </a:extLst>
           </p:cNvPr>
@@ -23585,7 +23608,7 @@
           <p:cNvPr id="23" name="">
             <a:extLst xmlns:a="http://schemas.openxmlformats.org/drawingml/2006/main">
               <a:ext uri="{FF2B5EF4-FFF2-40B4-BE49-F238E27FC236}">
-                <a16:creationId xmlns:a16="http://schemas.microsoft.com/office/drawing/2014/main" id="{B3D59B37-5A9C-46F8-821F-EFBDB15BC32E}"/>
+                <a16:creationId xmlns:a16="http://schemas.microsoft.com/office/drawing/2014/main" id="{AF738F26-FA69-4019-B922-A47AAE883EA7}"/>
               </a:ext>
             </a:extLst>
           </p:cNvPr>
@@ -23595,7 +23618,7 @@
           <p:nvPr/>
         </p:nvPicPr>
         <p:blipFill>
-          <a:blip xmlns:r="http://schemas.openxmlformats.org/officeDocument/2006/relationships" xmlns:a="http://schemas.openxmlformats.org/drawingml/2006/main" r:embed="R21372bcb0c44482b"/>
+          <a:blip xmlns:r="http://schemas.openxmlformats.org/officeDocument/2006/relationships" xmlns:a="http://schemas.openxmlformats.org/drawingml/2006/main" r:embed="R06033580e33d43d7"/>
           <a:stretch xmlns:a="http://schemas.openxmlformats.org/drawingml/2006/main"/>
         </p:blipFill>
         <p:spPr>
@@ -23613,7 +23636,7 @@
           <p:cNvPr id="24" name="">
             <a:extLst xmlns:a="http://schemas.openxmlformats.org/drawingml/2006/main">
               <a:ext uri="{FF2B5EF4-FFF2-40B4-BE49-F238E27FC236}">
-                <a16:creationId xmlns:a16="http://schemas.microsoft.com/office/drawing/2014/main" id="{F4F71224-E46F-43CB-BA80-AFEA8E1B8657}"/>
+                <a16:creationId xmlns:a16="http://schemas.microsoft.com/office/drawing/2014/main" id="{06EBC67D-B186-46FF-923E-BFF39E8EADD6}"/>
               </a:ext>
             </a:extLst>
           </p:cNvPr>
@@ -23770,7 +23793,7 @@
           <p:cNvPr id="25" name="">
             <a:extLst xmlns:a="http://schemas.openxmlformats.org/drawingml/2006/main">
               <a:ext uri="{FF2B5EF4-FFF2-40B4-BE49-F238E27FC236}">
-                <a16:creationId xmlns:a16="http://schemas.microsoft.com/office/drawing/2014/main" id="{9446917A-E385-4CDF-B337-FC04D3A08214}"/>
+                <a16:creationId xmlns:a16="http://schemas.microsoft.com/office/drawing/2014/main" id="{5480D736-5218-4F8F-BFFA-B9F51E96060E}"/>
               </a:ext>
             </a:extLst>
           </p:cNvPr>
@@ -23927,7 +23950,7 @@
           <p:cNvPr id="26" name="">
             <a:extLst xmlns:a="http://schemas.openxmlformats.org/drawingml/2006/main">
               <a:ext uri="{FF2B5EF4-FFF2-40B4-BE49-F238E27FC236}">
-                <a16:creationId xmlns:a16="http://schemas.microsoft.com/office/drawing/2014/main" id="{804D6670-2B19-4001-BCE4-01035F8F6C49}"/>
+                <a16:creationId xmlns:a16="http://schemas.microsoft.com/office/drawing/2014/main" id="{C1438E87-438B-4CF9-AB12-905C95F68A0C}"/>
               </a:ext>
             </a:extLst>
           </p:cNvPr>
@@ -24082,7 +24105,7 @@
     </p:spTree>
     <p:extLst>
       <p:ext uri="{BB962C8B-B14F-4D97-AF65-F5344CB8AC3E}">
-        <p14:creationId xmlns:p14="http://schemas.microsoft.com/office/powerpoint/2010/main" val="1458956020"/>
+        <p14:creationId xmlns:p14="http://schemas.microsoft.com/office/powerpoint/2010/main" val="1794393928"/>
       </p:ext>
     </p:extLst>
   </p:cSld>
@@ -24113,7 +24136,7 @@
           <p:cNvPr id="22" name="">
             <a:extLst xmlns:a="http://schemas.openxmlformats.org/drawingml/2006/main">
               <a:ext uri="{FF2B5EF4-FFF2-40B4-BE49-F238E27FC236}">
-                <a16:creationId xmlns:a16="http://schemas.microsoft.com/office/drawing/2014/main" id="{079676C1-9386-45CF-B511-F9E2779B9627}"/>
+                <a16:creationId xmlns:a16="http://schemas.microsoft.com/office/drawing/2014/main" id="{A4AD1F0F-3119-44B4-BF33-C2453C36A8D2}"/>
               </a:ext>
             </a:extLst>
           </p:cNvPr>
@@ -24270,7 +24293,7 @@
           <p:cNvPr id="2" name="">
             <a:extLst xmlns:a="http://schemas.openxmlformats.org/drawingml/2006/main">
               <a:ext uri="{FF2B5EF4-FFF2-40B4-BE49-F238E27FC236}">
-                <a16:creationId xmlns:a16="http://schemas.microsoft.com/office/drawing/2014/main" id="{0588725A-80CF-4E64-B723-606B6C9562E2}"/>
+                <a16:creationId xmlns:a16="http://schemas.microsoft.com/office/drawing/2014/main" id="{79795E60-EB0A-479A-BBEA-06268E3AFD53}"/>
               </a:ext>
             </a:extLst>
           </p:cNvPr>
@@ -24301,7 +24324,7 @@
           <p:cNvPr id="3" name="">
             <a:extLst xmlns:a="http://schemas.openxmlformats.org/drawingml/2006/main">
               <a:ext uri="{FF2B5EF4-FFF2-40B4-BE49-F238E27FC236}">
-                <a16:creationId xmlns:a16="http://schemas.microsoft.com/office/drawing/2014/main" id="{52608D4F-0A8F-44A9-A8C2-625AD8846DBD}"/>
+                <a16:creationId xmlns:a16="http://schemas.microsoft.com/office/drawing/2014/main" id="{3F6B1542-E167-4B93-A358-3FEA3E7463C4}"/>
               </a:ext>
             </a:extLst>
           </p:cNvPr>
@@ -24458,7 +24481,7 @@
           <p:cNvPr id="4" name="">
             <a:extLst xmlns:a="http://schemas.openxmlformats.org/drawingml/2006/main">
               <a:ext uri="{FF2B5EF4-FFF2-40B4-BE49-F238E27FC236}">
-                <a16:creationId xmlns:a16="http://schemas.microsoft.com/office/drawing/2014/main" id="{1CB464FE-3867-4881-8729-ABFC353B7652}"/>
+                <a16:creationId xmlns:a16="http://schemas.microsoft.com/office/drawing/2014/main" id="{8F8C5B05-635C-40EE-B186-AB8C1248B123}"/>
               </a:ext>
             </a:extLst>
           </p:cNvPr>
@@ -24615,7 +24638,7 @@
           <p:cNvPr id="5" name="">
             <a:extLst xmlns:a="http://schemas.openxmlformats.org/drawingml/2006/main">
               <a:ext uri="{FF2B5EF4-FFF2-40B4-BE49-F238E27FC236}">
-                <a16:creationId xmlns:a16="http://schemas.microsoft.com/office/drawing/2014/main" id="{ADEB287F-7D6B-4C76-92F7-7EF855EA570B}"/>
+                <a16:creationId xmlns:a16="http://schemas.microsoft.com/office/drawing/2014/main" id="{874BC3A7-58C0-4403-98C2-C062743684C2}"/>
               </a:ext>
             </a:extLst>
           </p:cNvPr>
@@ -24772,7 +24795,7 @@
           <p:cNvPr id="6" name="">
             <a:extLst xmlns:a="http://schemas.openxmlformats.org/drawingml/2006/main">
               <a:ext uri="{FF2B5EF4-FFF2-40B4-BE49-F238E27FC236}">
-                <a16:creationId xmlns:a16="http://schemas.microsoft.com/office/drawing/2014/main" id="{B0229CF9-72F8-48F6-9798-0D6B19D99A75}"/>
+                <a16:creationId xmlns:a16="http://schemas.microsoft.com/office/drawing/2014/main" id="{9E428943-254F-4241-BFE5-097CE39465B2}"/>
               </a:ext>
             </a:extLst>
           </p:cNvPr>
@@ -24929,7 +24952,7 @@
           <p:cNvPr id="7" name="">
             <a:extLst xmlns:a="http://schemas.openxmlformats.org/drawingml/2006/main">
               <a:ext uri="{FF2B5EF4-FFF2-40B4-BE49-F238E27FC236}">
-                <a16:creationId xmlns:a16="http://schemas.microsoft.com/office/drawing/2014/main" id="{E14DD365-04F2-461A-B681-BBAD9A6D0C7F}"/>
+                <a16:creationId xmlns:a16="http://schemas.microsoft.com/office/drawing/2014/main" id="{B3C57ECE-9EE0-45B9-9D9E-0D45E1232C94}"/>
               </a:ext>
             </a:extLst>
           </p:cNvPr>
@@ -25136,7 +25159,7 @@
           <p:cNvPr id="8" name="">
             <a:extLst xmlns:a="http://schemas.openxmlformats.org/drawingml/2006/main">
               <a:ext uri="{FF2B5EF4-FFF2-40B4-BE49-F238E27FC236}">
-                <a16:creationId xmlns:a16="http://schemas.microsoft.com/office/drawing/2014/main" id="{F63BD34D-B68B-4ADA-9482-747689E4EC2B}"/>
+                <a16:creationId xmlns:a16="http://schemas.microsoft.com/office/drawing/2014/main" id="{788FAACA-7972-4770-B435-DFC170AFDD6E}"/>
               </a:ext>
             </a:extLst>
           </p:cNvPr>
@@ -25176,7 +25199,7 @@
           <p:cNvPr id="9" name="">
             <a:extLst xmlns:a="http://schemas.openxmlformats.org/drawingml/2006/main">
               <a:ext uri="{FF2B5EF4-FFF2-40B4-BE49-F238E27FC236}">
-                <a16:creationId xmlns:a16="http://schemas.microsoft.com/office/drawing/2014/main" id="{16C897E9-FAD0-4B0F-8D27-DA2AFA96BF5C}"/>
+                <a16:creationId xmlns:a16="http://schemas.microsoft.com/office/drawing/2014/main" id="{B92DD2B7-572D-4772-8A71-536F3AC754B0}"/>
               </a:ext>
             </a:extLst>
           </p:cNvPr>
@@ -25333,7 +25356,7 @@
           <p:cNvPr id="10" name="">
             <a:extLst xmlns:a="http://schemas.openxmlformats.org/drawingml/2006/main">
               <a:ext uri="{FF2B5EF4-FFF2-40B4-BE49-F238E27FC236}">
-                <a16:creationId xmlns:a16="http://schemas.microsoft.com/office/drawing/2014/main" id="{DF7C6251-9072-4B4A-BDD4-9FEE5410A73A}"/>
+                <a16:creationId xmlns:a16="http://schemas.microsoft.com/office/drawing/2014/main" id="{10236779-1044-42FB-9557-60E0C70A3679}"/>
               </a:ext>
             </a:extLst>
           </p:cNvPr>
@@ -25517,7 +25540,7 @@
           <p:cNvPr id="11" name="">
             <a:extLst xmlns:a="http://schemas.openxmlformats.org/drawingml/2006/main">
               <a:ext uri="{FF2B5EF4-FFF2-40B4-BE49-F238E27FC236}">
-                <a16:creationId xmlns:a16="http://schemas.microsoft.com/office/drawing/2014/main" id="{8A6F7B22-306D-4FEF-88B3-8409FE3AB64E}"/>
+                <a16:creationId xmlns:a16="http://schemas.microsoft.com/office/drawing/2014/main" id="{2B6F5CEF-2607-4A47-9744-FEFB00D9AB63}"/>
               </a:ext>
             </a:extLst>
           </p:cNvPr>
@@ -25557,7 +25580,7 @@
           <p:cNvPr id="12" name="">
             <a:extLst xmlns:a="http://schemas.openxmlformats.org/drawingml/2006/main">
               <a:ext uri="{FF2B5EF4-FFF2-40B4-BE49-F238E27FC236}">
-                <a16:creationId xmlns:a16="http://schemas.microsoft.com/office/drawing/2014/main" id="{B83C21B7-26DD-453F-8B4D-6EAB89E92D85}"/>
+                <a16:creationId xmlns:a16="http://schemas.microsoft.com/office/drawing/2014/main" id="{AD85B957-FCA6-40EC-B86A-96BF415C41F2}"/>
               </a:ext>
             </a:extLst>
           </p:cNvPr>
@@ -25714,7 +25737,7 @@
           <p:cNvPr id="13" name="">
             <a:extLst xmlns:a="http://schemas.openxmlformats.org/drawingml/2006/main">
               <a:ext uri="{FF2B5EF4-FFF2-40B4-BE49-F238E27FC236}">
-                <a16:creationId xmlns:a16="http://schemas.microsoft.com/office/drawing/2014/main" id="{F127923C-88FB-4B49-8ADA-8C4B7EC566C1}"/>
+                <a16:creationId xmlns:a16="http://schemas.microsoft.com/office/drawing/2014/main" id="{387233E9-4F07-4227-832F-5C0DA7DAC17E}"/>
               </a:ext>
             </a:extLst>
           </p:cNvPr>
@@ -25898,7 +25921,7 @@
           <p:cNvPr id="14" name="">
             <a:extLst xmlns:a="http://schemas.openxmlformats.org/drawingml/2006/main">
               <a:ext uri="{FF2B5EF4-FFF2-40B4-BE49-F238E27FC236}">
-                <a16:creationId xmlns:a16="http://schemas.microsoft.com/office/drawing/2014/main" id="{252C00C4-590A-4820-B3D6-4503555EF991}"/>
+                <a16:creationId xmlns:a16="http://schemas.microsoft.com/office/drawing/2014/main" id="{12D9B7E5-5B7E-44ED-AA8D-06A5D8785B0E}"/>
               </a:ext>
             </a:extLst>
           </p:cNvPr>
@@ -26055,7 +26078,7 @@
           <p:cNvPr id="15" name="">
             <a:extLst xmlns:a="http://schemas.openxmlformats.org/drawingml/2006/main">
               <a:ext uri="{FF2B5EF4-FFF2-40B4-BE49-F238E27FC236}">
-                <a16:creationId xmlns:a16="http://schemas.microsoft.com/office/drawing/2014/main" id="{1E0B2CE4-A496-494C-8527-A446983F178C}"/>
+                <a16:creationId xmlns:a16="http://schemas.microsoft.com/office/drawing/2014/main" id="{9A22F0DD-B21A-427B-A499-B741F50ED2D9}"/>
               </a:ext>
             </a:extLst>
           </p:cNvPr>
@@ -26095,7 +26118,7 @@
           <p:cNvPr id="16" name="">
             <a:extLst xmlns:a="http://schemas.openxmlformats.org/drawingml/2006/main">
               <a:ext uri="{FF2B5EF4-FFF2-40B4-BE49-F238E27FC236}">
-                <a16:creationId xmlns:a16="http://schemas.microsoft.com/office/drawing/2014/main" id="{D8AC111B-43A2-42E3-B269-12311B008B6A}"/>
+                <a16:creationId xmlns:a16="http://schemas.microsoft.com/office/drawing/2014/main" id="{4FECC5FC-FD9D-4A01-AF55-1D23BF7DD08D}"/>
               </a:ext>
             </a:extLst>
           </p:cNvPr>
@@ -26279,7 +26302,7 @@
           <p:cNvPr id="17" name="">
             <a:extLst xmlns:a="http://schemas.openxmlformats.org/drawingml/2006/main">
               <a:ext uri="{FF2B5EF4-FFF2-40B4-BE49-F238E27FC236}">
-                <a16:creationId xmlns:a16="http://schemas.microsoft.com/office/drawing/2014/main" id="{E50780E3-BE6B-44FF-B6A3-4261DAFEDA4A}"/>
+                <a16:creationId xmlns:a16="http://schemas.microsoft.com/office/drawing/2014/main" id="{954BCB40-8AF6-45CF-9F3F-09505E138666}"/>
               </a:ext>
             </a:extLst>
           </p:cNvPr>
@@ -26436,7 +26459,7 @@
           <p:cNvPr id="18" name="">
             <a:extLst xmlns:a="http://schemas.openxmlformats.org/drawingml/2006/main">
               <a:ext uri="{FF2B5EF4-FFF2-40B4-BE49-F238E27FC236}">
-                <a16:creationId xmlns:a16="http://schemas.microsoft.com/office/drawing/2014/main" id="{0D6BAA0E-880F-4047-8971-2779D606A351}"/>
+                <a16:creationId xmlns:a16="http://schemas.microsoft.com/office/drawing/2014/main" id="{67C1616D-5F97-45ED-8884-53AA51C98420}"/>
               </a:ext>
             </a:extLst>
           </p:cNvPr>
@@ -26639,7 +26662,7 @@
           <p:cNvPr id="19" name="">
             <a:extLst xmlns:a="http://schemas.openxmlformats.org/drawingml/2006/main">
               <a:ext uri="{FF2B5EF4-FFF2-40B4-BE49-F238E27FC236}">
-                <a16:creationId xmlns:a16="http://schemas.microsoft.com/office/drawing/2014/main" id="{914BE6BF-3AB1-4F5F-8D58-D2E1A1CA8A08}"/>
+                <a16:creationId xmlns:a16="http://schemas.microsoft.com/office/drawing/2014/main" id="{B275031C-49A9-4A27-A2CE-A007F712ABFD}"/>
               </a:ext>
             </a:extLst>
           </p:cNvPr>
@@ -26681,7 +26704,7 @@
           <p:cNvPr id="20" name="">
             <a:extLst xmlns:a="http://schemas.openxmlformats.org/drawingml/2006/main">
               <a:ext uri="{FF2B5EF4-FFF2-40B4-BE49-F238E27FC236}">
-                <a16:creationId xmlns:a16="http://schemas.microsoft.com/office/drawing/2014/main" id="{67662594-F6D4-4783-9B98-3F7390029D60}"/>
+                <a16:creationId xmlns:a16="http://schemas.microsoft.com/office/drawing/2014/main" id="{3E4D4D77-A48C-4DFF-B9FC-057170A8A1B3}"/>
               </a:ext>
             </a:extLst>
           </p:cNvPr>
@@ -26838,7 +26861,7 @@
           <p:cNvPr id="21" name="">
             <a:extLst xmlns:a="http://schemas.openxmlformats.org/drawingml/2006/main">
               <a:ext uri="{FF2B5EF4-FFF2-40B4-BE49-F238E27FC236}">
-                <a16:creationId xmlns:a16="http://schemas.microsoft.com/office/drawing/2014/main" id="{BBD9A15C-C0F7-4F8F-A68A-801C40F4951F}"/>
+                <a16:creationId xmlns:a16="http://schemas.microsoft.com/office/drawing/2014/main" id="{BCEF5890-3C9C-4A1B-B23C-33DDC896AE93}"/>
               </a:ext>
             </a:extLst>
           </p:cNvPr>
@@ -27039,7 +27062,7 @@
     </p:spTree>
     <p:extLst>
       <p:ext uri="{BB962C8B-B14F-4D97-AF65-F5344CB8AC3E}">
-        <p14:creationId xmlns:p14="http://schemas.microsoft.com/office/powerpoint/2010/main" val="140693792"/>
+        <p14:creationId xmlns:p14="http://schemas.microsoft.com/office/powerpoint/2010/main" val="1861434388"/>
       </p:ext>
     </p:extLst>
   </p:cSld>
@@ -27070,7 +27093,7 @@
           <p:cNvPr id="27" name="">
             <a:extLst xmlns:a="http://schemas.openxmlformats.org/drawingml/2006/main">
               <a:ext uri="{FF2B5EF4-FFF2-40B4-BE49-F238E27FC236}">
-                <a16:creationId xmlns:a16="http://schemas.microsoft.com/office/drawing/2014/main" id="{A885AE92-920A-4490-AE74-F9F656111E1F}"/>
+                <a16:creationId xmlns:a16="http://schemas.microsoft.com/office/drawing/2014/main" id="{9888DEF2-4B31-4522-A130-A025EC1312D2}"/>
               </a:ext>
             </a:extLst>
           </p:cNvPr>
@@ -27227,7 +27250,7 @@
           <p:cNvPr id="2" name="">
             <a:extLst xmlns:a="http://schemas.openxmlformats.org/drawingml/2006/main">
               <a:ext uri="{FF2B5EF4-FFF2-40B4-BE49-F238E27FC236}">
-                <a16:creationId xmlns:a16="http://schemas.microsoft.com/office/drawing/2014/main" id="{DF1C1AF0-C300-42CB-8022-C44B9833F1BD}"/>
+                <a16:creationId xmlns:a16="http://schemas.microsoft.com/office/drawing/2014/main" id="{E22DBE3F-92EC-441D-88E7-F6D41D89751E}"/>
               </a:ext>
             </a:extLst>
           </p:cNvPr>
@@ -27258,7 +27281,7 @@
           <p:cNvPr id="3" name="">
             <a:extLst xmlns:a="http://schemas.openxmlformats.org/drawingml/2006/main">
               <a:ext uri="{FF2B5EF4-FFF2-40B4-BE49-F238E27FC236}">
-                <a16:creationId xmlns:a16="http://schemas.microsoft.com/office/drawing/2014/main" id="{8F20A8AF-B8D7-4EAD-9B8B-289EF31BBE31}"/>
+                <a16:creationId xmlns:a16="http://schemas.microsoft.com/office/drawing/2014/main" id="{EDA19856-2B77-487B-9BDC-EEF155DC0603}"/>
               </a:ext>
             </a:extLst>
           </p:cNvPr>
@@ -27415,7 +27438,7 @@
           <p:cNvPr id="4" name="">
             <a:extLst xmlns:a="http://schemas.openxmlformats.org/drawingml/2006/main">
               <a:ext uri="{FF2B5EF4-FFF2-40B4-BE49-F238E27FC236}">
-                <a16:creationId xmlns:a16="http://schemas.microsoft.com/office/drawing/2014/main" id="{5EF87760-830D-4FBB-A857-D715370A7564}"/>
+                <a16:creationId xmlns:a16="http://schemas.microsoft.com/office/drawing/2014/main" id="{927C3321-7979-4BC3-A25C-12871F2CAFB2}"/>
               </a:ext>
             </a:extLst>
           </p:cNvPr>
@@ -27572,7 +27595,7 @@
           <p:cNvPr id="5" name="">
             <a:extLst xmlns:a="http://schemas.openxmlformats.org/drawingml/2006/main">
               <a:ext uri="{FF2B5EF4-FFF2-40B4-BE49-F238E27FC236}">
-                <a16:creationId xmlns:a16="http://schemas.microsoft.com/office/drawing/2014/main" id="{CB33AC68-E188-4520-B540-4A58286CA9B3}"/>
+                <a16:creationId xmlns:a16="http://schemas.microsoft.com/office/drawing/2014/main" id="{333DC9A8-0B8E-4E85-8F18-F65B182D7F21}"/>
               </a:ext>
             </a:extLst>
           </p:cNvPr>
@@ -27729,7 +27752,7 @@
           <p:cNvPr id="6" name="">
             <a:extLst xmlns:a="http://schemas.openxmlformats.org/drawingml/2006/main">
               <a:ext uri="{FF2B5EF4-FFF2-40B4-BE49-F238E27FC236}">
-                <a16:creationId xmlns:a16="http://schemas.microsoft.com/office/drawing/2014/main" id="{11D78918-5CB2-49B3-B664-D99A05057DF7}"/>
+                <a16:creationId xmlns:a16="http://schemas.microsoft.com/office/drawing/2014/main" id="{4F74EB8D-3D47-4EB7-9999-7E2CA6FC4088}"/>
               </a:ext>
             </a:extLst>
           </p:cNvPr>
@@ -27886,7 +27909,7 @@
           <p:cNvPr id="7" name="">
             <a:extLst xmlns:a="http://schemas.openxmlformats.org/drawingml/2006/main">
               <a:ext uri="{FF2B5EF4-FFF2-40B4-BE49-F238E27FC236}">
-                <a16:creationId xmlns:a16="http://schemas.microsoft.com/office/drawing/2014/main" id="{B3E36699-2F4B-46E3-BAF1-791B6DFE7D4F}"/>
+                <a16:creationId xmlns:a16="http://schemas.microsoft.com/office/drawing/2014/main" id="{0B827A1D-DF96-4DE0-91A8-2ADB2D3F6F39}"/>
               </a:ext>
             </a:extLst>
           </p:cNvPr>
@@ -28043,7 +28066,7 @@
           <p:cNvPr id="8" name="">
             <a:extLst xmlns:a="http://schemas.openxmlformats.org/drawingml/2006/main">
               <a:ext uri="{FF2B5EF4-FFF2-40B4-BE49-F238E27FC236}">
-                <a16:creationId xmlns:a16="http://schemas.microsoft.com/office/drawing/2014/main" id="{8294BEA8-5C57-49DB-B412-85E563457E9A}"/>
+                <a16:creationId xmlns:a16="http://schemas.microsoft.com/office/drawing/2014/main" id="{FEA8CB6F-F2C7-4D31-B783-7FC21DA9CA62}"/>
               </a:ext>
             </a:extLst>
           </p:cNvPr>
@@ -28200,7 +28223,7 @@
           <p:cNvPr id="9" name="">
             <a:extLst xmlns:a="http://schemas.openxmlformats.org/drawingml/2006/main">
               <a:ext uri="{FF2B5EF4-FFF2-40B4-BE49-F238E27FC236}">
-                <a16:creationId xmlns:a16="http://schemas.microsoft.com/office/drawing/2014/main" id="{0AAB0839-0A2B-4919-A2BE-DEC16A302608}"/>
+                <a16:creationId xmlns:a16="http://schemas.microsoft.com/office/drawing/2014/main" id="{CF90B911-0DBE-4254-8DCC-F3BB34EAA197}"/>
               </a:ext>
             </a:extLst>
           </p:cNvPr>
@@ -28231,7 +28254,7 @@
           <p:cNvPr id="10" name="">
             <a:extLst xmlns:a="http://schemas.openxmlformats.org/drawingml/2006/main">
               <a:ext uri="{FF2B5EF4-FFF2-40B4-BE49-F238E27FC236}">
-                <a16:creationId xmlns:a16="http://schemas.microsoft.com/office/drawing/2014/main" id="{C51112F6-E0D0-49C0-B7D2-C88E2A4ABB73}"/>
+                <a16:creationId xmlns:a16="http://schemas.microsoft.com/office/drawing/2014/main" id="{5E8A2FEF-1ECB-4B0A-BDFF-9967EB7AC0BC}"/>
               </a:ext>
             </a:extLst>
           </p:cNvPr>
@@ -28388,7 +28411,7 @@
           <p:cNvPr id="11" name="">
             <a:extLst xmlns:a="http://schemas.openxmlformats.org/drawingml/2006/main">
               <a:ext uri="{FF2B5EF4-FFF2-40B4-BE49-F238E27FC236}">
-                <a16:creationId xmlns:a16="http://schemas.microsoft.com/office/drawing/2014/main" id="{F45A4A75-FD26-4784-9321-A6062D7BB4CF}"/>
+                <a16:creationId xmlns:a16="http://schemas.microsoft.com/office/drawing/2014/main" id="{6E81C696-4AA5-4622-8CD5-67ACF21799C0}"/>
               </a:ext>
             </a:extLst>
           </p:cNvPr>
@@ -28545,7 +28568,7 @@
           <p:cNvPr id="12" name="">
             <a:extLst xmlns:a="http://schemas.openxmlformats.org/drawingml/2006/main">
               <a:ext uri="{FF2B5EF4-FFF2-40B4-BE49-F238E27FC236}">
-                <a16:creationId xmlns:a16="http://schemas.microsoft.com/office/drawing/2014/main" id="{A73EB47E-842D-44C7-BF97-B31B3399FB19}"/>
+                <a16:creationId xmlns:a16="http://schemas.microsoft.com/office/drawing/2014/main" id="{D77E85C1-A5BA-4114-A54B-408D7F991EA3}"/>
               </a:ext>
             </a:extLst>
           </p:cNvPr>
@@ -28576,7 +28599,7 @@
           <p:cNvPr id="13" name="">
             <a:extLst xmlns:a="http://schemas.openxmlformats.org/drawingml/2006/main">
               <a:ext uri="{FF2B5EF4-FFF2-40B4-BE49-F238E27FC236}">
-                <a16:creationId xmlns:a16="http://schemas.microsoft.com/office/drawing/2014/main" id="{25739423-7705-46A6-ACFE-2052BE792E17}"/>
+                <a16:creationId xmlns:a16="http://schemas.microsoft.com/office/drawing/2014/main" id="{110C78CE-69BD-4510-8132-EDD5A08DD73D}"/>
               </a:ext>
             </a:extLst>
           </p:cNvPr>
@@ -28733,7 +28756,7 @@
           <p:cNvPr id="14" name="">
             <a:extLst xmlns:a="http://schemas.openxmlformats.org/drawingml/2006/main">
               <a:ext uri="{FF2B5EF4-FFF2-40B4-BE49-F238E27FC236}">
-                <a16:creationId xmlns:a16="http://schemas.microsoft.com/office/drawing/2014/main" id="{5064363E-62D5-4D3D-B507-FC1CD46178DD}"/>
+                <a16:creationId xmlns:a16="http://schemas.microsoft.com/office/drawing/2014/main" id="{9596C1C0-9EAA-4F4D-8CD2-92EF1A78BB3B}"/>
               </a:ext>
             </a:extLst>
           </p:cNvPr>
@@ -28890,7 +28913,7 @@
           <p:cNvPr id="15" name="">
             <a:extLst xmlns:a="http://schemas.openxmlformats.org/drawingml/2006/main">
               <a:ext uri="{FF2B5EF4-FFF2-40B4-BE49-F238E27FC236}">
-                <a16:creationId xmlns:a16="http://schemas.microsoft.com/office/drawing/2014/main" id="{D93FB678-2788-42B6-BFF4-D989E4F908B3}"/>
+                <a16:creationId xmlns:a16="http://schemas.microsoft.com/office/drawing/2014/main" id="{E9BB277F-73CF-4D5D-BC0A-8ED28C6C750C}"/>
               </a:ext>
             </a:extLst>
           </p:cNvPr>
@@ -28921,7 +28944,7 @@
           <p:cNvPr id="16" name="">
             <a:extLst xmlns:a="http://schemas.openxmlformats.org/drawingml/2006/main">
               <a:ext uri="{FF2B5EF4-FFF2-40B4-BE49-F238E27FC236}">
-                <a16:creationId xmlns:a16="http://schemas.microsoft.com/office/drawing/2014/main" id="{D2718D1B-7791-47CC-B017-23E3789062EA}"/>
+                <a16:creationId xmlns:a16="http://schemas.microsoft.com/office/drawing/2014/main" id="{986F0F40-82F6-4193-8690-E52FB8B188AE}"/>
               </a:ext>
             </a:extLst>
           </p:cNvPr>
@@ -29078,7 +29101,7 @@
           <p:cNvPr id="17" name="">
             <a:extLst xmlns:a="http://schemas.openxmlformats.org/drawingml/2006/main">
               <a:ext uri="{FF2B5EF4-FFF2-40B4-BE49-F238E27FC236}">
-                <a16:creationId xmlns:a16="http://schemas.microsoft.com/office/drawing/2014/main" id="{7BB8C317-42AD-4A0E-8E5C-198BE6EE350E}"/>
+                <a16:creationId xmlns:a16="http://schemas.microsoft.com/office/drawing/2014/main" id="{B5E86A1A-9991-4D2E-BBE1-31950A28624B}"/>
               </a:ext>
             </a:extLst>
           </p:cNvPr>
@@ -29235,7 +29258,7 @@
           <p:cNvPr id="18" name="">
             <a:extLst xmlns:a="http://schemas.openxmlformats.org/drawingml/2006/main">
               <a:ext uri="{FF2B5EF4-FFF2-40B4-BE49-F238E27FC236}">
-                <a16:creationId xmlns:a16="http://schemas.microsoft.com/office/drawing/2014/main" id="{C622A226-8C21-4EF8-BC9B-9692A8036690}"/>
+                <a16:creationId xmlns:a16="http://schemas.microsoft.com/office/drawing/2014/main" id="{59B9EF59-8277-440C-82CF-735EE8FF594F}"/>
               </a:ext>
             </a:extLst>
           </p:cNvPr>
@@ -29392,7 +29415,7 @@
           <p:cNvPr id="19" name="">
             <a:extLst xmlns:a="http://schemas.openxmlformats.org/drawingml/2006/main">
               <a:ext uri="{FF2B5EF4-FFF2-40B4-BE49-F238E27FC236}">
-                <a16:creationId xmlns:a16="http://schemas.microsoft.com/office/drawing/2014/main" id="{96E7CE2D-1142-4AC7-A9E0-521E92CFB781}"/>
+                <a16:creationId xmlns:a16="http://schemas.microsoft.com/office/drawing/2014/main" id="{956784A2-0092-4550-8952-A462E403C9DD}"/>
               </a:ext>
             </a:extLst>
           </p:cNvPr>
@@ -29434,7 +29457,7 @@
           <p:cNvPr id="20" name="">
             <a:extLst xmlns:a="http://schemas.openxmlformats.org/drawingml/2006/main">
               <a:ext uri="{FF2B5EF4-FFF2-40B4-BE49-F238E27FC236}">
-                <a16:creationId xmlns:a16="http://schemas.microsoft.com/office/drawing/2014/main" id="{DA0105D5-B566-43B4-83A9-E33B92173C6B}"/>
+                <a16:creationId xmlns:a16="http://schemas.microsoft.com/office/drawing/2014/main" id="{D560CDF6-128F-4866-A0F4-5D5B5D4CB7E4}"/>
               </a:ext>
             </a:extLst>
           </p:cNvPr>
@@ -29444,7 +29467,7 @@
           <p:nvPr/>
         </p:nvPicPr>
         <p:blipFill>
-          <a:blip xmlns:r="http://schemas.openxmlformats.org/officeDocument/2006/relationships" xmlns:a="http://schemas.openxmlformats.org/drawingml/2006/main" r:embed="Rb3e78c2b78784806"/>
+          <a:blip xmlns:r="http://schemas.openxmlformats.org/officeDocument/2006/relationships" xmlns:a="http://schemas.openxmlformats.org/drawingml/2006/main" r:embed="Rc0c821fd213d43e5"/>
           <a:stretch xmlns:a="http://schemas.openxmlformats.org/drawingml/2006/main"/>
         </p:blipFill>
         <p:spPr>
@@ -29462,7 +29485,7 @@
           <p:cNvPr id="21" name="">
             <a:extLst xmlns:a="http://schemas.openxmlformats.org/drawingml/2006/main">
               <a:ext uri="{FF2B5EF4-FFF2-40B4-BE49-F238E27FC236}">
-                <a16:creationId xmlns:a16="http://schemas.microsoft.com/office/drawing/2014/main" id="{A213646F-BAF2-4AF4-B781-168E1588D9D5}"/>
+                <a16:creationId xmlns:a16="http://schemas.microsoft.com/office/drawing/2014/main" id="{8F80DA9B-1439-4005-A094-395D79137218}"/>
               </a:ext>
             </a:extLst>
           </p:cNvPr>
@@ -29619,7 +29642,7 @@
           <p:cNvPr id="22" name="">
             <a:extLst xmlns:a="http://schemas.openxmlformats.org/drawingml/2006/main">
               <a:ext uri="{FF2B5EF4-FFF2-40B4-BE49-F238E27FC236}">
-                <a16:creationId xmlns:a16="http://schemas.microsoft.com/office/drawing/2014/main" id="{2D50687F-807A-4A7C-92C7-4C0269C1BFD8}"/>
+                <a16:creationId xmlns:a16="http://schemas.microsoft.com/office/drawing/2014/main" id="{2418771C-DA9E-4F83-9D28-6261643943A3}"/>
               </a:ext>
             </a:extLst>
           </p:cNvPr>
@@ -29776,7 +29799,7 @@
           <p:cNvPr id="23" name="">
             <a:extLst xmlns:a="http://schemas.openxmlformats.org/drawingml/2006/main">
               <a:ext uri="{FF2B5EF4-FFF2-40B4-BE49-F238E27FC236}">
-                <a16:creationId xmlns:a16="http://schemas.microsoft.com/office/drawing/2014/main" id="{973C24A1-27D4-4F5E-9735-3B1D305E0D07}"/>
+                <a16:creationId xmlns:a16="http://schemas.microsoft.com/office/drawing/2014/main" id="{2547D76F-9F11-4737-B54F-7652171A2F54}"/>
               </a:ext>
             </a:extLst>
           </p:cNvPr>
@@ -29933,7 +29956,7 @@
           <p:cNvPr id="24" name="">
             <a:extLst xmlns:a="http://schemas.openxmlformats.org/drawingml/2006/main">
               <a:ext uri="{FF2B5EF4-FFF2-40B4-BE49-F238E27FC236}">
-                <a16:creationId xmlns:a16="http://schemas.microsoft.com/office/drawing/2014/main" id="{0169BC37-A6FC-4327-8486-D2CF91B7748A}"/>
+                <a16:creationId xmlns:a16="http://schemas.microsoft.com/office/drawing/2014/main" id="{53BE0AA7-2FDC-4E7E-B025-263971136D18}"/>
               </a:ext>
             </a:extLst>
           </p:cNvPr>
@@ -30090,7 +30113,7 @@
           <p:cNvPr id="25" name="">
             <a:extLst xmlns:a="http://schemas.openxmlformats.org/drawingml/2006/main">
               <a:ext uri="{FF2B5EF4-FFF2-40B4-BE49-F238E27FC236}">
-                <a16:creationId xmlns:a16="http://schemas.microsoft.com/office/drawing/2014/main" id="{8C321D3D-2BB8-42D1-B1C9-8484F1C6F4F9}"/>
+                <a16:creationId xmlns:a16="http://schemas.microsoft.com/office/drawing/2014/main" id="{8C0D25DD-FA22-4608-AF92-A8BE02C9C31E}"/>
               </a:ext>
             </a:extLst>
           </p:cNvPr>
@@ -30247,7 +30270,7 @@
           <p:cNvPr id="26" name="">
             <a:extLst xmlns:a="http://schemas.openxmlformats.org/drawingml/2006/main">
               <a:ext uri="{FF2B5EF4-FFF2-40B4-BE49-F238E27FC236}">
-                <a16:creationId xmlns:a16="http://schemas.microsoft.com/office/drawing/2014/main" id="{C7398435-9E1E-468B-BDBD-1B963AB7780A}"/>
+                <a16:creationId xmlns:a16="http://schemas.microsoft.com/office/drawing/2014/main" id="{5EC979AE-6B23-4184-8787-775A7DF591DE}"/>
               </a:ext>
             </a:extLst>
           </p:cNvPr>
@@ -30402,7 +30425,7 @@
     </p:spTree>
     <p:extLst>
       <p:ext uri="{BB962C8B-B14F-4D97-AF65-F5344CB8AC3E}">
-        <p14:creationId xmlns:p14="http://schemas.microsoft.com/office/powerpoint/2010/main" val="470989444"/>
+        <p14:creationId xmlns:p14="http://schemas.microsoft.com/office/powerpoint/2010/main" val="150811673"/>
       </p:ext>
     </p:extLst>
   </p:cSld>
@@ -30433,7 +30456,7 @@
           <p:cNvPr id="18" name="">
             <a:extLst xmlns:a="http://schemas.openxmlformats.org/drawingml/2006/main">
               <a:ext uri="{FF2B5EF4-FFF2-40B4-BE49-F238E27FC236}">
-                <a16:creationId xmlns:a16="http://schemas.microsoft.com/office/drawing/2014/main" id="{9D5B9A45-B7C7-4E76-AB2D-7C368B24624F}"/>
+                <a16:creationId xmlns:a16="http://schemas.microsoft.com/office/drawing/2014/main" id="{F9791AD7-E728-4FDF-85E3-87CCCC19D846}"/>
               </a:ext>
             </a:extLst>
           </p:cNvPr>
@@ -30590,7 +30613,7 @@
           <p:cNvPr id="2" name="">
             <a:extLst xmlns:a="http://schemas.openxmlformats.org/drawingml/2006/main">
               <a:ext uri="{FF2B5EF4-FFF2-40B4-BE49-F238E27FC236}">
-                <a16:creationId xmlns:a16="http://schemas.microsoft.com/office/drawing/2014/main" id="{75350DE8-ED53-41B7-811E-454DA6ED76C4}"/>
+                <a16:creationId xmlns:a16="http://schemas.microsoft.com/office/drawing/2014/main" id="{95F391E0-98AF-4C6E-9BF2-9C63597E4894}"/>
               </a:ext>
             </a:extLst>
           </p:cNvPr>
@@ -30621,7 +30644,7 @@
           <p:cNvPr id="3" name="">
             <a:extLst xmlns:a="http://schemas.openxmlformats.org/drawingml/2006/main">
               <a:ext uri="{FF2B5EF4-FFF2-40B4-BE49-F238E27FC236}">
-                <a16:creationId xmlns:a16="http://schemas.microsoft.com/office/drawing/2014/main" id="{E69E354E-3F53-45C2-9506-B08F61850DBB}"/>
+                <a16:creationId xmlns:a16="http://schemas.microsoft.com/office/drawing/2014/main" id="{A65F3CBE-B2CF-4B9F-8DD9-8A5F73602908}"/>
               </a:ext>
             </a:extLst>
           </p:cNvPr>
@@ -30778,7 +30801,7 @@
           <p:cNvPr id="4" name="">
             <a:extLst xmlns:a="http://schemas.openxmlformats.org/drawingml/2006/main">
               <a:ext uri="{FF2B5EF4-FFF2-40B4-BE49-F238E27FC236}">
-                <a16:creationId xmlns:a16="http://schemas.microsoft.com/office/drawing/2014/main" id="{8983D1F3-1A1B-47E0-A8AD-7BD4F6F5EB33}"/>
+                <a16:creationId xmlns:a16="http://schemas.microsoft.com/office/drawing/2014/main" id="{2985E6B5-5E8D-41AB-AC12-3D5CCCE203F5}"/>
               </a:ext>
             </a:extLst>
           </p:cNvPr>
@@ -30935,7 +30958,7 @@
           <p:cNvPr id="5" name="">
             <a:extLst xmlns:a="http://schemas.openxmlformats.org/drawingml/2006/main">
               <a:ext uri="{FF2B5EF4-FFF2-40B4-BE49-F238E27FC236}">
-                <a16:creationId xmlns:a16="http://schemas.microsoft.com/office/drawing/2014/main" id="{1E13DADC-026C-4260-8155-86C446BD02AA}"/>
+                <a16:creationId xmlns:a16="http://schemas.microsoft.com/office/drawing/2014/main" id="{27059FBF-ABC7-4D08-B426-9AC38E2CAA73}"/>
               </a:ext>
             </a:extLst>
           </p:cNvPr>
@@ -31092,7 +31115,7 @@
           <p:cNvPr id="6" name="Chart">
             <a:extLst xmlns:a="http://schemas.openxmlformats.org/drawingml/2006/main">
               <a:ext uri="{FF2B5EF4-FFF2-40B4-BE49-F238E27FC236}">
-                <a16:creationId xmlns:a16="http://schemas.microsoft.com/office/drawing/2014/main" id="{543B7B81-5286-4A91-ABBC-8FBFA41976C9}"/>
+                <a16:creationId xmlns:a16="http://schemas.microsoft.com/office/drawing/2014/main" id="{213326DE-8961-4D8D-A543-19C9AD12AD4C}"/>
               </a:ext>
             </a:extLst>
           </p:cNvPr>
@@ -31105,7 +31128,7 @@
         </p:xfrm>
         <a:graphic xmlns:a="http://schemas.openxmlformats.org/drawingml/2006/main">
           <a:graphicData uri="http://schemas.openxmlformats.org/drawingml/2006/chart">
-            <c:chart xmlns:r="http://schemas.openxmlformats.org/officeDocument/2006/relationships" xmlns:c="http://schemas.openxmlformats.org/drawingml/2006/chart" r:id="R8bee8c047be74bfd"/>
+            <c:chart xmlns:r="http://schemas.openxmlformats.org/officeDocument/2006/relationships" xmlns:c="http://schemas.openxmlformats.org/drawingml/2006/chart" r:id="R929cfb6cfe82482d"/>
           </a:graphicData>
         </a:graphic>
       </p:graphicFrame>
@@ -31114,7 +31137,7 @@
           <p:cNvPr id="7" name="">
             <a:extLst xmlns:a="http://schemas.openxmlformats.org/drawingml/2006/main">
               <a:ext uri="{FF2B5EF4-FFF2-40B4-BE49-F238E27FC236}">
-                <a16:creationId xmlns:a16="http://schemas.microsoft.com/office/drawing/2014/main" id="{CE2CAE7C-ABFA-40F6-9B13-3CED4207D50A}"/>
+                <a16:creationId xmlns:a16="http://schemas.microsoft.com/office/drawing/2014/main" id="{137D6772-A6EB-448A-A928-8A02D7948E1B}"/>
               </a:ext>
             </a:extLst>
           </p:cNvPr>
@@ -31271,7 +31294,7 @@
           <p:cNvPr id="8" name="">
             <a:extLst xmlns:a="http://schemas.openxmlformats.org/drawingml/2006/main">
               <a:ext uri="{FF2B5EF4-FFF2-40B4-BE49-F238E27FC236}">
-                <a16:creationId xmlns:a16="http://schemas.microsoft.com/office/drawing/2014/main" id="{CC245B33-A0A8-449A-A831-A82125716C6B}"/>
+                <a16:creationId xmlns:a16="http://schemas.microsoft.com/office/drawing/2014/main" id="{ED3F74C3-CE89-4834-ABC3-C306E3DEAA04}"/>
               </a:ext>
             </a:extLst>
           </p:cNvPr>
@@ -31428,7 +31451,7 @@
           <p:cNvPr id="9" name="">
             <a:extLst xmlns:a="http://schemas.openxmlformats.org/drawingml/2006/main">
               <a:ext uri="{FF2B5EF4-FFF2-40B4-BE49-F238E27FC236}">
-                <a16:creationId xmlns:a16="http://schemas.microsoft.com/office/drawing/2014/main" id="{4414AF5A-D9D9-4BA3-8B97-8252A5CC4BF1}"/>
+                <a16:creationId xmlns:a16="http://schemas.microsoft.com/office/drawing/2014/main" id="{606F35B9-E21D-49C5-99CB-FE69EEE42FC5}"/>
               </a:ext>
             </a:extLst>
           </p:cNvPr>
@@ -31459,7 +31482,7 @@
           <p:cNvPr id="10" name="">
             <a:extLst xmlns:a="http://schemas.openxmlformats.org/drawingml/2006/main">
               <a:ext uri="{FF2B5EF4-FFF2-40B4-BE49-F238E27FC236}">
-                <a16:creationId xmlns:a16="http://schemas.microsoft.com/office/drawing/2014/main" id="{0DF35974-A12B-4B08-B2AF-BBC8C768C895}"/>
+                <a16:creationId xmlns:a16="http://schemas.microsoft.com/office/drawing/2014/main" id="{6BAC5F54-7940-4DE9-9C60-BFC343644BF5}"/>
               </a:ext>
             </a:extLst>
           </p:cNvPr>
@@ -31616,7 +31639,7 @@
           <p:cNvPr id="11" name="">
             <a:extLst xmlns:a="http://schemas.openxmlformats.org/drawingml/2006/main">
               <a:ext uri="{FF2B5EF4-FFF2-40B4-BE49-F238E27FC236}">
-                <a16:creationId xmlns:a16="http://schemas.microsoft.com/office/drawing/2014/main" id="{4A48C3D4-D2D4-48A9-97F9-42C5265FD491}"/>
+                <a16:creationId xmlns:a16="http://schemas.microsoft.com/office/drawing/2014/main" id="{65C92A9E-D413-4B2C-9842-E21C4363C568}"/>
               </a:ext>
             </a:extLst>
           </p:cNvPr>
@@ -31773,7 +31796,7 @@
           <p:cNvPr id="12" name="">
             <a:extLst xmlns:a="http://schemas.openxmlformats.org/drawingml/2006/main">
               <a:ext uri="{FF2B5EF4-FFF2-40B4-BE49-F238E27FC236}">
-                <a16:creationId xmlns:a16="http://schemas.microsoft.com/office/drawing/2014/main" id="{5D8FDA7C-910A-468B-8186-AC4ABFD42D09}"/>
+                <a16:creationId xmlns:a16="http://schemas.microsoft.com/office/drawing/2014/main" id="{D193CEE1-C77E-4CEF-B604-2CA444232721}"/>
               </a:ext>
             </a:extLst>
           </p:cNvPr>
@@ -31930,7 +31953,7 @@
           <p:cNvPr id="13" name="">
             <a:extLst xmlns:a="http://schemas.openxmlformats.org/drawingml/2006/main">
               <a:ext uri="{FF2B5EF4-FFF2-40B4-BE49-F238E27FC236}">
-                <a16:creationId xmlns:a16="http://schemas.microsoft.com/office/drawing/2014/main" id="{46E88D50-76F0-4ADE-8984-B073C13F93C2}"/>
+                <a16:creationId xmlns:a16="http://schemas.microsoft.com/office/drawing/2014/main" id="{D360BFF4-0E35-4458-9798-8B5D97566CA7}"/>
               </a:ext>
             </a:extLst>
           </p:cNvPr>
@@ -32087,7 +32110,7 @@
           <p:cNvPr id="14" name="">
             <a:extLst xmlns:a="http://schemas.openxmlformats.org/drawingml/2006/main">
               <a:ext uri="{FF2B5EF4-FFF2-40B4-BE49-F238E27FC236}">
-                <a16:creationId xmlns:a16="http://schemas.microsoft.com/office/drawing/2014/main" id="{F2D8EF85-47FC-4DE9-A6AC-14A6254058DE}"/>
+                <a16:creationId xmlns:a16="http://schemas.microsoft.com/office/drawing/2014/main" id="{AEFB2D85-AA12-4BEB-992C-389C61C25AA5}"/>
               </a:ext>
             </a:extLst>
           </p:cNvPr>
@@ -32244,7 +32267,7 @@
           <p:cNvPr id="15" name="">
             <a:extLst xmlns:a="http://schemas.openxmlformats.org/drawingml/2006/main">
               <a:ext uri="{FF2B5EF4-FFF2-40B4-BE49-F238E27FC236}">
-                <a16:creationId xmlns:a16="http://schemas.microsoft.com/office/drawing/2014/main" id="{D05F272F-7E5D-45E3-A102-C2702FB834EC}"/>
+                <a16:creationId xmlns:a16="http://schemas.microsoft.com/office/drawing/2014/main" id="{2F1A8A95-0B57-43A1-A8C6-D5E8F2BE8A9C}"/>
               </a:ext>
             </a:extLst>
           </p:cNvPr>
@@ -32401,7 +32424,7 @@
           <p:cNvPr id="16" name="">
             <a:extLst xmlns:a="http://schemas.openxmlformats.org/drawingml/2006/main">
               <a:ext uri="{FF2B5EF4-FFF2-40B4-BE49-F238E27FC236}">
-                <a16:creationId xmlns:a16="http://schemas.microsoft.com/office/drawing/2014/main" id="{32F44D2C-4147-49EA-B2EB-C4A0482CFEDF}"/>
+                <a16:creationId xmlns:a16="http://schemas.microsoft.com/office/drawing/2014/main" id="{84E1C357-D6D2-43C9-8DD6-CB29165C5A0A}"/>
               </a:ext>
             </a:extLst>
           </p:cNvPr>
@@ -32558,7 +32581,7 @@
           <p:cNvPr id="17" name="">
             <a:extLst xmlns:a="http://schemas.openxmlformats.org/drawingml/2006/main">
               <a:ext uri="{FF2B5EF4-FFF2-40B4-BE49-F238E27FC236}">
-                <a16:creationId xmlns:a16="http://schemas.microsoft.com/office/drawing/2014/main" id="{91B596DB-7CE5-4DAE-AB18-EDFDCD6CE8AC}"/>
+                <a16:creationId xmlns:a16="http://schemas.microsoft.com/office/drawing/2014/main" id="{5D403A8E-BADD-4166-9B3A-CFD9DB214B56}"/>
               </a:ext>
             </a:extLst>
           </p:cNvPr>
@@ -32713,7 +32736,7 @@
     </p:spTree>
     <p:extLst>
       <p:ext uri="{BB962C8B-B14F-4D97-AF65-F5344CB8AC3E}">
-        <p14:creationId xmlns:p14="http://schemas.microsoft.com/office/powerpoint/2010/main" val="2106789842"/>
+        <p14:creationId xmlns:p14="http://schemas.microsoft.com/office/powerpoint/2010/main" val="756635285"/>
       </p:ext>
     </p:extLst>
   </p:cSld>
@@ -32744,7 +32767,7 @@
           <p:cNvPr id="18" name="">
             <a:extLst xmlns:a="http://schemas.openxmlformats.org/drawingml/2006/main">
               <a:ext uri="{FF2B5EF4-FFF2-40B4-BE49-F238E27FC236}">
-                <a16:creationId xmlns:a16="http://schemas.microsoft.com/office/drawing/2014/main" id="{8D2C3EF5-FA7F-4FAA-9AE6-87370338E95F}"/>
+                <a16:creationId xmlns:a16="http://schemas.microsoft.com/office/drawing/2014/main" id="{286DB922-A7F7-4D59-80A5-CEEA82D48C10}"/>
               </a:ext>
             </a:extLst>
           </p:cNvPr>
@@ -32901,7 +32924,7 @@
           <p:cNvPr id="2" name="">
             <a:extLst xmlns:a="http://schemas.openxmlformats.org/drawingml/2006/main">
               <a:ext uri="{FF2B5EF4-FFF2-40B4-BE49-F238E27FC236}">
-                <a16:creationId xmlns:a16="http://schemas.microsoft.com/office/drawing/2014/main" id="{5580280B-EA26-4E0B-8F61-BCFED7BCE752}"/>
+                <a16:creationId xmlns:a16="http://schemas.microsoft.com/office/drawing/2014/main" id="{33C5917F-6CDC-4449-A473-1BAB6652759A}"/>
               </a:ext>
             </a:extLst>
           </p:cNvPr>
@@ -32932,7 +32955,7 @@
           <p:cNvPr id="3" name="">
             <a:extLst xmlns:a="http://schemas.openxmlformats.org/drawingml/2006/main">
               <a:ext uri="{FF2B5EF4-FFF2-40B4-BE49-F238E27FC236}">
-                <a16:creationId xmlns:a16="http://schemas.microsoft.com/office/drawing/2014/main" id="{2AAB40CB-56C0-4580-90E0-0B8300686213}"/>
+                <a16:creationId xmlns:a16="http://schemas.microsoft.com/office/drawing/2014/main" id="{0420C686-1BBC-4AF7-85E2-E0863AA18E1C}"/>
               </a:ext>
             </a:extLst>
           </p:cNvPr>
@@ -33089,7 +33112,7 @@
           <p:cNvPr id="4" name="">
             <a:extLst xmlns:a="http://schemas.openxmlformats.org/drawingml/2006/main">
               <a:ext uri="{FF2B5EF4-FFF2-40B4-BE49-F238E27FC236}">
-                <a16:creationId xmlns:a16="http://schemas.microsoft.com/office/drawing/2014/main" id="{33520BE2-8C18-43CF-95AF-9DF6E9C866C8}"/>
+                <a16:creationId xmlns:a16="http://schemas.microsoft.com/office/drawing/2014/main" id="{71774F68-7ABB-474A-9821-FE3607C7C965}"/>
               </a:ext>
             </a:extLst>
           </p:cNvPr>
@@ -33246,7 +33269,7 @@
           <p:cNvPr id="5" name="">
             <a:extLst xmlns:a="http://schemas.openxmlformats.org/drawingml/2006/main">
               <a:ext uri="{FF2B5EF4-FFF2-40B4-BE49-F238E27FC236}">
-                <a16:creationId xmlns:a16="http://schemas.microsoft.com/office/drawing/2014/main" id="{8B8C64E6-DB9A-4233-BC81-78C60507F8E8}"/>
+                <a16:creationId xmlns:a16="http://schemas.microsoft.com/office/drawing/2014/main" id="{0003457C-259D-4659-8ADF-8A771D26FC0A}"/>
               </a:ext>
             </a:extLst>
           </p:cNvPr>
@@ -33403,7 +33426,7 @@
           <p:cNvPr id="6" name="">
             <a:extLst xmlns:a="http://schemas.openxmlformats.org/drawingml/2006/main">
               <a:ext uri="{FF2B5EF4-FFF2-40B4-BE49-F238E27FC236}">
-                <a16:creationId xmlns:a16="http://schemas.microsoft.com/office/drawing/2014/main" id="{55E70437-A0BC-46F7-ADBF-891D2F8F6C2E}"/>
+                <a16:creationId xmlns:a16="http://schemas.microsoft.com/office/drawing/2014/main" id="{133BF1BE-9009-42E4-A8FE-B6B2A30E6DA8}"/>
               </a:ext>
             </a:extLst>
           </p:cNvPr>
@@ -34217,7 +34240,7 @@
           <p:cNvPr id="7" name="">
             <a:extLst xmlns:a="http://schemas.openxmlformats.org/drawingml/2006/main">
               <a:ext uri="{FF2B5EF4-FFF2-40B4-BE49-F238E27FC236}">
-                <a16:creationId xmlns:a16="http://schemas.microsoft.com/office/drawing/2014/main" id="{27599A4A-849C-40D6-8198-708BD43A1085}"/>
+                <a16:creationId xmlns:a16="http://schemas.microsoft.com/office/drawing/2014/main" id="{91A20C09-8F1B-4CEF-9096-5E3E62ECFD43}"/>
               </a:ext>
             </a:extLst>
           </p:cNvPr>
@@ -34374,7 +34397,7 @@
           <p:cNvPr id="8" name="">
             <a:extLst xmlns:a="http://schemas.openxmlformats.org/drawingml/2006/main">
               <a:ext uri="{FF2B5EF4-FFF2-40B4-BE49-F238E27FC236}">
-                <a16:creationId xmlns:a16="http://schemas.microsoft.com/office/drawing/2014/main" id="{5C404FA9-4BA2-4405-83B7-46A088548D17}"/>
+                <a16:creationId xmlns:a16="http://schemas.microsoft.com/office/drawing/2014/main" id="{D584CE4F-B998-47F8-A8E3-FE8DE11281FB}"/>
               </a:ext>
             </a:extLst>
           </p:cNvPr>
@@ -34531,7 +34554,7 @@
           <p:cNvPr id="9" name="">
             <a:extLst xmlns:a="http://schemas.openxmlformats.org/drawingml/2006/main">
               <a:ext uri="{FF2B5EF4-FFF2-40B4-BE49-F238E27FC236}">
-                <a16:creationId xmlns:a16="http://schemas.microsoft.com/office/drawing/2014/main" id="{E1F4D1E3-D8FF-48B7-9B4B-C3D9A29826BB}"/>
+                <a16:creationId xmlns:a16="http://schemas.microsoft.com/office/drawing/2014/main" id="{6D26FBC8-FB9A-4C54-ACE1-BB870F656CB0}"/>
               </a:ext>
             </a:extLst>
           </p:cNvPr>
@@ -34688,7 +34711,7 @@
           <p:cNvPr id="10" name="">
             <a:extLst xmlns:a="http://schemas.openxmlformats.org/drawingml/2006/main">
               <a:ext uri="{FF2B5EF4-FFF2-40B4-BE49-F238E27FC236}">
-                <a16:creationId xmlns:a16="http://schemas.microsoft.com/office/drawing/2014/main" id="{B1123C33-175F-40B0-ACC6-296F3CA7979B}"/>
+                <a16:creationId xmlns:a16="http://schemas.microsoft.com/office/drawing/2014/main" id="{24709AEA-564D-4756-991F-403CFBB51977}"/>
               </a:ext>
             </a:extLst>
           </p:cNvPr>
@@ -34845,7 +34868,7 @@
           <p:cNvPr id="11" name="">
             <a:extLst xmlns:a="http://schemas.openxmlformats.org/drawingml/2006/main">
               <a:ext uri="{FF2B5EF4-FFF2-40B4-BE49-F238E27FC236}">
-                <a16:creationId xmlns:a16="http://schemas.microsoft.com/office/drawing/2014/main" id="{EC573360-C90D-436A-9E01-839DD4A000E5}"/>
+                <a16:creationId xmlns:a16="http://schemas.microsoft.com/office/drawing/2014/main" id="{C3404169-D105-46DA-86E0-EB10A516DCDB}"/>
               </a:ext>
             </a:extLst>
           </p:cNvPr>
@@ -35002,7 +35025,7 @@
           <p:cNvPr id="12" name="">
             <a:extLst xmlns:a="http://schemas.openxmlformats.org/drawingml/2006/main">
               <a:ext uri="{FF2B5EF4-FFF2-40B4-BE49-F238E27FC236}">
-                <a16:creationId xmlns:a16="http://schemas.microsoft.com/office/drawing/2014/main" id="{EFF27D98-616E-4B25-B106-F8F9B2ABB0A0}"/>
+                <a16:creationId xmlns:a16="http://schemas.microsoft.com/office/drawing/2014/main" id="{440F28FB-0E3E-4F20-995D-2FFD3BD92BDD}"/>
               </a:ext>
             </a:extLst>
           </p:cNvPr>
@@ -35033,7 +35056,7 @@
           <p:cNvPr id="13" name="">
             <a:extLst xmlns:a="http://schemas.openxmlformats.org/drawingml/2006/main">
               <a:ext uri="{FF2B5EF4-FFF2-40B4-BE49-F238E27FC236}">
-                <a16:creationId xmlns:a16="http://schemas.microsoft.com/office/drawing/2014/main" id="{F9B06221-F348-4955-8C73-19A1DF68C6A3}"/>
+                <a16:creationId xmlns:a16="http://schemas.microsoft.com/office/drawing/2014/main" id="{09DE07ED-E221-4E8E-92B5-7355CD9BB825}"/>
               </a:ext>
             </a:extLst>
           </p:cNvPr>
@@ -35190,7 +35213,7 @@
           <p:cNvPr id="14" name="">
             <a:extLst xmlns:a="http://schemas.openxmlformats.org/drawingml/2006/main">
               <a:ext uri="{FF2B5EF4-FFF2-40B4-BE49-F238E27FC236}">
-                <a16:creationId xmlns:a16="http://schemas.microsoft.com/office/drawing/2014/main" id="{E20DCF29-D698-4EA9-BE34-B0D74AF1E609}"/>
+                <a16:creationId xmlns:a16="http://schemas.microsoft.com/office/drawing/2014/main" id="{76240E05-5BD2-4C9C-B4F4-6AF63E968373}"/>
               </a:ext>
             </a:extLst>
           </p:cNvPr>
@@ -35347,7 +35370,7 @@
           <p:cNvPr id="15" name="p6-status-update">
             <a:extLst xmlns:a="http://schemas.openxmlformats.org/drawingml/2006/main">
               <a:ext uri="{FF2B5EF4-FFF2-40B4-BE49-F238E27FC236}">
-                <a16:creationId xmlns:a16="http://schemas.microsoft.com/office/drawing/2014/main" id="{C7A0F273-D196-4E57-9BAD-09269D298967}"/>
+                <a16:creationId xmlns:a16="http://schemas.microsoft.com/office/drawing/2014/main" id="{106413D4-94E8-43A5-860D-BC83DF837F76}"/>
               </a:ext>
             </a:extLst>
           </p:cNvPr>
@@ -35573,7 +35596,7 @@
           <p:cNvPr id="16" name="">
             <a:extLst xmlns:a="http://schemas.openxmlformats.org/drawingml/2006/main">
               <a:ext uri="{FF2B5EF4-FFF2-40B4-BE49-F238E27FC236}">
-                <a16:creationId xmlns:a16="http://schemas.microsoft.com/office/drawing/2014/main" id="{7167F246-947C-4689-97A8-9D76D27EC38D}"/>
+                <a16:creationId xmlns:a16="http://schemas.microsoft.com/office/drawing/2014/main" id="{05946E42-B37B-4E77-8F81-E9AF949612B4}"/>
               </a:ext>
             </a:extLst>
           </p:cNvPr>
@@ -35730,7 +35753,7 @@
           <p:cNvPr id="17" name="">
             <a:extLst xmlns:a="http://schemas.openxmlformats.org/drawingml/2006/main">
               <a:ext uri="{FF2B5EF4-FFF2-40B4-BE49-F238E27FC236}">
-                <a16:creationId xmlns:a16="http://schemas.microsoft.com/office/drawing/2014/main" id="{B98F68E3-B2A8-49D6-9055-64CFB8727574}"/>
+                <a16:creationId xmlns:a16="http://schemas.microsoft.com/office/drawing/2014/main" id="{F9319BA8-96C4-4223-A5ED-8E64E571FD43}"/>
               </a:ext>
             </a:extLst>
           </p:cNvPr>
@@ -35742,7 +35765,7 @@
         <p:spPr>
           <a:xfrm xmlns:a="http://schemas.openxmlformats.org/drawingml/2006/main">
             <a:off x="685800" y="6019800"/>
-            <a:ext cx="10668000" cy="285750"/>
+            <a:ext cx="10668000" cy="457200"/>
           </a:xfrm>
           <a:prstGeom xmlns:a="http://schemas.openxmlformats.org/drawingml/2006/main" prst="rect">
             <a:avLst/>
@@ -35757,7 +35780,7 @@
           <a:bodyPr xmlns:a="http://schemas.openxmlformats.org/drawingml/2006/main" lIns="0" tIns="0" rIns="0" bIns="0" anchor="t"/>
           <a:lstStyle xmlns:a="http://schemas.openxmlformats.org/drawingml/2006/main">
             <a:defPPr algn="l">
-              <a:defRPr sz="1200" b="0" i="0">
+              <a:defRPr sz="1050" b="0" i="0">
                 <a:solidFill>
                   <a:srgbClr val="B9C8CA"/>
                 </a:solidFill>
@@ -35767,7 +35790,7 @@
               </a:defRPr>
             </a:defPPr>
             <a:lvl1pPr algn="l">
-              <a:defRPr sz="1200" b="0" i="0">
+              <a:defRPr sz="1050" b="0" i="0">
                 <a:solidFill>
                   <a:srgbClr val="B9C8CA"/>
                 </a:solidFill>
@@ -35777,7 +35800,7 @@
               </a:defRPr>
             </a:lvl1pPr>
             <a:lvl2pPr algn="l">
-              <a:defRPr sz="1200" b="0" i="0">
+              <a:defRPr sz="1050" b="0" i="0">
                 <a:solidFill>
                   <a:srgbClr val="B9C8CA"/>
                 </a:solidFill>
@@ -35787,7 +35810,7 @@
               </a:defRPr>
             </a:lvl2pPr>
             <a:lvl3pPr algn="l">
-              <a:defRPr sz="1200" b="0" i="0">
+              <a:defRPr sz="1050" b="0" i="0">
                 <a:solidFill>
                   <a:srgbClr val="B9C8CA"/>
                 </a:solidFill>
@@ -35797,7 +35820,7 @@
               </a:defRPr>
             </a:lvl3pPr>
             <a:lvl4pPr algn="l">
-              <a:defRPr sz="1200" b="0" i="0">
+              <a:defRPr sz="1050" b="0" i="0">
                 <a:solidFill>
                   <a:srgbClr val="B9C8CA"/>
                 </a:solidFill>
@@ -35807,7 +35830,7 @@
               </a:defRPr>
             </a:lvl4pPr>
             <a:lvl5pPr algn="l">
-              <a:defRPr sz="1200" b="0" i="0">
+              <a:defRPr sz="1050" b="0" i="0">
                 <a:solidFill>
                   <a:srgbClr val="B9C8CA"/>
                 </a:solidFill>
@@ -35817,7 +35840,7 @@
               </a:defRPr>
             </a:lvl5pPr>
             <a:lvl6pPr algn="l">
-              <a:defRPr sz="1200" b="0" i="0">
+              <a:defRPr sz="1050" b="0" i="0">
                 <a:solidFill>
                   <a:srgbClr val="B9C8CA"/>
                 </a:solidFill>
@@ -35827,7 +35850,7 @@
               </a:defRPr>
             </a:lvl6pPr>
             <a:lvl7pPr algn="l">
-              <a:defRPr sz="1200" b="0" i="0">
+              <a:defRPr sz="1050" b="0" i="0">
                 <a:solidFill>
                   <a:srgbClr val="B9C8CA"/>
                 </a:solidFill>
@@ -35837,7 +35860,7 @@
               </a:defRPr>
             </a:lvl7pPr>
             <a:lvl8pPr algn="l">
-              <a:defRPr sz="1200" b="0" i="0">
+              <a:defRPr sz="1050" b="0" i="0">
                 <a:solidFill>
                   <a:srgbClr val="B9C8CA"/>
                 </a:solidFill>
@@ -35847,7 +35870,7 @@
               </a:defRPr>
             </a:lvl8pPr>
             <a:lvl9pPr algn="l">
-              <a:defRPr sz="1200" b="0" i="0">
+              <a:defRPr sz="1050" b="0" i="0">
                 <a:solidFill>
                   <a:srgbClr val="B9C8CA"/>
                 </a:solidFill>
@@ -35859,7 +35882,7 @@
           </a:lstStyle>
           <a:p xmlns:a="http://schemas.openxmlformats.org/drawingml/2006/main">
             <a:pPr algn="l">
-              <a:defRPr sz="1200" b="0" i="0">
+              <a:defRPr sz="1050" b="0" i="0">
                 <a:solidFill>
                   <a:srgbClr val="B9C8CA"/>
                 </a:solidFill>
@@ -35869,7 +35892,7 @@
               </a:defRPr>
             </a:pPr>
             <a:r>
-              <a:rPr sz="1200" b="0" i="0">
+              <a:rPr sz="1050" b="0" i="0">
                 <a:solidFill>
                   <a:srgbClr val="B9C8CA"/>
                 </a:solidFill>
@@ -35877,7 +35900,30 @@
                 <a:ea typeface="Songti SC"/>
                 <a:cs typeface="Songti SC"/>
               </a:rPr>
-              <a:t>真实残余：单一 Flask · 模型银标 · 小样本 · 图扩展增加无依据断言 · Neo4j 未现场重连 · Windows/PowerPoint 实机未验证</a:t>
+              <a:t>残余：单一 Flask · 模型银标 · 小样本 · 图扩展增加无依据断言 · Windows 字体/PowerPoint 原生未验证 · 课堂彩排</a:t>
+            </a:r>
+          </a:p>
+          <a:p xmlns:a="http://schemas.openxmlformats.org/drawingml/2006/main">
+            <a:pPr algn="l">
+              <a:defRPr sz="1050" b="0" i="0">
+                <a:solidFill>
+                  <a:srgbClr val="B9C8CA"/>
+                </a:solidFill>
+                <a:latin typeface="Songti SC"/>
+                <a:ea typeface="Songti SC"/>
+                <a:cs typeface="Songti SC"/>
+              </a:defRPr>
+            </a:pPr>
+            <a:r>
+              <a:rPr sz="1050" b="0" i="0">
+                <a:solidFill>
+                  <a:srgbClr val="B9C8CA"/>
+                </a:solidFill>
+                <a:latin typeface="Songti SC"/>
+                <a:ea typeface="Songti SC"/>
+                <a:cs typeface="Songti SC"/>
+              </a:rPr>
+              <a:t>P2 已在真实 Neo4j 完成扩展分片四跳验收；生产图仍为旧 1.4.1，新增实体来自真实新数据版本重放。</a:t>
             </a:r>
           </a:p>
         </p:txBody>
@@ -35885,7 +35931,7 @@
     </p:spTree>
     <p:extLst>
       <p:ext uri="{BB962C8B-B14F-4D97-AF65-F5344CB8AC3E}">
-        <p14:creationId xmlns:p14="http://schemas.microsoft.com/office/powerpoint/2010/main" val="1568246393"/>
+        <p14:creationId xmlns:p14="http://schemas.microsoft.com/office/powerpoint/2010/main" val="1113933774"/>
       </p:ext>
     </p:extLst>
   </p:cSld>

</xml_diff>

<commit_message>
feat: complete final course evolution evidence
</commit_message>
<xml_diff>
--- a/demo/final/期末汇报_20261030最终版.pptx
+++ b/demo/final/期末汇报_20261030最终版.pptx
@@ -871,7 +871,7 @@
           <a:lstStyle xmlns:a="http://schemas.openxmlformats.org/drawingml/2006/main"/>
           <a:p xmlns:a="http://schemas.openxmlformats.org/drawingml/2006/main">
             <a:r>
-              <a:t>建议约100秒。这条固定链是 PR #6096（lkk7→davidism）→ 05e9c6b → src/flask/testing.py → flask.testing._get_werkzeug_version，来自新数据版本的冻结只读重放，不是靠同号或共现拼接。PR #6096 的顶层 user 字段证明 lkk7 到 PullRequest 的 Authored，merged_by 字段证明 davidism 到同一 PullRequest 的 Merged；两条边都由 P3 生成。PR 到 Commit 05e9c6b 的 MergedAs 仍由 P1 提供，P3 只校验下游。Commit 到 src/flask/testing.py 是同快照的 Touches，File 到 flask.testing._get_werkzeug_version 是 AST 产生的 Defines；函数签名证据是 [3179,3214)，函数位于第 100 到 106 行。这条链刻意不生成 Developer 到 Commit，也没有 commit-author 关系；Developer 只来自 PR API 的 user 和 merged_by。FlaskClient 是 ClassDef，不能冒充 Function。该结果的网络请求和模型请求均为 0，不是旧生产图原地补写。来源：deliveries/P3/2026-10-30/developer_function_validation.json；deliveries/P3/2026-10-30/developer_function_handoff.md；docs/code.md。</a:t>
+              <a:t>建议约100秒。先把它放回项目演化时间线：Issue #6093 在2026-07-13报告IPv6地址解析问题，PR #6096在07-14打开、08-11合并；冻结的Decision明确选择把修复放到main，而不是bug fix发布，理由是不预期还有bug fix版本且问题不严重。现在沿固定链进入代码：PR #6096（lkk7→davidism）→ 05e9c6b → src/flask/testing.py → flask.testing._get_werkzeug_version。lkk7到PR为Authored，davidism到同一PR为Merged，字段都来自PR API顶层；PR到Commit由P1的MergedAs连接；Commit到文件是同SHA的Touches；File到函数由AST产生Defines。函数签名证据是[3179,3214)，函数位于第100至106行。时间相邻不是因果：Issue关闭时间、ClaimsToClose和MergedAs分别保留强度，当前图也没有用ReachableIn把这次提交谎称为已随某Release发布。该函数层来自独立P1+P3合并验收数据，旧生产图仍止于File。整条验收的网络请求和模型请求均为0。来源：evaluation/results/evolution_timeline.json；deliveries/P3/2026-10-30/developer_function_validation.json；evaluation/results/cross_source_chain.json。</a:t>
             </a:r>
           </a:p>
         </p:txBody>
@@ -24283,7 +24283,7 @@
                 <a:ea typeface="Songti SC"/>
                 <a:cs typeface="Songti SC"/>
               </a:rPr>
-              <a:t>跨源案例：PR #6096 到函数实体</a:t>
+              <a:t>跨源演化：从 IPv6 Issue 到函数实体</a:t>
             </a:r>
           </a:p>
         </p:txBody>
@@ -24942,7 +24942,7 @@
                 <a:ea typeface="Songti SC"/>
                 <a:cs typeface="Songti SC"/>
               </a:rPr>
-              <a:t>固定链：PR #6096（lkk7→davidism）→ 05e9c6b → src/flask/testing.py → flask.testing._get_werkzeug_version · 新数据版本只读重放</a:t>
+              <a:t>演化链：Issue #6093（07-13）→ PR #6096（07-14）→ 08-11 合并 → 05e9c6b → testing.py → _get_werkzeug_version</a:t>
             </a:r>
           </a:p>
         </p:txBody>

</xml_diff>

<commit_message>
docs: leave personal course fields blank
</commit_message>
<xml_diff>
--- a/demo/final/期末汇报_20261030最终版.pptx
+++ b/demo/final/期末汇报_20261030最终版.pptx
@@ -521,7 +521,7 @@
           <a:lstStyle xmlns:a="http://schemas.openxmlformats.org/drawingml/2006/main"/>
           <a:p xmlns:a="http://schemas.openxmlformats.org/drawingml/2006/main">
             <a:r>
-              <a:t>建议约40秒。最后一页把已完成结果和不能外推的边界分开。系统已经完成真实 Flask URL 到采集、抽取、建图、检索和带出处问答的闭环；P6 还完成了 pallets/itsdangerous 的第二小库迁移检查，得到可核对的依赖查询答案。冻结包可以复现，在线重跑需要使用者自己的 API 与预算。结论是系统可运行、可追溯、可复现，但图谱收益没有在本次小样本中显著成立，正确弃答率因合格分母为 0 而保持 N/A，不能解释为核验失败。仍未外推的是一般图收益、任意仓库适用性。Neo4j 执行边界已核实：主代理恢复持久服务后，P2 在公开提交 19602e6 使用真实 Neo4j/PostgreSQL 完成扩展数据集加载和 PR #6096 四跳验收，26 项真实服务回归通过，两条方向路径分别为 author-to-function 与 function-to-merger；当前生产图仍是旧 1.4.1，新增实体来自真实新数据版本重放。其他真实残余是 Windows 字体、PowerPoint 原生检查、课堂彩排和成员信息。六角色分工见表，姓名、学号和正式互评全部保留待本人补充，不虚构。P4 前期独立调研、方案、架构、协作框架、试跑和采集器移植保留原归属。来源：P2 公开提交 19602e6 的 cross_source_chain.json、handoff 与 STATUS_P2；reports/technical_report.md第8–9章；feat/p6-formal-results 78eaa07 的 final_acceptance.json 与 P6 handoff；deliveries/P1/2026-10-30/handoff.md；deliveries/P4/2026-10-27/handoff.md；coordination/STATUS_P5.md。</a:t>
+              <a:t>建议约40秒。最后一页把已完成结果和不能外推的边界分开。系统已经完成真实 Flask URL 到采集、抽取、建图、检索和带出处问答的闭环；P6 还完成了 pallets/itsdangerous 的第二小库迁移检查，得到可核对的依赖查询答案。冻结包可以复现，在线重跑需要使用者自己的 API 与预算。结论是系统可运行、可追溯、可复现，但图谱收益没有在本次小样本中显著成立，正确弃答率因合格分母为 0 而保持 N/A，不能解释为核验失败。仍未外推的是一般图收益、任意仓库适用性。Neo4j 执行边界已核实：主代理恢复持久服务后，P2 在公开提交 19602e6 使用真实 Neo4j/PostgreSQL 完成扩展数据集加载和 PR #6096 四跳验收，26 项真实服务回归通过，两条方向路径分别为 author-to-function 与 function-to-merger；当前生产图仍是旧 1.4.1，新增实体来自真实新数据版本重放。其他真实残余是 Windows 字体替换与课堂彩排；macOS PowerPoint 原生复核已通过。六角色分工见表；姓名、学号、职责确认与正式互评按当前要求留空，不虚构。P4 前期独立调研、方案、架构、协作框架、试跑和采集器移植保留原归属。来源：P2 公开提交 19602e6 的 cross_source_chain.json、handoff 与 STATUS_P2；reports/technical_report.md第8–9章；feat/p6-formal-results 78eaa07 的 final_acceptance.json 与 P6 handoff；deliveries/P1/2026-10-30/handoff.md；deliveries/P4/2026-10-27/handoff.md；coordination/STATUS_P5.md。</a:t>
             </a:r>
           </a:p>
         </p:txBody>
@@ -1081,7 +1081,7 @@
           <a:lstStyle xmlns:a="http://schemas.openxmlformats.org/drawingml/2006/main"/>
           <a:p xmlns:a="http://schemas.openxmlformats.org/drawingml/2006/main">
             <a:r>
-              <a:t>建议约100秒。20 道测试题上，A 组事实覆盖 0.600、证据组召回 0.636、无依据断言率 0.026；B 组分别是 0.740、0.691 和 0.043。B-A 配对事实覆盖差是 0.157，但配对胜负为 B 胜 5、A 胜 4、平 6，固定种子 95% 描述性 bootstrap 区间是 [-0.122,0.457]，跨零，因此不能宣称图扩展有显著收益。P6 最终公开结果为全池 92/92；6 道候选题均完成两遍完整核验，确认证据不足为 0。正确弃答率仍为 N/A，但原因是分子和合格分母都为 0，表示没有确认不足题，不再表示核验未完成。48 个 A/B 答案仍完整保留为 32 ok、15 empty、1 error，不能把空回答改写成正确弃答。第二小库 pallets/itsdangerous 得到 347 来源、30 完整讨论、82 实体、78 关系和 180 证据；job 仍为 partial 并保留记录缺口，但 validate、graph、retrieval 均 ready。依赖查询返回 50 条路径、25 条证据和 5 条 claims，所有 cited evidence、原文引文和来源哈希复核通过。共享账本保守累计 9.465795 元，剩余 10.374205 元。第 9 页下方 p6-status-update 是唯一 P6 状态区，数据来自公开提交 78eaa07。Neo4j 执行边界已核实：主代理已恢复持久服务，P2 使用真实 Neo4j/PostgreSQL 完成扩展数据集加载和 PR #6096 四跳验收，26 项真实服务回归通过，包含 author-to-function 与 function-to-merger 两条方向路径。当前生产图仍为旧 1.4.1，新增实体来自真实新数据版本重放，不是生产图原地补写。其他真实残余是单一 Flask、模型银标、小样本、无依据断言增加、Windows 字体与 PowerPoint 原生未验证、课堂彩排待完成。来源：P2 公开提交 19602e6 的 cross_source_chain.json、handoff 与 STATUS_P2；feat/p6-formal-results 78eaa07 的 evaluation/results/formal_summary.json、final_acceptance.json、second_repo_acceptance.json 和 P6 handoff。</a:t>
+              <a:t>建议约100秒。20 道测试题上，A 组事实覆盖 0.600、证据组召回 0.636、无依据断言率 0.026；B 组分别是 0.740、0.691 和 0.043。B-A 配对事实覆盖差是 0.157，但配对胜负为 B 胜 5、A 胜 4、平 6，固定种子 95% 描述性 bootstrap 区间是 [-0.122,0.457]，跨零，因此不能宣称图扩展有显著收益。P6 最终公开结果为全池 92/92；6 道候选题均完成两遍完整核验，确认证据不足为 0。正确弃答率仍为 N/A，但原因是分子和合格分母都为 0，表示没有确认不足题，不再表示核验未完成。48 个 A/B 答案仍完整保留为 32 ok、15 empty、1 error，不能把空回答改写成正确弃答。第二小库 pallets/itsdangerous 得到 347 来源、30 完整讨论、82 实体、78 关系和 180 证据；job 仍为 partial 并保留记录缺口，但 validate、graph、retrieval 均 ready。依赖查询返回 50 条路径、25 条证据和 5 条 claims，所有 cited evidence、原文引文和来源哈希复核通过。共享账本保守累计 9.465795 元，剩余 10.374205 元。第 9 页下方 p6-status-update 是唯一 P6 状态区，数据来自公开提交 78eaa07。Neo4j 执行边界已核实：主代理已恢复持久服务，P2 使用真实 Neo4j/PostgreSQL 完成扩展数据集加载和 PR #6096 四跳验收，26 项真实服务回归通过，包含 author-to-function 与 function-to-merger 两条方向路径。当前生产图仍为旧 1.4.1，新增实体来自真实新数据版本重放，不是生产图原地补写。其他真实残余是单一 Flask、模型银标、小样本、无依据断言增加、Windows 字体替换与课堂彩排待完成；macOS PowerPoint 原生复核已通过。来源：P2 公开提交 19602e6 的 cross_source_chain.json、handoff 与 STATUS_P2；feat/p6-formal-results 78eaa07 的 evaluation/results/formal_summary.json、final_acceptance.json、second_repo_acceptance.json 和 P6 handoff。</a:t>
             </a:r>
           </a:p>
         </p:txBody>
@@ -5489,7 +5489,7 @@
                 <a:ea typeface="Songti SC"/>
                 <a:cs typeface="Songti SC"/>
               </a:rPr>
-              <a:t>六角色协作 · 姓名与学号待本人补充</a:t>
+              <a:t>六角色协作 · P1–P6</a:t>
             </a:r>
           </a:p>
         </p:txBody>
@@ -6434,7 +6434,7 @@
                           <a:ea typeface="Songti SC"/>
                           <a:cs typeface="Songti SC"/>
                         </a:rPr>
-                        <a:t>待本人补充</a:t>
+                        <a:t/>
                       </a:r>
                     </a:p>
                   </a:txBody>
@@ -6550,7 +6550,7 @@
                           <a:ea typeface="Songti SC"/>
                           <a:cs typeface="Songti SC"/>
                         </a:rPr>
-                        <a:t>待本人补充</a:t>
+                        <a:t/>
                       </a:r>
                     </a:p>
                   </a:txBody>
@@ -6666,7 +6666,7 @@
                           <a:ea typeface="Songti SC"/>
                           <a:cs typeface="Songti SC"/>
                         </a:rPr>
-                        <a:t>待本人补充</a:t>
+                        <a:t/>
                       </a:r>
                     </a:p>
                   </a:txBody>
@@ -6782,7 +6782,7 @@
                           <a:ea typeface="Songti SC"/>
                           <a:cs typeface="Songti SC"/>
                         </a:rPr>
-                        <a:t>待本人补充</a:t>
+                        <a:t/>
                       </a:r>
                     </a:p>
                   </a:txBody>
@@ -6898,7 +6898,7 @@
                           <a:ea typeface="Songti SC"/>
                           <a:cs typeface="Songti SC"/>
                         </a:rPr>
-                        <a:t>待本人补充</a:t>
+                        <a:t/>
                       </a:r>
                     </a:p>
                   </a:txBody>
@@ -7014,7 +7014,7 @@
                           <a:ea typeface="Songti SC"/>
                           <a:cs typeface="Songti SC"/>
                         </a:rPr>
-                        <a:t>待本人补充</a:t>
+                        <a:t/>
                       </a:r>
                     </a:p>
                   </a:txBody>
@@ -8660,7 +8660,7 @@
                 <a:ea typeface="Songti SC"/>
                 <a:cs typeface="Songti SC"/>
               </a:rPr>
-              <a:t>下一步：Windows 实机、PowerPoint 原生检查、课堂彩排、成员信息。</a:t>
+              <a:t>下一步：Windows 字体替换、课堂彩排。</a:t>
             </a:r>
           </a:p>
         </p:txBody>
@@ -8817,7 +8817,7 @@
                 <a:ea typeface="Songti SC"/>
                 <a:cs typeface="Songti SC"/>
               </a:rPr>
-              <a:t>UI/归档 21 项通过 · ruff 通过 · 成员姓名、学号与正式互评待本人补充。</a:t>
+              <a:t>UI/归档 21 项通过 · ruff 通过 · macOS PowerPoint 原生复核通过。</a:t>
             </a:r>
           </a:p>
         </p:txBody>
@@ -35900,7 +35900,7 @@
                 <a:ea typeface="Songti SC"/>
                 <a:cs typeface="Songti SC"/>
               </a:rPr>
-              <a:t>残余：单一 Flask · 模型银标 · 小样本 · 图扩展增加无依据断言 · Windows 字体/PowerPoint 原生未验证 · 课堂彩排</a:t>
+              <a:t>残余：单一 Flask · 模型银标 · 小样本 · 图扩展增加无依据断言 · Windows 字体替换未验证 · 课堂彩排</a:t>
             </a:r>
           </a:p>
           <a:p xmlns:a="http://schemas.openxmlformats.org/drawingml/2006/main">

</xml_diff>

<commit_message>
fix: correct query scope and final course evidence
</commit_message>
<xml_diff>
--- a/demo/final/期末汇报_20261030最终版.pptx
+++ b/demo/final/期末汇报_20261030最终版.pptx
@@ -1081,7 +1081,7 @@
           <a:lstStyle xmlns:a="http://schemas.openxmlformats.org/drawingml/2006/main"/>
           <a:p xmlns:a="http://schemas.openxmlformats.org/drawingml/2006/main">
             <a:r>
-              <a:t>建议约100秒。20 道测试题上，A 组事实覆盖 0.600、证据组召回 0.636、无依据断言率 0.026；B 组分别是 0.740、0.691 和 0.043。B-A 配对事实覆盖差是 0.157，但配对胜负为 B 胜 5、A 胜 4、平 6，固定种子 95% 描述性 bootstrap 区间是 [-0.122,0.457]，跨零，因此不能宣称图扩展有显著收益。P6 最终公开结果为全池 92/92；6 道候选题均完成两遍完整核验，确认证据不足为 0。正确弃答率仍为 N/A，但原因是分子和合格分母都为 0，表示没有确认不足题，不再表示核验未完成。48 个 A/B 答案仍完整保留为 32 ok、15 empty、1 error，不能把空回答改写成正确弃答。第二小库 pallets/itsdangerous 得到 347 来源、30 完整讨论、82 实体、78 关系和 180 证据；job 仍为 partial 并保留记录缺口，但 validate、graph、retrieval 均 ready。依赖查询返回 50 条路径、25 条证据和 5 条 claims，所有 cited evidence、原文引文和来源哈希复核通过。共享账本保守累计 9.465795 元，剩余 10.374205 元。第 9 页下方 p6-status-update 是唯一 P6 状态区，数据来自公开提交 78eaa07。Neo4j 执行边界已核实：主代理已恢复持久服务，P2 使用真实 Neo4j/PostgreSQL 完成扩展数据集加载和 PR #6096 四跳验收，26 项真实服务回归通过，包含 author-to-function 与 function-to-merger 两条方向路径。当前生产图仍为旧 1.4.1，新增实体来自真实新数据版本重放，不是生产图原地补写。其他真实残余是单一 Flask、模型银标、小样本、无依据断言增加、Windows 字体替换与课堂彩排待完成；macOS PowerPoint 原生复核已通过。来源：P2 公开提交 19602e6 的 cross_source_chain.json、handoff 与 STATUS_P2；feat/p6-formal-results 78eaa07 的 evaluation/results/formal_summary.json、final_acceptance.json、second_repo_acceptance.json 和 P6 handoff。</a:t>
+              <a:t>建议约100秒。20 道测试题上，A 组总体事实覆盖 0.600、证据组召回 0.636、无依据断言率 0.026；B 组分别是 0.740、0.691 和 0.043。表中总体事实覆盖差为 0.740-0.600=0.140；右侧 0.157 是 15 道可配对计分题的逐题配对平均差，二者口径不同，不能互相替代。配对胜负为 B 胜 5、A 胜 4、平 6，固定种子 95% 描述性 bootstrap 区间是 [-0.122,0.457]，跨零，因此不能宣称图扩展有显著收益。P6 最终公开结果为全池 46 批×2=92 个请求位置全部成功；6 道候选题均完成两遍完整核验，确认证据不足为 0。正确弃答率仍为 N/A，但原因是分子和合格分母都为 0，表示没有确认不足题，不再表示核验未完成。48 个 A/B 答案仍完整保留为 32 ok、15 empty、1 error，不能把空回答改写成正确弃答。第二小库 pallets/itsdangerous 得到 347 来源、30 完整讨论、82 实体、78 关系和 180 证据；job 仍为 partial 并保留记录缺口，但 validate、graph、retrieval 均 ready。依赖查询返回 50 条路径、25 条证据和 5 条 claims，所有 cited evidence、原文引文和来源哈希复核通过。共享账本保守累计 9.465795 元，剩余 10.374205 元。第 9 页下方 p6-status-update 是唯一 P6 状态区，数据来自公开提交 78eaa07。Neo4j 执行边界已核实：主代理已恢复持久服务，P2 使用真实 Neo4j/PostgreSQL 完成扩展数据集加载和 PR #6096 四跳验收，26 项真实服务回归通过，包含 author-to-function 与 function-to-merger 两条方向路径。当前生产图仍为旧 1.4.1，新增实体来自真实新数据版本重放，不是生产图原地补写。其他真实残余是单一 Flask、模型银标、小样本、无依据断言增加、Windows 字体替换与课堂彩排待完成；macOS PowerPoint 原生复核已通过。来源：P2 公开提交 19602e6 的 cross_source_chain.json、handoff 与 STATUS_P2；feat/p6-formal-results 78eaa07 的 evaluation/results/formal_summary.json、final_acceptance.json、second_repo_acceptance.json 和 P6 handoff。</a:t>
             </a:r>
           </a:p>
         </p:txBody>
@@ -32914,7 +32914,7 @@
                 <a:ea typeface="Songti SC"/>
                 <a:cs typeface="Songti SC"/>
               </a:rPr>
-              <a:t>A/B对照：事实覆盖+0.157，但区间跨零</a:t>
+              <a:t>A/B对照：配对平均差+0.157，区间跨零</a:t>
             </a:r>
           </a:p>
         </p:txBody>
@@ -33638,7 +33638,7 @@
                           <a:ea typeface="Songti SC"/>
                           <a:cs typeface="Songti SC"/>
                         </a:rPr>
-                        <a:t>事实覆盖</a:t>
+                        <a:t>总体事实覆盖</a:t>
                       </a:r>
                     </a:p>
                   </a:txBody>
@@ -34387,7 +34387,7 @@
                 <a:ea typeface="Songti SC"/>
                 <a:cs typeface="Songti SC"/>
               </a:rPr>
-              <a:t>B-A 配对事实覆盖差</a:t>
+              <a:t>15题配对平均事实覆盖差</a:t>
             </a:r>
           </a:p>
         </p:txBody>
@@ -35517,7 +35517,7 @@
                 <a:ea typeface="Songti SC"/>
                 <a:cs typeface="Songti SC"/>
               </a:rPr>
-              <a:t>全池 92/92；6 题均两遍完整核验；确认证据不足 0；正确弃答率 N/A（分母 0）。</a:t>
+              <a:t>全池 46批×2=92位置均成功；6题各两遍核验；确认证据不足0；正确弃答率N/A（分母0）。</a:t>
             </a:r>
           </a:p>
           <a:p xmlns:a="http://schemas.openxmlformats.org/drawingml/2006/main">

</xml_diff>